<commit_message>
Acrescenta a fala do apresentador em cada slide
Apresentacao de faculdade precisa mostrar o caminho, nao so o resultado.
As notas citam pelo nome a consulta, o join, o filtro e a regra de
agregacao de cada etapa: o join por codigo IBGE que cruza SIH e CNES, a
deduplicacao por row_number sobre janela particionada por n_aih, a coluna
defasagem_faturamento que revelou a competencia de pagamento, o perfil de
atendimento derivado dos tres primeiros caracteres do CID.

Ficam no painel de anotacoes do proprio .pptx, entao viajam com o arquivo
e aparecem no modo apresentador.

Nao substituem o roteiro do video: 49 slides narrados dao 18 minutos, e o
pitch tem limite de 5. Sao artefatos diferentes para plateias diferentes.

Co-Authored-By: Claude Opus 5 <noreply@anthropic.com>
</commit_message>
<xml_diff>
--- a/EC_Sprint_2_1TSCO_EvidenciasConstrucao_SaudeViz_Lucas_Colen.pptx
+++ b/EC_Sprint_2_1TSCO_EvidenciasConstrucao_SaudeViz_Lucas_Colen.pptx
@@ -6,54 +6,54 @@
   </p:sldMasterIdLst>
   <p:sldIdLst>
     <p:sldId id="256" r:id="rId7"/>
-    <p:sldId id="257" r:id="rId8"/>
-    <p:sldId id="258" r:id="rId9"/>
-    <p:sldId id="259" r:id="rId10"/>
-    <p:sldId id="260" r:id="rId11"/>
-    <p:sldId id="261" r:id="rId12"/>
-    <p:sldId id="262" r:id="rId13"/>
-    <p:sldId id="263" r:id="rId14"/>
-    <p:sldId id="264" r:id="rId15"/>
-    <p:sldId id="265" r:id="rId16"/>
-    <p:sldId id="266" r:id="rId17"/>
-    <p:sldId id="267" r:id="rId18"/>
-    <p:sldId id="268" r:id="rId19"/>
-    <p:sldId id="269" r:id="rId20"/>
-    <p:sldId id="270" r:id="rId21"/>
-    <p:sldId id="271" r:id="rId22"/>
-    <p:sldId id="272" r:id="rId23"/>
-    <p:sldId id="273" r:id="rId24"/>
-    <p:sldId id="274" r:id="rId25"/>
-    <p:sldId id="275" r:id="rId26"/>
-    <p:sldId id="276" r:id="rId27"/>
-    <p:sldId id="277" r:id="rId28"/>
-    <p:sldId id="278" r:id="rId29"/>
-    <p:sldId id="279" r:id="rId30"/>
-    <p:sldId id="280" r:id="rId31"/>
-    <p:sldId id="281" r:id="rId32"/>
-    <p:sldId id="282" r:id="rId33"/>
-    <p:sldId id="283" r:id="rId34"/>
-    <p:sldId id="284" r:id="rId35"/>
-    <p:sldId id="285" r:id="rId36"/>
-    <p:sldId id="286" r:id="rId37"/>
-    <p:sldId id="287" r:id="rId38"/>
-    <p:sldId id="288" r:id="rId39"/>
-    <p:sldId id="289" r:id="rId40"/>
-    <p:sldId id="290" r:id="rId41"/>
-    <p:sldId id="291" r:id="rId42"/>
-    <p:sldId id="292" r:id="rId43"/>
-    <p:sldId id="293" r:id="rId44"/>
-    <p:sldId id="294" r:id="rId45"/>
-    <p:sldId id="295" r:id="rId46"/>
-    <p:sldId id="296" r:id="rId47"/>
-    <p:sldId id="297" r:id="rId48"/>
-    <p:sldId id="298" r:id="rId49"/>
-    <p:sldId id="299" r:id="rId50"/>
-    <p:sldId id="300" r:id="rId51"/>
-    <p:sldId id="301" r:id="rId52"/>
-    <p:sldId id="302" r:id="rId53"/>
-    <p:sldId id="303" r:id="rId54"/>
-    <p:sldId id="304" r:id="rId55"/>
+    <p:sldId id="257" r:id="rId9"/>
+    <p:sldId id="258" r:id="rId10"/>
+    <p:sldId id="259" r:id="rId11"/>
+    <p:sldId id="260" r:id="rId12"/>
+    <p:sldId id="261" r:id="rId13"/>
+    <p:sldId id="262" r:id="rId14"/>
+    <p:sldId id="263" r:id="rId15"/>
+    <p:sldId id="264" r:id="rId16"/>
+    <p:sldId id="265" r:id="rId17"/>
+    <p:sldId id="266" r:id="rId18"/>
+    <p:sldId id="267" r:id="rId19"/>
+    <p:sldId id="268" r:id="rId20"/>
+    <p:sldId id="269" r:id="rId21"/>
+    <p:sldId id="270" r:id="rId22"/>
+    <p:sldId id="271" r:id="rId23"/>
+    <p:sldId id="272" r:id="rId24"/>
+    <p:sldId id="273" r:id="rId25"/>
+    <p:sldId id="274" r:id="rId26"/>
+    <p:sldId id="275" r:id="rId27"/>
+    <p:sldId id="276" r:id="rId28"/>
+    <p:sldId id="277" r:id="rId29"/>
+    <p:sldId id="278" r:id="rId30"/>
+    <p:sldId id="279" r:id="rId31"/>
+    <p:sldId id="280" r:id="rId32"/>
+    <p:sldId id="281" r:id="rId33"/>
+    <p:sldId id="282" r:id="rId34"/>
+    <p:sldId id="283" r:id="rId35"/>
+    <p:sldId id="284" r:id="rId36"/>
+    <p:sldId id="285" r:id="rId37"/>
+    <p:sldId id="286" r:id="rId38"/>
+    <p:sldId id="287" r:id="rId39"/>
+    <p:sldId id="288" r:id="rId40"/>
+    <p:sldId id="289" r:id="rId41"/>
+    <p:sldId id="290" r:id="rId42"/>
+    <p:sldId id="291" r:id="rId43"/>
+    <p:sldId id="292" r:id="rId44"/>
+    <p:sldId id="293" r:id="rId45"/>
+    <p:sldId id="294" r:id="rId46"/>
+    <p:sldId id="295" r:id="rId47"/>
+    <p:sldId id="296" r:id="rId48"/>
+    <p:sldId id="297" r:id="rId49"/>
+    <p:sldId id="298" r:id="rId50"/>
+    <p:sldId id="299" r:id="rId51"/>
+    <p:sldId id="300" r:id="rId52"/>
+    <p:sldId id="301" r:id="rId53"/>
+    <p:sldId id="302" r:id="rId54"/>
+    <p:sldId id="303" r:id="rId55"/>
+    <p:sldId id="304" r:id="rId56"/>
   </p:sldIdLst>
   <p:sldSz cx="9144000" cy="5143500" type="screen4x3"/>
   <p:notesSz cx="6858000" cy="9144000"/>
@@ -153,6 +153,4126 @@
     </a:lvl9pPr>
   </p:defaultTextStyle>
 </p:presentation>
+</file>
+
+<file path=ppt/notesMasters/notesMaster1.xml><?xml version="1.0" encoding="utf-8"?>
+<p:notesMaster xmlns:a="http://schemas.openxmlformats.org/drawingml/2006/main" xmlns:p="http://schemas.openxmlformats.org/presentationml/2006/main" xmlns:r="http://schemas.openxmlformats.org/officeDocument/2006/relationships">
+  <p:cSld>
+    <p:bg>
+      <p:bgRef idx="1001">
+        <a:schemeClr val="bg1"/>
+      </p:bgRef>
+    </p:bg>
+    <p:spTree>
+      <p:nvGrpSpPr>
+        <p:cNvPr id="1" name=""/>
+        <p:cNvGrpSpPr/>
+        <p:nvPr/>
+      </p:nvGrpSpPr>
+      <p:grpSpPr>
+        <a:xfrm>
+          <a:off x="0" y="0"/>
+          <a:ext cx="0" cy="0"/>
+          <a:chOff x="0" y="0"/>
+          <a:chExt cx="0" cy="0"/>
+        </a:xfrm>
+      </p:grpSpPr>
+      <p:sp>
+        <p:nvSpPr>
+          <p:cNvPr id="2" name="Header Placeholder 1"/>
+          <p:cNvSpPr>
+            <a:spLocks noGrp="1"/>
+          </p:cNvSpPr>
+          <p:nvPr>
+            <p:ph type="hdr" sz="quarter"/>
+          </p:nvPr>
+        </p:nvSpPr>
+        <p:spPr>
+          <a:xfrm>
+            <a:off x="0" y="0"/>
+            <a:ext cx="2971800" cy="457200"/>
+          </a:xfrm>
+          <a:prstGeom prst="rect">
+            <a:avLst/>
+          </a:prstGeom>
+        </p:spPr>
+        <p:txBody>
+          <a:bodyPr vert="horz" lIns="91440" tIns="45720" rIns="91440" bIns="45720" rtlCol="0"/>
+          <a:lstStyle>
+            <a:lvl1pPr algn="l">
+              <a:defRPr sz="1200"/>
+            </a:lvl1pPr>
+          </a:lstStyle>
+          <a:p>
+            <a:endParaRPr lang="en-US"/>
+          </a:p>
+        </p:txBody>
+      </p:sp>
+      <p:sp>
+        <p:nvSpPr>
+          <p:cNvPr id="3" name="Date Placeholder 2"/>
+          <p:cNvSpPr>
+            <a:spLocks noGrp="1"/>
+          </p:cNvSpPr>
+          <p:nvPr>
+            <p:ph type="dt" idx="1"/>
+          </p:nvPr>
+        </p:nvSpPr>
+        <p:spPr>
+          <a:xfrm>
+            <a:off x="3884613" y="0"/>
+            <a:ext cx="2971800" cy="457200"/>
+          </a:xfrm>
+          <a:prstGeom prst="rect">
+            <a:avLst/>
+          </a:prstGeom>
+        </p:spPr>
+        <p:txBody>
+          <a:bodyPr vert="horz" lIns="91440" tIns="45720" rIns="91440" bIns="45720" rtlCol="0"/>
+          <a:lstStyle>
+            <a:lvl1pPr algn="r">
+              <a:defRPr sz="1200"/>
+            </a:lvl1pPr>
+          </a:lstStyle>
+          <a:p>
+            <a:fld id="{0F89C1C7-3DCD-1040-A9CF-14679D8B5DDD}" type="datetimeFigureOut">
+              <a:rPr lang="en-US" smtClean="0"/>
+              <a:t>10/17/16</a:t>
+            </a:fld>
+            <a:endParaRPr lang="en-US"/>
+          </a:p>
+        </p:txBody>
+      </p:sp>
+      <p:sp>
+        <p:nvSpPr>
+          <p:cNvPr id="4" name="Slide Image Placeholder 3"/>
+          <p:cNvSpPr>
+            <a:spLocks noGrp="1" noRot="1" noChangeAspect="1"/>
+          </p:cNvSpPr>
+          <p:nvPr>
+            <p:ph type="sldImg" idx="2"/>
+          </p:nvPr>
+        </p:nvSpPr>
+        <p:spPr>
+          <a:xfrm>
+            <a:off x="1143000" y="685800"/>
+            <a:ext cx="4572000" cy="3429000"/>
+          </a:xfrm>
+          <a:prstGeom prst="rect">
+            <a:avLst/>
+          </a:prstGeom>
+          <a:noFill/>
+          <a:ln w="12700">
+            <a:solidFill>
+              <a:prstClr val="black"/>
+            </a:solidFill>
+          </a:ln>
+        </p:spPr>
+        <p:txBody>
+          <a:bodyPr vert="horz" lIns="91440" tIns="45720" rIns="91440" bIns="45720" rtlCol="0" anchor="ctr"/>
+          <a:lstStyle/>
+          <a:p>
+            <a:endParaRPr lang="en-US"/>
+          </a:p>
+        </p:txBody>
+      </p:sp>
+      <p:sp>
+        <p:nvSpPr>
+          <p:cNvPr id="5" name="Notes Placeholder 4"/>
+          <p:cNvSpPr>
+            <a:spLocks noGrp="1"/>
+          </p:cNvSpPr>
+          <p:nvPr>
+            <p:ph type="body" sz="quarter" idx="3"/>
+          </p:nvPr>
+        </p:nvSpPr>
+        <p:spPr>
+          <a:xfrm>
+            <a:off x="685800" y="4343400"/>
+            <a:ext cx="5486400" cy="4114800"/>
+          </a:xfrm>
+          <a:prstGeom prst="rect">
+            <a:avLst/>
+          </a:prstGeom>
+        </p:spPr>
+        <p:txBody>
+          <a:bodyPr vert="horz" lIns="91440" tIns="45720" rIns="91440" bIns="45720" rtlCol="0"/>
+          <a:lstStyle/>
+          <a:p>
+            <a:pPr lvl="0"/>
+            <a:r>
+              <a:rPr lang="en-US" smtClean="0"/>
+              <a:t>Click to edit Master text styles</a:t>
+            </a:r>
+          </a:p>
+          <a:p>
+            <a:pPr lvl="1"/>
+            <a:r>
+              <a:rPr lang="en-US" smtClean="0"/>
+              <a:t>Second level</a:t>
+            </a:r>
+          </a:p>
+          <a:p>
+            <a:pPr lvl="2"/>
+            <a:r>
+              <a:rPr lang="en-US" smtClean="0"/>
+              <a:t>Third level</a:t>
+            </a:r>
+          </a:p>
+          <a:p>
+            <a:pPr lvl="3"/>
+            <a:r>
+              <a:rPr lang="en-US" smtClean="0"/>
+              <a:t>Fourth level</a:t>
+            </a:r>
+          </a:p>
+          <a:p>
+            <a:pPr lvl="4"/>
+            <a:r>
+              <a:rPr lang="en-US" smtClean="0"/>
+              <a:t>Fifth level</a:t>
+            </a:r>
+            <a:endParaRPr lang="en-US"/>
+          </a:p>
+        </p:txBody>
+      </p:sp>
+      <p:sp>
+        <p:nvSpPr>
+          <p:cNvPr id="6" name="Footer Placeholder 5"/>
+          <p:cNvSpPr>
+            <a:spLocks noGrp="1"/>
+          </p:cNvSpPr>
+          <p:nvPr>
+            <p:ph type="ftr" sz="quarter" idx="4"/>
+          </p:nvPr>
+        </p:nvSpPr>
+        <p:spPr>
+          <a:xfrm>
+            <a:off x="0" y="8685213"/>
+            <a:ext cx="2971800" cy="457200"/>
+          </a:xfrm>
+          <a:prstGeom prst="rect">
+            <a:avLst/>
+          </a:prstGeom>
+        </p:spPr>
+        <p:txBody>
+          <a:bodyPr vert="horz" lIns="91440" tIns="45720" rIns="91440" bIns="45720" rtlCol="0" anchor="b"/>
+          <a:lstStyle>
+            <a:lvl1pPr algn="l">
+              <a:defRPr sz="1200"/>
+            </a:lvl1pPr>
+          </a:lstStyle>
+          <a:p>
+            <a:endParaRPr lang="en-US"/>
+          </a:p>
+        </p:txBody>
+      </p:sp>
+      <p:sp>
+        <p:nvSpPr>
+          <p:cNvPr id="7" name="Slide Number Placeholder 6"/>
+          <p:cNvSpPr>
+            <a:spLocks noGrp="1"/>
+          </p:cNvSpPr>
+          <p:nvPr>
+            <p:ph type="sldNum" sz="quarter" idx="5"/>
+          </p:nvPr>
+        </p:nvSpPr>
+        <p:spPr>
+          <a:xfrm>
+            <a:off x="3884613" y="8685213"/>
+            <a:ext cx="2971800" cy="457200"/>
+          </a:xfrm>
+          <a:prstGeom prst="rect">
+            <a:avLst/>
+          </a:prstGeom>
+        </p:spPr>
+        <p:txBody>
+          <a:bodyPr vert="horz" lIns="91440" tIns="45720" rIns="91440" bIns="45720" rtlCol="0" anchor="b"/>
+          <a:lstStyle>
+            <a:lvl1pPr algn="r">
+              <a:defRPr sz="1200"/>
+            </a:lvl1pPr>
+          </a:lstStyle>
+          <a:p>
+            <a:fld id="{BB5E49A5-4136-284D-997B-48E1D791AD67}" type="slidenum">
+              <a:rPr lang="en-US" smtClean="0"/>
+              <a:t>‹#›</a:t>
+            </a:fld>
+            <a:endParaRPr lang="en-US"/>
+          </a:p>
+        </p:txBody>
+      </p:sp>
+    </p:spTree>
+    <p:extLst>
+      <p:ext uri="{BB962C8B-B14F-4D97-AF65-F5344CB8AC3E}">
+        <p14:creationId xmlns:p14="http://schemas.microsoft.com/office/powerpoint/2010/main" val="2623252185"/>
+      </p:ext>
+    </p:extLst>
+  </p:cSld>
+  <p:clrMap bg1="lt1" tx1="dk1" bg2="lt2" tx2="dk2" accent1="accent1" accent2="accent2" accent3="accent3" accent4="accent4" accent5="accent5" accent6="accent6" hlink="hlink" folHlink="folHlink"/>
+  <p:notesStyle>
+    <a:lvl1pPr marL="0" algn="l" defTabSz="457200" rtl="0" eaLnBrk="1" latinLnBrk="0" hangingPunct="1">
+      <a:defRPr sz="1200" kern="1200">
+        <a:solidFill>
+          <a:schemeClr val="tx1"/>
+        </a:solidFill>
+        <a:latin typeface="+mn-lt"/>
+        <a:ea typeface="+mn-ea"/>
+        <a:cs typeface="+mn-cs"/>
+      </a:defRPr>
+    </a:lvl1pPr>
+    <a:lvl2pPr marL="457200" algn="l" defTabSz="457200" rtl="0" eaLnBrk="1" latinLnBrk="0" hangingPunct="1">
+      <a:defRPr sz="1200" kern="1200">
+        <a:solidFill>
+          <a:schemeClr val="tx1"/>
+        </a:solidFill>
+        <a:latin typeface="+mn-lt"/>
+        <a:ea typeface="+mn-ea"/>
+        <a:cs typeface="+mn-cs"/>
+      </a:defRPr>
+    </a:lvl2pPr>
+    <a:lvl3pPr marL="914400" algn="l" defTabSz="457200" rtl="0" eaLnBrk="1" latinLnBrk="0" hangingPunct="1">
+      <a:defRPr sz="1200" kern="1200">
+        <a:solidFill>
+          <a:schemeClr val="tx1"/>
+        </a:solidFill>
+        <a:latin typeface="+mn-lt"/>
+        <a:ea typeface="+mn-ea"/>
+        <a:cs typeface="+mn-cs"/>
+      </a:defRPr>
+    </a:lvl3pPr>
+    <a:lvl4pPr marL="1371600" algn="l" defTabSz="457200" rtl="0" eaLnBrk="1" latinLnBrk="0" hangingPunct="1">
+      <a:defRPr sz="1200" kern="1200">
+        <a:solidFill>
+          <a:schemeClr val="tx1"/>
+        </a:solidFill>
+        <a:latin typeface="+mn-lt"/>
+        <a:ea typeface="+mn-ea"/>
+        <a:cs typeface="+mn-cs"/>
+      </a:defRPr>
+    </a:lvl4pPr>
+    <a:lvl5pPr marL="1828800" algn="l" defTabSz="457200" rtl="0" eaLnBrk="1" latinLnBrk="0" hangingPunct="1">
+      <a:defRPr sz="1200" kern="1200">
+        <a:solidFill>
+          <a:schemeClr val="tx1"/>
+        </a:solidFill>
+        <a:latin typeface="+mn-lt"/>
+        <a:ea typeface="+mn-ea"/>
+        <a:cs typeface="+mn-cs"/>
+      </a:defRPr>
+    </a:lvl5pPr>
+    <a:lvl6pPr marL="2286000" algn="l" defTabSz="457200" rtl="0" eaLnBrk="1" latinLnBrk="0" hangingPunct="1">
+      <a:defRPr sz="1200" kern="1200">
+        <a:solidFill>
+          <a:schemeClr val="tx1"/>
+        </a:solidFill>
+        <a:latin typeface="+mn-lt"/>
+        <a:ea typeface="+mn-ea"/>
+        <a:cs typeface="+mn-cs"/>
+      </a:defRPr>
+    </a:lvl6pPr>
+    <a:lvl7pPr marL="2743200" algn="l" defTabSz="457200" rtl="0" eaLnBrk="1" latinLnBrk="0" hangingPunct="1">
+      <a:defRPr sz="1200" kern="1200">
+        <a:solidFill>
+          <a:schemeClr val="tx1"/>
+        </a:solidFill>
+        <a:latin typeface="+mn-lt"/>
+        <a:ea typeface="+mn-ea"/>
+        <a:cs typeface="+mn-cs"/>
+      </a:defRPr>
+    </a:lvl7pPr>
+    <a:lvl8pPr marL="3200400" algn="l" defTabSz="457200" rtl="0" eaLnBrk="1" latinLnBrk="0" hangingPunct="1">
+      <a:defRPr sz="1200" kern="1200">
+        <a:solidFill>
+          <a:schemeClr val="tx1"/>
+        </a:solidFill>
+        <a:latin typeface="+mn-lt"/>
+        <a:ea typeface="+mn-ea"/>
+        <a:cs typeface="+mn-cs"/>
+      </a:defRPr>
+    </a:lvl8pPr>
+    <a:lvl9pPr marL="3657600" algn="l" defTabSz="457200" rtl="0" eaLnBrk="1" latinLnBrk="0" hangingPunct="1">
+      <a:defRPr sz="1200" kern="1200">
+        <a:solidFill>
+          <a:schemeClr val="tx1"/>
+        </a:solidFill>
+        <a:latin typeface="+mn-lt"/>
+        <a:ea typeface="+mn-ea"/>
+        <a:cs typeface="+mn-cs"/>
+      </a:defRPr>
+    </a:lvl9pPr>
+  </p:notesStyle>
+</p:notesMaster>
+</file>
+
+<file path=ppt/notesSlides/notesSlide1.xml><?xml version="1.0" encoding="utf-8"?>
+<p:notes xmlns:a="http://schemas.openxmlformats.org/drawingml/2006/main" xmlns:p="http://schemas.openxmlformats.org/presentationml/2006/main" xmlns:r="http://schemas.openxmlformats.org/officeDocument/2006/relationships">
+  <p:cSld>
+    <p:spTree>
+      <p:nvGrpSpPr>
+        <p:cNvPr id="1" name=""/>
+        <p:cNvGrpSpPr/>
+        <p:nvPr/>
+      </p:nvGrpSpPr>
+      <p:grpSpPr>
+        <a:xfrm>
+          <a:off x="0" y="0"/>
+          <a:ext cx="0" cy="0"/>
+          <a:chOff x="0" y="0"/>
+          <a:chExt cx="0" cy="0"/>
+        </a:xfrm>
+      </p:grpSpPr>
+      <p:sp>
+        <p:nvSpPr>
+          <p:cNvPr id="2" name="Slide Image Placeholder 1"/>
+          <p:cNvSpPr>
+            <a:spLocks noGrp="1"/>
+          </p:cNvSpPr>
+          <p:nvPr>
+            <p:ph type="sldImg" idx="2"/>
+          </p:nvPr>
+        </p:nvSpPr>
+        <p:spPr/>
+      </p:sp>
+      <p:sp>
+        <p:nvSpPr>
+          <p:cNvPr id="3" name="Notes Placeholder 2"/>
+          <p:cNvSpPr>
+            <a:spLocks noGrp="1"/>
+          </p:cNvSpPr>
+          <p:nvPr>
+            <p:ph type="body" idx="3" sz="quarter"/>
+          </p:nvPr>
+        </p:nvSpPr>
+        <p:spPr/>
+        <p:txBody>
+          <a:bodyPr/>
+          <a:lstStyle/>
+          <a:p>
+            <a:r>
+              <a:t>Bom dia. SaudeViz: um painel que transforma microdados publicos de saude em resposta que um gestor consegue usar.</a:t>
+            </a:r>
+          </a:p>
+          <a:p>
+            <a:r>
+              <a:t>Vou mostrar de onde os dados vieram, o que precisou ser feito com eles, e como viraram informacao. O produto final esta no ar e eu demonstro ao vivo no fim.</a:t>
+            </a:r>
+          </a:p>
+        </p:txBody>
+      </p:sp>
+      <p:sp>
+        <p:nvSpPr>
+          <p:cNvPr id="4" name="Slide Number Placeholder 3"/>
+          <p:cNvSpPr>
+            <a:spLocks noGrp="1"/>
+          </p:cNvSpPr>
+          <p:nvPr>
+            <p:ph type="sldNum" idx="5" sz="quarter"/>
+          </p:nvPr>
+        </p:nvSpPr>
+        <p:spPr/>
+      </p:sp>
+    </p:spTree>
+  </p:cSld>
+  <p:clrMapOvr>
+    <a:masterClrMapping/>
+  </p:clrMapOvr>
+</p:notes>
+</file>
+
+<file path=ppt/notesSlides/notesSlide10.xml><?xml version="1.0" encoding="utf-8"?>
+<p:notes xmlns:a="http://schemas.openxmlformats.org/drawingml/2006/main" xmlns:p="http://schemas.openxmlformats.org/presentationml/2006/main" xmlns:r="http://schemas.openxmlformats.org/officeDocument/2006/relationships">
+  <p:cSld>
+    <p:spTree>
+      <p:nvGrpSpPr>
+        <p:cNvPr id="1" name=""/>
+        <p:cNvGrpSpPr/>
+        <p:nvPr/>
+      </p:nvGrpSpPr>
+      <p:grpSpPr>
+        <a:xfrm>
+          <a:off x="0" y="0"/>
+          <a:ext cx="0" cy="0"/>
+          <a:chOff x="0" y="0"/>
+          <a:chExt cx="0" cy="0"/>
+        </a:xfrm>
+      </p:grpSpPr>
+      <p:sp>
+        <p:nvSpPr>
+          <p:cNvPr id="2" name="Slide Image Placeholder 1"/>
+          <p:cNvSpPr>
+            <a:spLocks noGrp="1"/>
+          </p:cNvSpPr>
+          <p:nvPr>
+            <p:ph type="sldImg" idx="2"/>
+          </p:nvPr>
+        </p:nvSpPr>
+        <p:spPr/>
+      </p:sp>
+      <p:sp>
+        <p:nvSpPr>
+          <p:cNvPr id="3" name="Notes Placeholder 2"/>
+          <p:cNvSpPr>
+            <a:spLocks noGrp="1"/>
+          </p:cNvSpPr>
+          <p:nvPr>
+            <p:ph type="body" idx="3" sz="quarter"/>
+          </p:nvPr>
+        </p:nvSpPr>
+        <p:spPr/>
+        <p:txBody>
+          <a:bodyPr/>
+          <a:lstStyle/>
+          <a:p>
+            <a:r>
+              <a:t>A pergunta e "onde a capacidade foi ultrapassada".</a:t>
+            </a:r>
+          </a:p>
+          <a:p>
+            <a:r>
+              <a:t>Para responder eu precisei cruzar duas fontes que nao se conhecem: as internacoes do SIH e os leitos do CNES. O join e por codigo IBGE de seis digitos do municipio. Somo os leitos SUS de todos os estabelecimentos de cada municipio, somo os dias de permanencia consumidos naquele mes, divido um pelo outro e pelo numero de dias do mes. Isso da a taxa de ocupacao.</a:t>
+            </a:r>
+          </a:p>
+          <a:p>
+            <a:r>
+              <a:t>Repare nos dois numeros lado a lado: media simples e ponderada. A simples trata um municipio de tres leitos igual a Sao Paulo. A distancia entre as barras e o tamanho do erro que eu teria cometido se usasse a media ingenua.</a:t>
+            </a:r>
+          </a:p>
+        </p:txBody>
+      </p:sp>
+      <p:sp>
+        <p:nvSpPr>
+          <p:cNvPr id="4" name="Slide Number Placeholder 3"/>
+          <p:cNvSpPr>
+            <a:spLocks noGrp="1"/>
+          </p:cNvSpPr>
+          <p:nvPr>
+            <p:ph type="sldNum" idx="5" sz="quarter"/>
+          </p:nvPr>
+        </p:nvSpPr>
+        <p:spPr/>
+      </p:sp>
+    </p:spTree>
+  </p:cSld>
+  <p:clrMapOvr>
+    <a:masterClrMapping/>
+  </p:clrMapOvr>
+</p:notes>
+</file>
+
+<file path=ppt/notesSlides/notesSlide11.xml><?xml version="1.0" encoding="utf-8"?>
+<p:notes xmlns:a="http://schemas.openxmlformats.org/drawingml/2006/main" xmlns:p="http://schemas.openxmlformats.org/presentationml/2006/main" xmlns:r="http://schemas.openxmlformats.org/officeDocument/2006/relationships">
+  <p:cSld>
+    <p:spTree>
+      <p:nvGrpSpPr>
+        <p:cNvPr id="1" name=""/>
+        <p:cNvGrpSpPr/>
+        <p:nvPr/>
+      </p:nvGrpSpPr>
+      <p:grpSpPr>
+        <a:xfrm>
+          <a:off x="0" y="0"/>
+          <a:ext cx="0" cy="0"/>
+          <a:chOff x="0" y="0"/>
+          <a:chExt cx="0" cy="0"/>
+        </a:xfrm>
+      </p:grpSpPr>
+      <p:sp>
+        <p:nvSpPr>
+          <p:cNvPr id="2" name="Slide Image Placeholder 1"/>
+          <p:cNvSpPr>
+            <a:spLocks noGrp="1"/>
+          </p:cNvSpPr>
+          <p:nvPr>
+            <p:ph type="sldImg" idx="2"/>
+          </p:nvPr>
+        </p:nvSpPr>
+        <p:spPr/>
+      </p:sp>
+      <p:sp>
+        <p:nvSpPr>
+          <p:cNvPr id="3" name="Notes Placeholder 2"/>
+          <p:cNvSpPr>
+            <a:spLocks noGrp="1"/>
+          </p:cNvSpPr>
+          <p:nvPr>
+            <p:ph type="body" idx="3" sz="quarter"/>
+          </p:nvPr>
+        </p:nvSpPr>
+        <p:spPr/>
+        <p:txBody>
+          <a:bodyPr/>
+          <a:lstStyle/>
+          <a:p>
+            <a:r>
+              <a:t>A lista de municipios criticos sai de um filtro sobre a tabela de indicador: situacao igual a 'Critica', ordenado por taxa de ocupacao decrescente.</a:t>
+            </a:r>
+          </a:p>
+          <a:p>
+            <a:r>
+              <a:t>E eu declaro na tela que ocupacao acima de um e alerta para investigar, nao prova de colapso. Pode ser leito desatualizado no CNES, ou municipio-polo atendendo a regiao inteira. A ferramenta reduz mil seiscentos e sessenta e oito municipios a uma lista de dezenas. A decisao continua humana.</a:t>
+            </a:r>
+          </a:p>
+        </p:txBody>
+      </p:sp>
+      <p:sp>
+        <p:nvSpPr>
+          <p:cNvPr id="4" name="Slide Number Placeholder 3"/>
+          <p:cNvSpPr>
+            <a:spLocks noGrp="1"/>
+          </p:cNvSpPr>
+          <p:nvPr>
+            <p:ph type="sldNum" idx="5" sz="quarter"/>
+          </p:nvPr>
+        </p:nvSpPr>
+        <p:spPr/>
+      </p:sp>
+    </p:spTree>
+  </p:cSld>
+  <p:clrMapOvr>
+    <a:masterClrMapping/>
+  </p:clrMapOvr>
+</p:notes>
+</file>
+
+<file path=ppt/notesSlides/notesSlide12.xml><?xml version="1.0" encoding="utf-8"?>
+<p:notes xmlns:a="http://schemas.openxmlformats.org/drawingml/2006/main" xmlns:p="http://schemas.openxmlformats.org/presentationml/2006/main" xmlns:r="http://schemas.openxmlformats.org/officeDocument/2006/relationships">
+  <p:cSld>
+    <p:spTree>
+      <p:nvGrpSpPr>
+        <p:cNvPr id="1" name=""/>
+        <p:cNvGrpSpPr/>
+        <p:nvPr/>
+      </p:nvGrpSpPr>
+      <p:grpSpPr>
+        <a:xfrm>
+          <a:off x="0" y="0"/>
+          <a:ext cx="0" cy="0"/>
+          <a:chOff x="0" y="0"/>
+          <a:chExt cx="0" cy="0"/>
+        </a:xfrm>
+      </p:grpSpPr>
+      <p:sp>
+        <p:nvSpPr>
+          <p:cNvPr id="2" name="Slide Image Placeholder 1"/>
+          <p:cNvSpPr>
+            <a:spLocks noGrp="1"/>
+          </p:cNvSpPr>
+          <p:nvPr>
+            <p:ph type="sldImg" idx="2"/>
+          </p:nvPr>
+        </p:nvSpPr>
+        <p:spPr/>
+      </p:sp>
+      <p:sp>
+        <p:nvSpPr>
+          <p:cNvPr id="3" name="Notes Placeholder 2"/>
+          <p:cNvSpPr>
+            <a:spLocks noGrp="1"/>
+          </p:cNvSpPr>
+          <p:nvPr>
+            <p:ph type="body" idx="3" sz="quarter"/>
+          </p:nvPr>
+        </p:nvSpPr>
+        <p:spPr/>
+        <p:txBody>
+          <a:bodyPr/>
+          <a:lstStyle/>
+          <a:p>
+            <a:r>
+              <a:t>Esta tela responde "quais perfis pressionam mais".</a:t>
+            </a:r>
+          </a:p>
+          <a:p>
+            <a:r>
+              <a:t>O perfil de atendimento nao existe no dado bruto: eu derivei do CID principal, pegando os tres primeiros caracteres e classificando por faixa. J00 a J99 vira respiratorio, S00 a T98 vira causa externa, F00 a F99 vira saude mental.</a:t>
+            </a:r>
+          </a:p>
+          <a:p>
+            <a:r>
+              <a:t>E o ranking nao e por volume. Eu ordeno por pressao relativa: a participacao no total de leitos-dia dividida pela participacao no total de internacoes. Saude mental fica no topo com 2,15 — ocupa o dobro de leito por internacao que a media. Num painel ordenado por volume ela nem apareceria.</a:t>
+            </a:r>
+          </a:p>
+        </p:txBody>
+      </p:sp>
+      <p:sp>
+        <p:nvSpPr>
+          <p:cNvPr id="4" name="Slide Number Placeholder 3"/>
+          <p:cNvSpPr>
+            <a:spLocks noGrp="1"/>
+          </p:cNvSpPr>
+          <p:nvPr>
+            <p:ph type="sldNum" idx="5" sz="quarter"/>
+          </p:nvPr>
+        </p:nvSpPr>
+        <p:spPr/>
+      </p:sp>
+    </p:spTree>
+  </p:cSld>
+  <p:clrMapOvr>
+    <a:masterClrMapping/>
+  </p:clrMapOvr>
+</p:notes>
+</file>
+
+<file path=ppt/notesSlides/notesSlide13.xml><?xml version="1.0" encoding="utf-8"?>
+<p:notes xmlns:a="http://schemas.openxmlformats.org/drawingml/2006/main" xmlns:p="http://schemas.openxmlformats.org/presentationml/2006/main" xmlns:r="http://schemas.openxmlformats.org/officeDocument/2006/relationships">
+  <p:cSld>
+    <p:spTree>
+      <p:nvGrpSpPr>
+        <p:cNvPr id="1" name=""/>
+        <p:cNvGrpSpPr/>
+        <p:nvPr/>
+      </p:nvGrpSpPr>
+      <p:grpSpPr>
+        <a:xfrm>
+          <a:off x="0" y="0"/>
+          <a:ext cx="0" cy="0"/>
+          <a:chOff x="0" y="0"/>
+          <a:chExt cx="0" cy="0"/>
+        </a:xfrm>
+      </p:grpSpPr>
+      <p:sp>
+        <p:nvSpPr>
+          <p:cNvPr id="2" name="Slide Image Placeholder 1"/>
+          <p:cNvSpPr>
+            <a:spLocks noGrp="1"/>
+          </p:cNvSpPr>
+          <p:nvPr>
+            <p:ph type="sldImg" idx="2"/>
+          </p:nvPr>
+        </p:nvSpPr>
+        <p:spPr/>
+      </p:sp>
+      <p:sp>
+        <p:nvSpPr>
+          <p:cNvPr id="3" name="Notes Placeholder 2"/>
+          <p:cNvSpPr>
+            <a:spLocks noGrp="1"/>
+          </p:cNvSpPr>
+          <p:nvPr>
+            <p:ph type="body" idx="3" sz="quarter"/>
+          </p:nvPr>
+        </p:nvSpPr>
+        <p:spPr/>
+        <p:txBody>
+          <a:bodyPr/>
+          <a:lstStyle/>
+          <a:p>
+            <a:r>
+              <a:t>Terceira entrega: a arquitetura que de fato foi implementada.</a:t>
+            </a:r>
+          </a:p>
+        </p:txBody>
+      </p:sp>
+      <p:sp>
+        <p:nvSpPr>
+          <p:cNvPr id="4" name="Slide Number Placeholder 3"/>
+          <p:cNvSpPr>
+            <a:spLocks noGrp="1"/>
+          </p:cNvSpPr>
+          <p:nvPr>
+            <p:ph type="sldNum" idx="5" sz="quarter"/>
+          </p:nvPr>
+        </p:nvSpPr>
+        <p:spPr/>
+      </p:sp>
+    </p:spTree>
+  </p:cSld>
+  <p:clrMapOvr>
+    <a:masterClrMapping/>
+  </p:clrMapOvr>
+</p:notes>
+</file>
+
+<file path=ppt/notesSlides/notesSlide14.xml><?xml version="1.0" encoding="utf-8"?>
+<p:notes xmlns:a="http://schemas.openxmlformats.org/drawingml/2006/main" xmlns:p="http://schemas.openxmlformats.org/presentationml/2006/main" xmlns:r="http://schemas.openxmlformats.org/officeDocument/2006/relationships">
+  <p:cSld>
+    <p:spTree>
+      <p:nvGrpSpPr>
+        <p:cNvPr id="1" name=""/>
+        <p:cNvGrpSpPr/>
+        <p:nvPr/>
+      </p:nvGrpSpPr>
+      <p:grpSpPr>
+        <a:xfrm>
+          <a:off x="0" y="0"/>
+          <a:ext cx="0" cy="0"/>
+          <a:chOff x="0" y="0"/>
+          <a:chExt cx="0" cy="0"/>
+        </a:xfrm>
+      </p:grpSpPr>
+      <p:sp>
+        <p:nvSpPr>
+          <p:cNvPr id="2" name="Slide Image Placeholder 1"/>
+          <p:cNvSpPr>
+            <a:spLocks noGrp="1"/>
+          </p:cNvSpPr>
+          <p:nvPr>
+            <p:ph type="sldImg" idx="2"/>
+          </p:nvPr>
+        </p:nvSpPr>
+        <p:spPr/>
+      </p:sp>
+      <p:sp>
+        <p:nvSpPr>
+          <p:cNvPr id="3" name="Notes Placeholder 2"/>
+          <p:cNvSpPr>
+            <a:spLocks noGrp="1"/>
+          </p:cNvSpPr>
+          <p:nvPr>
+            <p:ph type="body" idx="3" sz="quarter"/>
+          </p:nvPr>
+        </p:nvSpPr>
+        <p:spPr/>
+        <p:txBody>
+          <a:bodyPr/>
+          <a:lstStyle/>
+          <a:p>
+            <a:r>
+              <a:t>O caminho completo do dado.</a:t>
+            </a:r>
+          </a:p>
+          <a:p>
+            <a:r>
+              <a:t>Quatro fontes publicas. A ingestao baixa e converte, o Databricks processa em tres camadas, o Oracle guarda a camada de consumo, o Streamlit consulta.</a:t>
+            </a:r>
+          </a:p>
+          <a:p>
+            <a:r>
+              <a:t>A conversao do .dbc roda fora do Databricks de proposito: e formato proprietario do DATASUS que exige extensao compilada em C e acesso FTP, os dois pouco praticos em compute serverless.</a:t>
+            </a:r>
+          </a:p>
+        </p:txBody>
+      </p:sp>
+      <p:sp>
+        <p:nvSpPr>
+          <p:cNvPr id="4" name="Slide Number Placeholder 3"/>
+          <p:cNvSpPr>
+            <a:spLocks noGrp="1"/>
+          </p:cNvSpPr>
+          <p:nvPr>
+            <p:ph type="sldNum" idx="5" sz="quarter"/>
+          </p:nvPr>
+        </p:nvSpPr>
+        <p:spPr/>
+      </p:sp>
+    </p:spTree>
+  </p:cSld>
+  <p:clrMapOvr>
+    <a:masterClrMapping/>
+  </p:clrMapOvr>
+</p:notes>
+</file>
+
+<file path=ppt/notesSlides/notesSlide15.xml><?xml version="1.0" encoding="utf-8"?>
+<p:notes xmlns:a="http://schemas.openxmlformats.org/drawingml/2006/main" xmlns:p="http://schemas.openxmlformats.org/presentationml/2006/main" xmlns:r="http://schemas.openxmlformats.org/officeDocument/2006/relationships">
+  <p:cSld>
+    <p:spTree>
+      <p:nvGrpSpPr>
+        <p:cNvPr id="1" name=""/>
+        <p:cNvGrpSpPr/>
+        <p:nvPr/>
+      </p:nvGrpSpPr>
+      <p:grpSpPr>
+        <a:xfrm>
+          <a:off x="0" y="0"/>
+          <a:ext cx="0" cy="0"/>
+          <a:chOff x="0" y="0"/>
+          <a:chExt cx="0" cy="0"/>
+        </a:xfrm>
+      </p:grpSpPr>
+      <p:sp>
+        <p:nvSpPr>
+          <p:cNvPr id="2" name="Slide Image Placeholder 1"/>
+          <p:cNvSpPr>
+            <a:spLocks noGrp="1"/>
+          </p:cNvSpPr>
+          <p:nvPr>
+            <p:ph type="sldImg" idx="2"/>
+          </p:nvPr>
+        </p:nvSpPr>
+        <p:spPr/>
+      </p:sp>
+      <p:sp>
+        <p:nvSpPr>
+          <p:cNvPr id="3" name="Notes Placeholder 2"/>
+          <p:cNvSpPr>
+            <a:spLocks noGrp="1"/>
+          </p:cNvSpPr>
+          <p:nvPr>
+            <p:ph type="body" idx="3" sz="quarter"/>
+          </p:nvPr>
+        </p:nvSpPr>
+        <p:spPr/>
+        <p:txBody>
+          <a:bodyPr/>
+          <a:lstStyle/>
+          <a:p>
+            <a:r>
+              <a:t>Cada etapa esta onde esta por um motivo, e vale explicar a escolha.</a:t>
+            </a:r>
+          </a:p>
+          <a:p>
+            <a:r>
+              <a:t>O download local e por causa da biblioteca compilada. O processamento no Databricks e porque sao sete milhoes de linhas — em pandas na minha maquina isso daria quatorze giga de memoria e eu tenho cinco livres. Medi antes de migrar.</a:t>
+            </a:r>
+          </a:p>
+          <a:p>
+            <a:r>
+              <a:t>O Oracle e a camada de servico: e dele que o painel consulta, e e nele que estao os COMMENT ON que alimentam o tradutor de linguagem natural.</a:t>
+            </a:r>
+          </a:p>
+        </p:txBody>
+      </p:sp>
+      <p:sp>
+        <p:nvSpPr>
+          <p:cNvPr id="4" name="Slide Number Placeholder 3"/>
+          <p:cNvSpPr>
+            <a:spLocks noGrp="1"/>
+          </p:cNvSpPr>
+          <p:nvPr>
+            <p:ph type="sldNum" idx="5" sz="quarter"/>
+          </p:nvPr>
+        </p:nvSpPr>
+        <p:spPr/>
+      </p:sp>
+    </p:spTree>
+  </p:cSld>
+  <p:clrMapOvr>
+    <a:masterClrMapping/>
+  </p:clrMapOvr>
+</p:notes>
+</file>
+
+<file path=ppt/notesSlides/notesSlide16.xml><?xml version="1.0" encoding="utf-8"?>
+<p:notes xmlns:a="http://schemas.openxmlformats.org/drawingml/2006/main" xmlns:p="http://schemas.openxmlformats.org/presentationml/2006/main" xmlns:r="http://schemas.openxmlformats.org/officeDocument/2006/relationships">
+  <p:cSld>
+    <p:spTree>
+      <p:nvGrpSpPr>
+        <p:cNvPr id="1" name=""/>
+        <p:cNvGrpSpPr/>
+        <p:nvPr/>
+      </p:nvGrpSpPr>
+      <p:grpSpPr>
+        <a:xfrm>
+          <a:off x="0" y="0"/>
+          <a:ext cx="0" cy="0"/>
+          <a:chOff x="0" y="0"/>
+          <a:chExt cx="0" cy="0"/>
+        </a:xfrm>
+      </p:grpSpPr>
+      <p:sp>
+        <p:nvSpPr>
+          <p:cNvPr id="2" name="Slide Image Placeholder 1"/>
+          <p:cNvSpPr>
+            <a:spLocks noGrp="1"/>
+          </p:cNvSpPr>
+          <p:nvPr>
+            <p:ph type="sldImg" idx="2"/>
+          </p:nvPr>
+        </p:nvSpPr>
+        <p:spPr/>
+      </p:sp>
+      <p:sp>
+        <p:nvSpPr>
+          <p:cNvPr id="3" name="Notes Placeholder 2"/>
+          <p:cNvSpPr>
+            <a:spLocks noGrp="1"/>
+          </p:cNvSpPr>
+          <p:nvPr>
+            <p:ph type="body" idx="3" sz="quarter"/>
+          </p:nvPr>
+        </p:nvSpPr>
+        <p:spPr/>
+        <p:txBody>
+          <a:bodyPr/>
+          <a:lstStyle/>
+          <a:p>
+            <a:r>
+              <a:t>Isto nao e diagrama, e o catalogo real do Databricks.</a:t>
+            </a:r>
+          </a:p>
+          <a:p>
+            <a:r>
+              <a:t>As tres camadas existem como schemas separados. Bronze guarda o dado cru sem transformar nada — se eu errar na Prata, reprocesso sem baixar sessenta arquivos do DATASUS de novo. Essa e a razao de existir da camada Bronze.</a:t>
+            </a:r>
+          </a:p>
+        </p:txBody>
+      </p:sp>
+      <p:sp>
+        <p:nvSpPr>
+          <p:cNvPr id="4" name="Slide Number Placeholder 3"/>
+          <p:cNvSpPr>
+            <a:spLocks noGrp="1"/>
+          </p:cNvSpPr>
+          <p:nvPr>
+            <p:ph type="sldNum" idx="5" sz="quarter"/>
+          </p:nvPr>
+        </p:nvSpPr>
+        <p:spPr/>
+      </p:sp>
+    </p:spTree>
+  </p:cSld>
+  <p:clrMapOvr>
+    <a:masterClrMapping/>
+  </p:clrMapOvr>
+</p:notes>
+</file>
+
+<file path=ppt/notesSlides/notesSlide17.xml><?xml version="1.0" encoding="utf-8"?>
+<p:notes xmlns:a="http://schemas.openxmlformats.org/drawingml/2006/main" xmlns:p="http://schemas.openxmlformats.org/presentationml/2006/main" xmlns:r="http://schemas.openxmlformats.org/officeDocument/2006/relationships">
+  <p:cSld>
+    <p:spTree>
+      <p:nvGrpSpPr>
+        <p:cNvPr id="1" name=""/>
+        <p:cNvGrpSpPr/>
+        <p:nvPr/>
+      </p:nvGrpSpPr>
+      <p:grpSpPr>
+        <a:xfrm>
+          <a:off x="0" y="0"/>
+          <a:ext cx="0" cy="0"/>
+          <a:chOff x="0" y="0"/>
+          <a:chExt cx="0" cy="0"/>
+        </a:xfrm>
+      </p:grpSpPr>
+      <p:sp>
+        <p:nvSpPr>
+          <p:cNvPr id="2" name="Slide Image Placeholder 1"/>
+          <p:cNvSpPr>
+            <a:spLocks noGrp="1"/>
+          </p:cNvSpPr>
+          <p:nvPr>
+            <p:ph type="sldImg" idx="2"/>
+          </p:nvPr>
+        </p:nvSpPr>
+        <p:spPr/>
+      </p:sp>
+      <p:sp>
+        <p:nvSpPr>
+          <p:cNvPr id="3" name="Notes Placeholder 2"/>
+          <p:cNvSpPr>
+            <a:spLocks noGrp="1"/>
+          </p:cNvSpPr>
+          <p:nvPr>
+            <p:ph type="body" idx="3" sz="quarter"/>
+          </p:nvPr>
+        </p:nvSpPr>
+        <p:spPr/>
+        <p:txBody>
+          <a:bodyPr/>
+          <a:lstStyle/>
+          <a:p>
+            <a:r>
+              <a:t>A camada Ouro no Oracle: onze tabelas T_SAUDE.</a:t>
+            </a:r>
+          </a:p>
+          <a:p>
+            <a:r>
+              <a:t>Fatos, dimensoes e tabelas de indicador ja agregadas. O painel nao calcula nada em tempo de tela: ele consulta indicador pronto. Isso e o que faz a tela responder em segundos.</a:t>
+            </a:r>
+          </a:p>
+        </p:txBody>
+      </p:sp>
+      <p:sp>
+        <p:nvSpPr>
+          <p:cNvPr id="4" name="Slide Number Placeholder 3"/>
+          <p:cNvSpPr>
+            <a:spLocks noGrp="1"/>
+          </p:cNvSpPr>
+          <p:nvPr>
+            <p:ph type="sldNum" idx="5" sz="quarter"/>
+          </p:nvPr>
+        </p:nvSpPr>
+        <p:spPr/>
+      </p:sp>
+    </p:spTree>
+  </p:cSld>
+  <p:clrMapOvr>
+    <a:masterClrMapping/>
+  </p:clrMapOvr>
+</p:notes>
+</file>
+
+<file path=ppt/notesSlides/notesSlide18.xml><?xml version="1.0" encoding="utf-8"?>
+<p:notes xmlns:a="http://schemas.openxmlformats.org/drawingml/2006/main" xmlns:p="http://schemas.openxmlformats.org/presentationml/2006/main" xmlns:r="http://schemas.openxmlformats.org/officeDocument/2006/relationships">
+  <p:cSld>
+    <p:spTree>
+      <p:nvGrpSpPr>
+        <p:cNvPr id="1" name=""/>
+        <p:cNvGrpSpPr/>
+        <p:nvPr/>
+      </p:nvGrpSpPr>
+      <p:grpSpPr>
+        <a:xfrm>
+          <a:off x="0" y="0"/>
+          <a:ext cx="0" cy="0"/>
+          <a:chOff x="0" y="0"/>
+          <a:chExt cx="0" cy="0"/>
+        </a:xfrm>
+      </p:grpSpPr>
+      <p:sp>
+        <p:nvSpPr>
+          <p:cNvPr id="2" name="Slide Image Placeholder 1"/>
+          <p:cNvSpPr>
+            <a:spLocks noGrp="1"/>
+          </p:cNvSpPr>
+          <p:nvPr>
+            <p:ph type="sldImg" idx="2"/>
+          </p:nvPr>
+        </p:nvSpPr>
+        <p:spPr/>
+      </p:sp>
+      <p:sp>
+        <p:nvSpPr>
+          <p:cNvPr id="3" name="Notes Placeholder 2"/>
+          <p:cNvSpPr>
+            <a:spLocks noGrp="1"/>
+          </p:cNvSpPr>
+          <p:nvPr>
+            <p:ph type="body" idx="3" sz="quarter"/>
+          </p:nvPr>
+        </p:nvSpPr>
+        <p:spPr/>
+        <p:txBody>
+          <a:bodyPr/>
+          <a:lstStyle/>
+          <a:p>
+            <a:r>
+              <a:t>Esta e a prova de que o modelo esta integro.</a:t>
+            </a:r>
+          </a:p>
+          <a:p>
+            <a:r>
+              <a:t>Eu tenho tres tabelas construidas por caminhos diferentes: o fato agregado por municipio e mes, o indicador de capacidade que faz join com os leitos, e o ranking de hospitais agregado por CNES. Sao tres agregacoes independentes, partindo de granularidades diferentes.</a:t>
+            </a:r>
+          </a:p>
+          <a:p>
+            <a:r>
+              <a:t>As tres somam exatamente cinco milhoes quinhentos e quarenta e seis mil oitocentos e dezessete. Se eu tivesse duplicado linha num join ou perdido registro num filtro, esses numeros divergiriam.</a:t>
+            </a:r>
+          </a:p>
+        </p:txBody>
+      </p:sp>
+      <p:sp>
+        <p:nvSpPr>
+          <p:cNvPr id="4" name="Slide Number Placeholder 3"/>
+          <p:cNvSpPr>
+            <a:spLocks noGrp="1"/>
+          </p:cNvSpPr>
+          <p:nvPr>
+            <p:ph type="sldNum" idx="5" sz="quarter"/>
+          </p:nvPr>
+        </p:nvSpPr>
+        <p:spPr/>
+      </p:sp>
+    </p:spTree>
+  </p:cSld>
+  <p:clrMapOvr>
+    <a:masterClrMapping/>
+  </p:clrMapOvr>
+</p:notes>
+</file>
+
+<file path=ppt/notesSlides/notesSlide19.xml><?xml version="1.0" encoding="utf-8"?>
+<p:notes xmlns:a="http://schemas.openxmlformats.org/drawingml/2006/main" xmlns:p="http://schemas.openxmlformats.org/presentationml/2006/main" xmlns:r="http://schemas.openxmlformats.org/officeDocument/2006/relationships">
+  <p:cSld>
+    <p:spTree>
+      <p:nvGrpSpPr>
+        <p:cNvPr id="1" name=""/>
+        <p:cNvGrpSpPr/>
+        <p:nvPr/>
+      </p:nvGrpSpPr>
+      <p:grpSpPr>
+        <a:xfrm>
+          <a:off x="0" y="0"/>
+          <a:ext cx="0" cy="0"/>
+          <a:chOff x="0" y="0"/>
+          <a:chExt cx="0" cy="0"/>
+        </a:xfrm>
+      </p:grpSpPr>
+      <p:sp>
+        <p:nvSpPr>
+          <p:cNvPr id="2" name="Slide Image Placeholder 1"/>
+          <p:cNvSpPr>
+            <a:spLocks noGrp="1"/>
+          </p:cNvSpPr>
+          <p:nvPr>
+            <p:ph type="sldImg" idx="2"/>
+          </p:nvPr>
+        </p:nvSpPr>
+        <p:spPr/>
+      </p:sp>
+      <p:sp>
+        <p:nvSpPr>
+          <p:cNvPr id="3" name="Notes Placeholder 2"/>
+          <p:cNvSpPr>
+            <a:spLocks noGrp="1"/>
+          </p:cNvSpPr>
+          <p:nvPr>
+            <p:ph type="body" idx="3" sz="quarter"/>
+          </p:nvPr>
+        </p:nvSpPr>
+        <p:spPr/>
+        <p:txBody>
+          <a:bodyPr/>
+          <a:lstStyle/>
+          <a:p>
+            <a:r>
+              <a:t>O que nao foi implementado, e por que.</a:t>
+            </a:r>
+          </a:p>
+          <a:p>
+            <a:r>
+              <a:t>Nos dois primeiros eu verifiquei no banco antes de desistir — nao presumi. No Select AI, consultei o all_objects. Na External Table, consultei o all_directories. Os dois retornaram vazio, e eu entreguei o DDL documentado junto com a consulta que comprova.</a:t>
+            </a:r>
+          </a:p>
+        </p:txBody>
+      </p:sp>
+      <p:sp>
+        <p:nvSpPr>
+          <p:cNvPr id="4" name="Slide Number Placeholder 3"/>
+          <p:cNvSpPr>
+            <a:spLocks noGrp="1"/>
+          </p:cNvSpPr>
+          <p:nvPr>
+            <p:ph type="sldNum" idx="5" sz="quarter"/>
+          </p:nvPr>
+        </p:nvSpPr>
+        <p:spPr/>
+      </p:sp>
+    </p:spTree>
+  </p:cSld>
+  <p:clrMapOvr>
+    <a:masterClrMapping/>
+  </p:clrMapOvr>
+</p:notes>
+</file>
+
+<file path=ppt/notesSlides/notesSlide2.xml><?xml version="1.0" encoding="utf-8"?>
+<p:notes xmlns:a="http://schemas.openxmlformats.org/drawingml/2006/main" xmlns:p="http://schemas.openxmlformats.org/presentationml/2006/main" xmlns:r="http://schemas.openxmlformats.org/officeDocument/2006/relationships">
+  <p:cSld>
+    <p:spTree>
+      <p:nvGrpSpPr>
+        <p:cNvPr id="1" name=""/>
+        <p:cNvGrpSpPr/>
+        <p:nvPr/>
+      </p:nvGrpSpPr>
+      <p:grpSpPr>
+        <a:xfrm>
+          <a:off x="0" y="0"/>
+          <a:ext cx="0" cy="0"/>
+          <a:chOff x="0" y="0"/>
+          <a:chExt cx="0" cy="0"/>
+        </a:xfrm>
+      </p:grpSpPr>
+      <p:sp>
+        <p:nvSpPr>
+          <p:cNvPr id="2" name="Slide Image Placeholder 1"/>
+          <p:cNvSpPr>
+            <a:spLocks noGrp="1"/>
+          </p:cNvSpPr>
+          <p:nvPr>
+            <p:ph type="sldImg" idx="2"/>
+          </p:nvPr>
+        </p:nvSpPr>
+        <p:spPr/>
+      </p:sp>
+      <p:sp>
+        <p:nvSpPr>
+          <p:cNvPr id="3" name="Notes Placeholder 2"/>
+          <p:cNvSpPr>
+            <a:spLocks noGrp="1"/>
+          </p:cNvSpPr>
+          <p:nvPr>
+            <p:ph type="body" idx="3" sz="quarter"/>
+          </p:nvPr>
+        </p:nvSpPr>
+        <p:spPr/>
+        <p:txBody>
+          <a:bodyPr/>
+          <a:lstStyle/>
+          <a:p>
+            <a:r>
+              <a:t>Bom dia. SaudeViz: um painel que transforma microdados publicos de saude em resposta que um gestor consegue usar.</a:t>
+            </a:r>
+          </a:p>
+          <a:p>
+            <a:r>
+              <a:t>Vou mostrar de onde os dados vieram, o que precisou ser feito com eles, e como viraram informacao. O produto final esta no ar e eu demonstro ao vivo no fim.</a:t>
+            </a:r>
+          </a:p>
+        </p:txBody>
+      </p:sp>
+      <p:sp>
+        <p:nvSpPr>
+          <p:cNvPr id="4" name="Slide Number Placeholder 3"/>
+          <p:cNvSpPr>
+            <a:spLocks noGrp="1"/>
+          </p:cNvSpPr>
+          <p:nvPr>
+            <p:ph type="sldNum" idx="5" sz="quarter"/>
+          </p:nvPr>
+        </p:nvSpPr>
+        <p:spPr/>
+      </p:sp>
+    </p:spTree>
+  </p:cSld>
+  <p:clrMapOvr>
+    <a:masterClrMapping/>
+  </p:clrMapOvr>
+</p:notes>
+</file>
+
+<file path=ppt/notesSlides/notesSlide20.xml><?xml version="1.0" encoding="utf-8"?>
+<p:notes xmlns:a="http://schemas.openxmlformats.org/drawingml/2006/main" xmlns:p="http://schemas.openxmlformats.org/presentationml/2006/main" xmlns:r="http://schemas.openxmlformats.org/officeDocument/2006/relationships">
+  <p:cSld>
+    <p:spTree>
+      <p:nvGrpSpPr>
+        <p:cNvPr id="1" name=""/>
+        <p:cNvGrpSpPr/>
+        <p:nvPr/>
+      </p:nvGrpSpPr>
+      <p:grpSpPr>
+        <a:xfrm>
+          <a:off x="0" y="0"/>
+          <a:ext cx="0" cy="0"/>
+          <a:chOff x="0" y="0"/>
+          <a:chExt cx="0" cy="0"/>
+        </a:xfrm>
+      </p:grpSpPr>
+      <p:sp>
+        <p:nvSpPr>
+          <p:cNvPr id="2" name="Slide Image Placeholder 1"/>
+          <p:cNvSpPr>
+            <a:spLocks noGrp="1"/>
+          </p:cNvSpPr>
+          <p:nvPr>
+            <p:ph type="sldImg" idx="2"/>
+          </p:nvPr>
+        </p:nvSpPr>
+        <p:spPr/>
+      </p:sp>
+      <p:sp>
+        <p:nvSpPr>
+          <p:cNvPr id="3" name="Notes Placeholder 2"/>
+          <p:cNvSpPr>
+            <a:spLocks noGrp="1"/>
+          </p:cNvSpPr>
+          <p:nvPr>
+            <p:ph type="body" idx="3" sz="quarter"/>
+          </p:nvPr>
+        </p:nvSpPr>
+        <p:spPr/>
+        <p:txBody>
+          <a:bodyPr/>
+          <a:lstStyle/>
+          <a:p>
+            <a:r>
+              <a:t>Quarta entrega: como os dados foram obtidos, tratados e transformados.</a:t>
+            </a:r>
+          </a:p>
+        </p:txBody>
+      </p:sp>
+      <p:sp>
+        <p:nvSpPr>
+          <p:cNvPr id="4" name="Slide Number Placeholder 3"/>
+          <p:cNvSpPr>
+            <a:spLocks noGrp="1"/>
+          </p:cNvSpPr>
+          <p:nvPr>
+            <p:ph type="sldNum" idx="5" sz="quarter"/>
+          </p:nvPr>
+        </p:nvSpPr>
+        <p:spPr/>
+      </p:sp>
+    </p:spTree>
+  </p:cSld>
+  <p:clrMapOvr>
+    <a:masterClrMapping/>
+  </p:clrMapOvr>
+</p:notes>
+</file>
+
+<file path=ppt/notesSlides/notesSlide21.xml><?xml version="1.0" encoding="utf-8"?>
+<p:notes xmlns:a="http://schemas.openxmlformats.org/drawingml/2006/main" xmlns:p="http://schemas.openxmlformats.org/presentationml/2006/main" xmlns:r="http://schemas.openxmlformats.org/officeDocument/2006/relationships">
+  <p:cSld>
+    <p:spTree>
+      <p:nvGrpSpPr>
+        <p:cNvPr id="1" name=""/>
+        <p:cNvGrpSpPr/>
+        <p:nvPr/>
+      </p:nvGrpSpPr>
+      <p:grpSpPr>
+        <a:xfrm>
+          <a:off x="0" y="0"/>
+          <a:ext cx="0" cy="0"/>
+          <a:chOff x="0" y="0"/>
+          <a:chExt cx="0" cy="0"/>
+        </a:xfrm>
+      </p:grpSpPr>
+      <p:sp>
+        <p:nvSpPr>
+          <p:cNvPr id="2" name="Slide Image Placeholder 1"/>
+          <p:cNvSpPr>
+            <a:spLocks noGrp="1"/>
+          </p:cNvSpPr>
+          <p:nvPr>
+            <p:ph type="sldImg" idx="2"/>
+          </p:nvPr>
+        </p:nvSpPr>
+        <p:spPr/>
+      </p:sp>
+      <p:sp>
+        <p:nvSpPr>
+          <p:cNvPr id="3" name="Notes Placeholder 2"/>
+          <p:cNvSpPr>
+            <a:spLocks noGrp="1"/>
+          </p:cNvSpPr>
+          <p:nvPr>
+            <p:ph type="body" idx="3" sz="quarter"/>
+          </p:nvPr>
+        </p:nvSpPr>
+        <p:spPr/>
+        <p:txBody>
+          <a:bodyPr/>
+          <a:lstStyle/>
+          <a:p>
+            <a:r>
+              <a:t>As fontes, e como cada uma e lida.</a:t>
+            </a:r>
+          </a:p>
+          <a:p>
+            <a:r>
+              <a:t>O SIH vem por FTP, em arquivo .dbc, um por estado e por mes: sessenta arquivos. O CNES vem por API REST em JSON — e aqui teve armadilha: o parametro de UF da API e silenciosamente ignorado. Eu recebia trinta e dois mil registros com apenas mil e duzentos unicos, repetidos vinte e sete vezes. Descobri contando distintos, e troquei para busca dirigida por codigo de estabelecimento.</a:t>
+            </a:r>
+          </a:p>
+          <a:p>
+            <a:r>
+              <a:t>O IBGE vem em CSV, e cumpre a exigencia do terceiro formato. A quarta fonte, de clima, eu acrescentei por conta.</a:t>
+            </a:r>
+          </a:p>
+        </p:txBody>
+      </p:sp>
+      <p:sp>
+        <p:nvSpPr>
+          <p:cNvPr id="4" name="Slide Number Placeholder 3"/>
+          <p:cNvSpPr>
+            <a:spLocks noGrp="1"/>
+          </p:cNvSpPr>
+          <p:nvPr>
+            <p:ph type="sldNum" idx="5" sz="quarter"/>
+          </p:nvPr>
+        </p:nvSpPr>
+        <p:spPr/>
+      </p:sp>
+    </p:spTree>
+  </p:cSld>
+  <p:clrMapOvr>
+    <a:masterClrMapping/>
+  </p:clrMapOvr>
+</p:notes>
+</file>
+
+<file path=ppt/notesSlides/notesSlide22.xml><?xml version="1.0" encoding="utf-8"?>
+<p:notes xmlns:a="http://schemas.openxmlformats.org/drawingml/2006/main" xmlns:p="http://schemas.openxmlformats.org/presentationml/2006/main" xmlns:r="http://schemas.openxmlformats.org/officeDocument/2006/relationships">
+  <p:cSld>
+    <p:spTree>
+      <p:nvGrpSpPr>
+        <p:cNvPr id="1" name=""/>
+        <p:cNvGrpSpPr/>
+        <p:nvPr/>
+      </p:nvGrpSpPr>
+      <p:grpSpPr>
+        <a:xfrm>
+          <a:off x="0" y="0"/>
+          <a:ext cx="0" cy="0"/>
+          <a:chOff x="0" y="0"/>
+          <a:chExt cx="0" cy="0"/>
+        </a:xfrm>
+      </p:grpSpPr>
+      <p:sp>
+        <p:nvSpPr>
+          <p:cNvPr id="2" name="Slide Image Placeholder 1"/>
+          <p:cNvSpPr>
+            <a:spLocks noGrp="1"/>
+          </p:cNvSpPr>
+          <p:nvPr>
+            <p:ph type="sldImg" idx="2"/>
+          </p:nvPr>
+        </p:nvSpPr>
+        <p:spPr/>
+      </p:sp>
+      <p:sp>
+        <p:nvSpPr>
+          <p:cNvPr id="3" name="Notes Placeholder 2"/>
+          <p:cNvSpPr>
+            <a:spLocks noGrp="1"/>
+          </p:cNvSpPr>
+          <p:nvPr>
+            <p:ph type="body" idx="3" sz="quarter"/>
+          </p:nvPr>
+        </p:nvSpPr>
+        <p:spPr/>
+        <p:txBody>
+          <a:bodyPr/>
+          <a:lstStyle/>
+          <a:p>
+            <a:r>
+              <a:t>O .dbc do DATASUS e um DBF comprimido com um algoritmo antigo, o PKWare DCL. Nenhuma biblioteca padrao le.</a:t>
+            </a:r>
+          </a:p>
+          <a:p>
+            <a:r>
+              <a:t>E teve um detalhe que custou tempo: a extensao C nao aceita acento no caminho do arquivo. O projeto mora numa pasta chamada "Educacao/Ciencia de Dados", com cedilha e acento. A solucao foi copiar cada arquivo para um diretorio temporario de nome ASCII, converter la, e devolver.</a:t>
+            </a:r>
+          </a:p>
+          <a:p>
+            <a:r>
+              <a:t>E o tipo de problema que nao aparece em tutorial.</a:t>
+            </a:r>
+          </a:p>
+        </p:txBody>
+      </p:sp>
+      <p:sp>
+        <p:nvSpPr>
+          <p:cNvPr id="4" name="Slide Number Placeholder 3"/>
+          <p:cNvSpPr>
+            <a:spLocks noGrp="1"/>
+          </p:cNvSpPr>
+          <p:nvPr>
+            <p:ph type="sldNum" idx="5" sz="quarter"/>
+          </p:nvPr>
+        </p:nvSpPr>
+        <p:spPr/>
+      </p:sp>
+    </p:spTree>
+  </p:cSld>
+  <p:clrMapOvr>
+    <a:masterClrMapping/>
+  </p:clrMapOvr>
+</p:notes>
+</file>
+
+<file path=ppt/notesSlides/notesSlide23.xml><?xml version="1.0" encoding="utf-8"?>
+<p:notes xmlns:a="http://schemas.openxmlformats.org/drawingml/2006/main" xmlns:p="http://schemas.openxmlformats.org/presentationml/2006/main" xmlns:r="http://schemas.openxmlformats.org/officeDocument/2006/relationships">
+  <p:cSld>
+    <p:spTree>
+      <p:nvGrpSpPr>
+        <p:cNvPr id="1" name=""/>
+        <p:cNvGrpSpPr/>
+        <p:nvPr/>
+      </p:nvGrpSpPr>
+      <p:grpSpPr>
+        <a:xfrm>
+          <a:off x="0" y="0"/>
+          <a:ext cx="0" cy="0"/>
+          <a:chOff x="0" y="0"/>
+          <a:chExt cx="0" cy="0"/>
+        </a:xfrm>
+      </p:grpSpPr>
+      <p:sp>
+        <p:nvSpPr>
+          <p:cNvPr id="2" name="Slide Image Placeholder 1"/>
+          <p:cNvSpPr>
+            <a:spLocks noGrp="1"/>
+          </p:cNvSpPr>
+          <p:nvPr>
+            <p:ph type="sldImg" idx="2"/>
+          </p:nvPr>
+        </p:nvSpPr>
+        <p:spPr/>
+      </p:sp>
+      <p:sp>
+        <p:nvSpPr>
+          <p:cNvPr id="3" name="Notes Placeholder 2"/>
+          <p:cNvSpPr>
+            <a:spLocks noGrp="1"/>
+          </p:cNvSpPr>
+          <p:nvPr>
+            <p:ph type="body" idx="3" sz="quarter"/>
+          </p:nvPr>
+        </p:nvSpPr>
+        <p:spPr/>
+        <p:txBody>
+          <a:bodyPr/>
+          <a:lstStyle/>
+          <a:p>
+            <a:r>
+              <a:t>Esta e a descoberta que reorientou o projeto inteiro.</a:t>
+            </a:r>
+          </a:p>
+          <a:p>
+            <a:r>
+              <a:t>Eu criei uma coluna calculada chamada defasagem_faturamento: a diferenca em meses entre a competencia do arquivo e o mes real da internacao. Agrupei por ela e contei.</a:t>
+            </a:r>
+          </a:p>
+          <a:p>
+            <a:r>
+              <a:t>Sessenta por cento no mesmo mes. Quarenta por cento espalhados nos tres meses seguintes. Ou seja: a competencia do SIH e o mes de PAGAMENTO da AIH, nao o da internacao.</a:t>
+            </a:r>
+          </a:p>
+          <a:p>
+            <a:r>
+              <a:t>Se eu tivesse usado a competencia como eixo de tempo, meu painel responderia uma pergunta financeira prometendo uma assistencial. Troquei a dimensao temporal para a data de internacao e ampliei a ingestao ate marco de 2025, para recuperar dezembro faturado com atraso.</a:t>
+            </a:r>
+          </a:p>
+          <a:p>
+            <a:r>
+              <a:t>Aqui tambem entram os filtros de qualidade: deduplicacao por numero de AIH mantendo a versao mais recente, via row_number sobre uma janela particionada por n_aih; descarte de permanencia fora de zero a trezentos e sessenta e cinco dias; e descarte de valor negativo.</a:t>
+            </a:r>
+          </a:p>
+        </p:txBody>
+      </p:sp>
+      <p:sp>
+        <p:nvSpPr>
+          <p:cNvPr id="4" name="Slide Number Placeholder 3"/>
+          <p:cNvSpPr>
+            <a:spLocks noGrp="1"/>
+          </p:cNvSpPr>
+          <p:nvPr>
+            <p:ph type="sldNum" idx="5" sz="quarter"/>
+          </p:nvPr>
+        </p:nvSpPr>
+        <p:spPr/>
+      </p:sp>
+    </p:spTree>
+  </p:cSld>
+  <p:clrMapOvr>
+    <a:masterClrMapping/>
+  </p:clrMapOvr>
+</p:notes>
+</file>
+
+<file path=ppt/notesSlides/notesSlide24.xml><?xml version="1.0" encoding="utf-8"?>
+<p:notes xmlns:a="http://schemas.openxmlformats.org/drawingml/2006/main" xmlns:p="http://schemas.openxmlformats.org/presentationml/2006/main" xmlns:r="http://schemas.openxmlformats.org/officeDocument/2006/relationships">
+  <p:cSld>
+    <p:spTree>
+      <p:nvGrpSpPr>
+        <p:cNvPr id="1" name=""/>
+        <p:cNvGrpSpPr/>
+        <p:nvPr/>
+      </p:nvGrpSpPr>
+      <p:grpSpPr>
+        <a:xfrm>
+          <a:off x="0" y="0"/>
+          <a:ext cx="0" cy="0"/>
+          <a:chOff x="0" y="0"/>
+          <a:chExt cx="0" cy="0"/>
+        </a:xfrm>
+      </p:grpSpPr>
+      <p:sp>
+        <p:nvSpPr>
+          <p:cNvPr id="2" name="Slide Image Placeholder 1"/>
+          <p:cNvSpPr>
+            <a:spLocks noGrp="1"/>
+          </p:cNvSpPr>
+          <p:nvPr>
+            <p:ph type="sldImg" idx="2"/>
+          </p:nvPr>
+        </p:nvSpPr>
+        <p:spPr/>
+      </p:sp>
+      <p:sp>
+        <p:nvSpPr>
+          <p:cNvPr id="3" name="Notes Placeholder 2"/>
+          <p:cNvSpPr>
+            <a:spLocks noGrp="1"/>
+          </p:cNvSpPr>
+          <p:nvPr>
+            <p:ph type="body" idx="3" sz="quarter"/>
+          </p:nvPr>
+        </p:nvSpPr>
+        <p:spPr/>
+        <p:txBody>
+          <a:bodyPr/>
+          <a:lstStyle/>
+          <a:p>
+            <a:r>
+              <a:t>Dezesseis consultas SQL documentadas, cobrindo as quatro frentes do desafio.</a:t>
+            </a:r>
+          </a:p>
+          <a:p>
+            <a:r>
+              <a:t>Cada uma tem a pergunta de negocio escrita antes do SQL, e a leitura do resultado escrita depois. Nao e SQL solto: e pergunta, consulta, resposta.</a:t>
+            </a:r>
+          </a:p>
+          <a:p>
+            <a:r>
+              <a:t>Uma delas eu precisei reescrever depois de revisar: a Q11 calculava media simples de leitos por cem mil habitantes entre municipios, o que da o mesmo peso a uma cidade de cinco mil e a uma de doze milhoes. Reescrevi com CTE por municipio, e a conclusao mudou: o Rio passou a ser o pior estado, nao Sao Paulo.</a:t>
+            </a:r>
+          </a:p>
+        </p:txBody>
+      </p:sp>
+      <p:sp>
+        <p:nvSpPr>
+          <p:cNvPr id="4" name="Slide Number Placeholder 3"/>
+          <p:cNvSpPr>
+            <a:spLocks noGrp="1"/>
+          </p:cNvSpPr>
+          <p:nvPr>
+            <p:ph type="sldNum" idx="5" sz="quarter"/>
+          </p:nvPr>
+        </p:nvSpPr>
+        <p:spPr/>
+      </p:sp>
+    </p:spTree>
+  </p:cSld>
+  <p:clrMapOvr>
+    <a:masterClrMapping/>
+  </p:clrMapOvr>
+</p:notes>
+</file>
+
+<file path=ppt/notesSlides/notesSlide25.xml><?xml version="1.0" encoding="utf-8"?>
+<p:notes xmlns:a="http://schemas.openxmlformats.org/drawingml/2006/main" xmlns:p="http://schemas.openxmlformats.org/presentationml/2006/main" xmlns:r="http://schemas.openxmlformats.org/officeDocument/2006/relationships">
+  <p:cSld>
+    <p:spTree>
+      <p:nvGrpSpPr>
+        <p:cNvPr id="1" name=""/>
+        <p:cNvGrpSpPr/>
+        <p:nvPr/>
+      </p:nvGrpSpPr>
+      <p:grpSpPr>
+        <a:xfrm>
+          <a:off x="0" y="0"/>
+          <a:ext cx="0" cy="0"/>
+          <a:chOff x="0" y="0"/>
+          <a:chExt cx="0" cy="0"/>
+        </a:xfrm>
+      </p:grpSpPr>
+      <p:sp>
+        <p:nvSpPr>
+          <p:cNvPr id="2" name="Slide Image Placeholder 1"/>
+          <p:cNvSpPr>
+            <a:spLocks noGrp="1"/>
+          </p:cNvSpPr>
+          <p:nvPr>
+            <p:ph type="sldImg" idx="2"/>
+          </p:nvPr>
+        </p:nvSpPr>
+        <p:spPr/>
+      </p:sp>
+      <p:sp>
+        <p:nvSpPr>
+          <p:cNvPr id="3" name="Notes Placeholder 2"/>
+          <p:cNvSpPr>
+            <a:spLocks noGrp="1"/>
+          </p:cNvSpPr>
+          <p:nvPr>
+            <p:ph type="body" idx="3" sz="quarter"/>
+          </p:nvPr>
+        </p:nvSpPr>
+        <p:spPr/>
+        <p:txBody>
+          <a:bodyPr/>
+          <a:lstStyle/>
+          <a:p>
+            <a:r>
+              <a:t>Duas tecnicas estatisticas, e as duas com proposito.</a:t>
+            </a:r>
+          </a:p>
+          <a:p>
+            <a:r>
+              <a:t>O IQR de Tukey define o limite de outlier em 1,172. Eu tinha escolhido 1,0 como limiar de alerta por raciocinio de negocio, antes de calcular isso. O criterio estatistico, que nao sabe do meu limiar, confirma que ocupacao acima de um e anomala nesta distribuicao.</a:t>
+            </a:r>
+          </a:p>
+          <a:p>
+            <a:r>
+              <a:t>A correlacao de Pearson entre ocupacao e transferencia da menos 0,305. Negativa: municipios com baixa ocupacao transferem MAIS. Nao e contradicao — e a assinatura de quem nao tem capacidade resolutiva, estabiliza o paciente e encaminha.</a:t>
+            </a:r>
+          </a:p>
+        </p:txBody>
+      </p:sp>
+      <p:sp>
+        <p:nvSpPr>
+          <p:cNvPr id="4" name="Slide Number Placeholder 3"/>
+          <p:cNvSpPr>
+            <a:spLocks noGrp="1"/>
+          </p:cNvSpPr>
+          <p:nvPr>
+            <p:ph type="sldNum" idx="5" sz="quarter"/>
+          </p:nvPr>
+        </p:nvSpPr>
+        <p:spPr/>
+      </p:sp>
+    </p:spTree>
+  </p:cSld>
+  <p:clrMapOvr>
+    <a:masterClrMapping/>
+  </p:clrMapOvr>
+</p:notes>
+</file>
+
+<file path=ppt/notesSlides/notesSlide26.xml><?xml version="1.0" encoding="utf-8"?>
+<p:notes xmlns:a="http://schemas.openxmlformats.org/drawingml/2006/main" xmlns:p="http://schemas.openxmlformats.org/presentationml/2006/main" xmlns:r="http://schemas.openxmlformats.org/officeDocument/2006/relationships">
+  <p:cSld>
+    <p:spTree>
+      <p:nvGrpSpPr>
+        <p:cNvPr id="1" name=""/>
+        <p:cNvGrpSpPr/>
+        <p:nvPr/>
+      </p:nvGrpSpPr>
+      <p:grpSpPr>
+        <a:xfrm>
+          <a:off x="0" y="0"/>
+          <a:ext cx="0" cy="0"/>
+          <a:chOff x="0" y="0"/>
+          <a:chExt cx="0" cy="0"/>
+        </a:xfrm>
+      </p:grpSpPr>
+      <p:sp>
+        <p:nvSpPr>
+          <p:cNvPr id="2" name="Slide Image Placeholder 1"/>
+          <p:cNvSpPr>
+            <a:spLocks noGrp="1"/>
+          </p:cNvSpPr>
+          <p:nvPr>
+            <p:ph type="sldImg" idx="2"/>
+          </p:nvPr>
+        </p:nvSpPr>
+        <p:spPr/>
+      </p:sp>
+      <p:sp>
+        <p:nvSpPr>
+          <p:cNvPr id="3" name="Notes Placeholder 2"/>
+          <p:cNvSpPr>
+            <a:spLocks noGrp="1"/>
+          </p:cNvSpPr>
+          <p:nvPr>
+            <p:ph type="body" idx="3" sz="quarter"/>
+          </p:nvPr>
+        </p:nvSpPr>
+        <p:spPr/>
+        <p:txBody>
+          <a:bodyPr/>
+          <a:lstStyle/>
+          <a:p>
+            <a:r>
+              <a:t>Aqui eu testei duas abordagens e deixei o dado escolher.</a:t>
+            </a:r>
+          </a:p>
+          <a:p>
+            <a:r>
+              <a:t>A primeira: regressao com tendencia linear, sazonalidade em termos de Fourier e variavel de feriado. A segunda: perfil semanal simples, que so aprende quanto cada dia da semana desvia da media.</a:t>
+            </a:r>
+          </a:p>
+          <a:p>
+            <a:r>
+              <a:t>Validei com janela expansivel — treino no passado, teste no futuro, avancando. Nunca com dado aleatorio, porque em serie temporal isso vaza o futuro para o treino.</a:t>
+            </a:r>
+          </a:p>
+          <a:p>
+            <a:r>
+              <a:t>A regressao perdeu. O erro dela sobe de seis para vinte e sete por cento conforme o horizonte cresce, porque a tendencia linear extrapola. O modelo simples fica estavel em cinco e meio.</a:t>
+            </a:r>
+          </a:p>
+          <a:p>
+            <a:r>
+              <a:t>Reconhecer que a serie nao tem tendencia explorável valeu mais do que forcar complexidade.</a:t>
+            </a:r>
+          </a:p>
+        </p:txBody>
+      </p:sp>
+      <p:sp>
+        <p:nvSpPr>
+          <p:cNvPr id="4" name="Slide Number Placeholder 3"/>
+          <p:cNvSpPr>
+            <a:spLocks noGrp="1"/>
+          </p:cNvSpPr>
+          <p:nvPr>
+            <p:ph type="sldNum" idx="5" sz="quarter"/>
+          </p:nvPr>
+        </p:nvSpPr>
+        <p:spPr/>
+      </p:sp>
+    </p:spTree>
+  </p:cSld>
+  <p:clrMapOvr>
+    <a:masterClrMapping/>
+  </p:clrMapOvr>
+</p:notes>
+</file>
+
+<file path=ppt/notesSlides/notesSlide27.xml><?xml version="1.0" encoding="utf-8"?>
+<p:notes xmlns:a="http://schemas.openxmlformats.org/drawingml/2006/main" xmlns:p="http://schemas.openxmlformats.org/presentationml/2006/main" xmlns:r="http://schemas.openxmlformats.org/officeDocument/2006/relationships">
+  <p:cSld>
+    <p:spTree>
+      <p:nvGrpSpPr>
+        <p:cNvPr id="1" name=""/>
+        <p:cNvGrpSpPr/>
+        <p:nvPr/>
+      </p:nvGrpSpPr>
+      <p:grpSpPr>
+        <a:xfrm>
+          <a:off x="0" y="0"/>
+          <a:ext cx="0" cy="0"/>
+          <a:chOff x="0" y="0"/>
+          <a:chExt cx="0" cy="0"/>
+        </a:xfrm>
+      </p:grpSpPr>
+      <p:sp>
+        <p:nvSpPr>
+          <p:cNvPr id="2" name="Slide Image Placeholder 1"/>
+          <p:cNvSpPr>
+            <a:spLocks noGrp="1"/>
+          </p:cNvSpPr>
+          <p:nvPr>
+            <p:ph type="sldImg" idx="2"/>
+          </p:nvPr>
+        </p:nvSpPr>
+        <p:spPr/>
+      </p:sp>
+      <p:sp>
+        <p:nvSpPr>
+          <p:cNvPr id="3" name="Notes Placeholder 2"/>
+          <p:cNvSpPr>
+            <a:spLocks noGrp="1"/>
+          </p:cNvSpPr>
+          <p:nvPr>
+            <p:ph type="body" idx="3" sz="quarter"/>
+          </p:nvPr>
+        </p:nvSpPr>
+        <p:spPr/>
+        <p:txBody>
+          <a:bodyPr/>
+          <a:lstStyle/>
+          <a:p>
+            <a:r>
+              <a:t>O sinal previsivel esta no calendario.</a:t>
+            </a:r>
+          </a:p>
+          <a:p>
+            <a:r>
+              <a:t>Sabado cai trinta e oito por cento, domingo quarenta e um, feriado vinte e seis. E consistente nos quatro estados, com variacao de tres pontos entre eles.</a:t>
+            </a:r>
+          </a:p>
+          <a:p>
+            <a:r>
+              <a:t>E a leitura importa: isso nao e menos gente doente no fim de semana. E a rede eletiva parada. Cirurgia programada nao acontece no domingo.</a:t>
+            </a:r>
+          </a:p>
+        </p:txBody>
+      </p:sp>
+      <p:sp>
+        <p:nvSpPr>
+          <p:cNvPr id="4" name="Slide Number Placeholder 3"/>
+          <p:cNvSpPr>
+            <a:spLocks noGrp="1"/>
+          </p:cNvSpPr>
+          <p:nvPr>
+            <p:ph type="sldNum" idx="5" sz="quarter"/>
+          </p:nvPr>
+        </p:nvSpPr>
+        <p:spPr/>
+      </p:sp>
+    </p:spTree>
+  </p:cSld>
+  <p:clrMapOvr>
+    <a:masterClrMapping/>
+  </p:clrMapOvr>
+</p:notes>
+</file>
+
+<file path=ppt/notesSlides/notesSlide28.xml><?xml version="1.0" encoding="utf-8"?>
+<p:notes xmlns:a="http://schemas.openxmlformats.org/drawingml/2006/main" xmlns:p="http://schemas.openxmlformats.org/presentationml/2006/main" xmlns:r="http://schemas.openxmlformats.org/officeDocument/2006/relationships">
+  <p:cSld>
+    <p:spTree>
+      <p:nvGrpSpPr>
+        <p:cNvPr id="1" name=""/>
+        <p:cNvGrpSpPr/>
+        <p:nvPr/>
+      </p:nvGrpSpPr>
+      <p:grpSpPr>
+        <a:xfrm>
+          <a:off x="0" y="0"/>
+          <a:ext cx="0" cy="0"/>
+          <a:chOff x="0" y="0"/>
+          <a:chExt cx="0" cy="0"/>
+        </a:xfrm>
+      </p:grpSpPr>
+      <p:sp>
+        <p:nvSpPr>
+          <p:cNvPr id="2" name="Slide Image Placeholder 1"/>
+          <p:cNvSpPr>
+            <a:spLocks noGrp="1"/>
+          </p:cNvSpPr>
+          <p:nvPr>
+            <p:ph type="sldImg" idx="2"/>
+          </p:nvPr>
+        </p:nvSpPr>
+        <p:spPr/>
+      </p:sp>
+      <p:sp>
+        <p:nvSpPr>
+          <p:cNvPr id="3" name="Notes Placeholder 2"/>
+          <p:cNvSpPr>
+            <a:spLocks noGrp="1"/>
+          </p:cNvSpPr>
+          <p:nvPr>
+            <p:ph type="body" idx="3" sz="quarter"/>
+          </p:nvPr>
+        </p:nvSpPr>
+        <p:spPr/>
+        <p:txBody>
+          <a:bodyPr/>
+          <a:lstStyle/>
+          <a:p>
+            <a:r>
+              <a:t>Quinta entrega: as evidencias visuais do que foi construido.</a:t>
+            </a:r>
+          </a:p>
+        </p:txBody>
+      </p:sp>
+      <p:sp>
+        <p:nvSpPr>
+          <p:cNvPr id="4" name="Slide Number Placeholder 3"/>
+          <p:cNvSpPr>
+            <a:spLocks noGrp="1"/>
+          </p:cNvSpPr>
+          <p:nvPr>
+            <p:ph type="sldNum" idx="5" sz="quarter"/>
+          </p:nvPr>
+        </p:nvSpPr>
+        <p:spPr/>
+      </p:sp>
+    </p:spTree>
+  </p:cSld>
+  <p:clrMapOvr>
+    <a:masterClrMapping/>
+  </p:clrMapOvr>
+</p:notes>
+</file>
+
+<file path=ppt/notesSlides/notesSlide29.xml><?xml version="1.0" encoding="utf-8"?>
+<p:notes xmlns:a="http://schemas.openxmlformats.org/drawingml/2006/main" xmlns:p="http://schemas.openxmlformats.org/presentationml/2006/main" xmlns:r="http://schemas.openxmlformats.org/officeDocument/2006/relationships">
+  <p:cSld>
+    <p:spTree>
+      <p:nvGrpSpPr>
+        <p:cNvPr id="1" name=""/>
+        <p:cNvGrpSpPr/>
+        <p:nvPr/>
+      </p:nvGrpSpPr>
+      <p:grpSpPr>
+        <a:xfrm>
+          <a:off x="0" y="0"/>
+          <a:ext cx="0" cy="0"/>
+          <a:chOff x="0" y="0"/>
+          <a:chExt cx="0" cy="0"/>
+        </a:xfrm>
+      </p:grpSpPr>
+      <p:sp>
+        <p:nvSpPr>
+          <p:cNvPr id="2" name="Slide Image Placeholder 1"/>
+          <p:cNvSpPr>
+            <a:spLocks noGrp="1"/>
+          </p:cNvSpPr>
+          <p:nvPr>
+            <p:ph type="sldImg" idx="2"/>
+          </p:nvPr>
+        </p:nvSpPr>
+        <p:spPr/>
+      </p:sp>
+      <p:sp>
+        <p:nvSpPr>
+          <p:cNvPr id="3" name="Notes Placeholder 2"/>
+          <p:cNvSpPr>
+            <a:spLocks noGrp="1"/>
+          </p:cNvSpPr>
+          <p:nvPr>
+            <p:ph type="body" idx="3" sz="quarter"/>
+          </p:nvPr>
+        </p:nvSpPr>
+        <p:spPr/>
+        <p:txBody>
+          <a:bodyPr/>
+          <a:lstStyle/>
+          <a:p>
+            <a:r>
+              <a:t>A previsao no painel, com intervalo de noventa e cinco por cento.</a:t>
+            </a:r>
+          </a:p>
+          <a:p>
+            <a:r>
+              <a:t>O intervalo vem do desvio dos residuos por dia da semana — nao e uma faixa arbitraria: cada dia tem a sua propria incerteza histórica.</a:t>
+            </a:r>
+          </a:p>
+        </p:txBody>
+      </p:sp>
+      <p:sp>
+        <p:nvSpPr>
+          <p:cNvPr id="4" name="Slide Number Placeholder 3"/>
+          <p:cNvSpPr>
+            <a:spLocks noGrp="1"/>
+          </p:cNvSpPr>
+          <p:nvPr>
+            <p:ph type="sldNum" idx="5" sz="quarter"/>
+          </p:nvPr>
+        </p:nvSpPr>
+        <p:spPr/>
+      </p:sp>
+    </p:spTree>
+  </p:cSld>
+  <p:clrMapOvr>
+    <a:masterClrMapping/>
+  </p:clrMapOvr>
+</p:notes>
+</file>
+
+<file path=ppt/notesSlides/notesSlide3.xml><?xml version="1.0" encoding="utf-8"?>
+<p:notes xmlns:a="http://schemas.openxmlformats.org/drawingml/2006/main" xmlns:p="http://schemas.openxmlformats.org/presentationml/2006/main" xmlns:r="http://schemas.openxmlformats.org/officeDocument/2006/relationships">
+  <p:cSld>
+    <p:spTree>
+      <p:nvGrpSpPr>
+        <p:cNvPr id="1" name=""/>
+        <p:cNvGrpSpPr/>
+        <p:nvPr/>
+      </p:nvGrpSpPr>
+      <p:grpSpPr>
+        <a:xfrm>
+          <a:off x="0" y="0"/>
+          <a:ext cx="0" cy="0"/>
+          <a:chOff x="0" y="0"/>
+          <a:chExt cx="0" cy="0"/>
+        </a:xfrm>
+      </p:grpSpPr>
+      <p:sp>
+        <p:nvSpPr>
+          <p:cNvPr id="2" name="Slide Image Placeholder 1"/>
+          <p:cNvSpPr>
+            <a:spLocks noGrp="1"/>
+          </p:cNvSpPr>
+          <p:nvPr>
+            <p:ph type="sldImg" idx="2"/>
+          </p:nvPr>
+        </p:nvSpPr>
+        <p:spPr/>
+      </p:sp>
+      <p:sp>
+        <p:nvSpPr>
+          <p:cNvPr id="3" name="Notes Placeholder 2"/>
+          <p:cNvSpPr>
+            <a:spLocks noGrp="1"/>
+          </p:cNvSpPr>
+          <p:nvPr>
+            <p:ph type="body" idx="3" sz="quarter"/>
+          </p:nvPr>
+        </p:nvSpPr>
+        <p:spPr/>
+        <p:txBody>
+          <a:bodyPr/>
+          <a:lstStyle/>
+          <a:p>
+            <a:r>
+              <a:t>Trabalho individual. Lucas Colen, RM 569173, turma 1TSCOA.</a:t>
+            </a:r>
+          </a:p>
+        </p:txBody>
+      </p:sp>
+      <p:sp>
+        <p:nvSpPr>
+          <p:cNvPr id="4" name="Slide Number Placeholder 3"/>
+          <p:cNvSpPr>
+            <a:spLocks noGrp="1"/>
+          </p:cNvSpPr>
+          <p:nvPr>
+            <p:ph type="sldNum" idx="5" sz="quarter"/>
+          </p:nvPr>
+        </p:nvSpPr>
+        <p:spPr/>
+      </p:sp>
+    </p:spTree>
+  </p:cSld>
+  <p:clrMapOvr>
+    <a:masterClrMapping/>
+  </p:clrMapOvr>
+</p:notes>
+</file>
+
+<file path=ppt/notesSlides/notesSlide30.xml><?xml version="1.0" encoding="utf-8"?>
+<p:notes xmlns:a="http://schemas.openxmlformats.org/drawingml/2006/main" xmlns:p="http://schemas.openxmlformats.org/presentationml/2006/main" xmlns:r="http://schemas.openxmlformats.org/officeDocument/2006/relationships">
+  <p:cSld>
+    <p:spTree>
+      <p:nvGrpSpPr>
+        <p:cNvPr id="1" name=""/>
+        <p:cNvGrpSpPr/>
+        <p:nvPr/>
+      </p:nvGrpSpPr>
+      <p:grpSpPr>
+        <a:xfrm>
+          <a:off x="0" y="0"/>
+          <a:ext cx="0" cy="0"/>
+          <a:chOff x="0" y="0"/>
+          <a:chExt cx="0" cy="0"/>
+        </a:xfrm>
+      </p:grpSpPr>
+      <p:sp>
+        <p:nvSpPr>
+          <p:cNvPr id="2" name="Slide Image Placeholder 1"/>
+          <p:cNvSpPr>
+            <a:spLocks noGrp="1"/>
+          </p:cNvSpPr>
+          <p:nvPr>
+            <p:ph type="sldImg" idx="2"/>
+          </p:nvPr>
+        </p:nvSpPr>
+        <p:spPr/>
+      </p:sp>
+      <p:sp>
+        <p:nvSpPr>
+          <p:cNvPr id="3" name="Notes Placeholder 2"/>
+          <p:cNvSpPr>
+            <a:spLocks noGrp="1"/>
+          </p:cNvSpPr>
+          <p:nvPr>
+            <p:ph type="body" idx="3" sz="quarter"/>
+          </p:nvPr>
+        </p:nvSpPr>
+        <p:spPr/>
+        <p:txBody>
+          <a:bodyPr/>
+          <a:lstStyle/>
+          <a:p>
+            <a:r>
+              <a:t>Este e o slide onde o painel deixa de descrever e passa a decidir.</a:t>
+            </a:r>
+          </a:p>
+          <a:p>
+            <a:r>
+              <a:t>O calculo: dias de permanencia consumidos no mes, divididos pelos dias do mes, da o numero medio de leitos ocupados. Divido isso pela taxa de ocupacao alvo — oitenta e cinco por cento — e tenho quantos leitos precisam estar abertos.</a:t>
+            </a:r>
+          </a:p>
+          <a:p>
+            <a:r>
+              <a:t>O mes de menor necessidade vira a demanda comum: o piso que a rede nao pode desmobilizar. O que passa disso e capacidade sazonal.</a:t>
+            </a:r>
+          </a:p>
+          <a:p>
+            <a:r>
+              <a:t>Belo Horizonte: piso de 5.107, pico em abril de 5.904, e so 408 leitos de folga. Seis por cento. O painel dispara o alerta sozinho.</a:t>
+            </a:r>
+          </a:p>
+        </p:txBody>
+      </p:sp>
+      <p:sp>
+        <p:nvSpPr>
+          <p:cNvPr id="4" name="Slide Number Placeholder 3"/>
+          <p:cNvSpPr>
+            <a:spLocks noGrp="1"/>
+          </p:cNvSpPr>
+          <p:nvPr>
+            <p:ph type="sldNum" idx="5" sz="quarter"/>
+          </p:nvPr>
+        </p:nvSpPr>
+        <p:spPr/>
+      </p:sp>
+    </p:spTree>
+  </p:cSld>
+  <p:clrMapOvr>
+    <a:masterClrMapping/>
+  </p:clrMapOvr>
+</p:notes>
+</file>
+
+<file path=ppt/notesSlides/notesSlide31.xml><?xml version="1.0" encoding="utf-8"?>
+<p:notes xmlns:a="http://schemas.openxmlformats.org/drawingml/2006/main" xmlns:p="http://schemas.openxmlformats.org/presentationml/2006/main" xmlns:r="http://schemas.openxmlformats.org/officeDocument/2006/relationships">
+  <p:cSld>
+    <p:spTree>
+      <p:nvGrpSpPr>
+        <p:cNvPr id="1" name=""/>
+        <p:cNvGrpSpPr/>
+        <p:nvPr/>
+      </p:nvGrpSpPr>
+      <p:grpSpPr>
+        <a:xfrm>
+          <a:off x="0" y="0"/>
+          <a:ext cx="0" cy="0"/>
+          <a:chOff x="0" y="0"/>
+          <a:chExt cx="0" cy="0"/>
+        </a:xfrm>
+      </p:grpSpPr>
+      <p:sp>
+        <p:nvSpPr>
+          <p:cNvPr id="2" name="Slide Image Placeholder 1"/>
+          <p:cNvSpPr>
+            <a:spLocks noGrp="1"/>
+          </p:cNvSpPr>
+          <p:nvPr>
+            <p:ph type="sldImg" idx="2"/>
+          </p:nvPr>
+        </p:nvSpPr>
+        <p:spPr/>
+      </p:sp>
+      <p:sp>
+        <p:nvSpPr>
+          <p:cNvPr id="3" name="Notes Placeholder 2"/>
+          <p:cNvSpPr>
+            <a:spLocks noGrp="1"/>
+          </p:cNvSpPr>
+          <p:nvPr>
+            <p:ph type="body" idx="3" sz="quarter"/>
+          </p:nvPr>
+        </p:nvSpPr>
+        <p:spPr/>
+        <p:txBody>
+          <a:bodyPr/>
+          <a:lstStyle/>
+          <a:p>
+            <a:r>
+              <a:t>Consultas de negocio rodando no Oracle, nao em parquet.</a:t>
+            </a:r>
+          </a:p>
+          <a:p>
+            <a:r>
+              <a:t>Este e o top dez de hospitais por volume, com a taxa de transferencia ao lado. A Santa Casa de BH tem cinquenta e quatro mil internacoes e transfere zero virgula dois por cento. E o perfil de quem resolve dentro de casa.</a:t>
+            </a:r>
+          </a:p>
+        </p:txBody>
+      </p:sp>
+      <p:sp>
+        <p:nvSpPr>
+          <p:cNvPr id="4" name="Slide Number Placeholder 3"/>
+          <p:cNvSpPr>
+            <a:spLocks noGrp="1"/>
+          </p:cNvSpPr>
+          <p:nvPr>
+            <p:ph type="sldNum" idx="5" sz="quarter"/>
+          </p:nvPr>
+        </p:nvSpPr>
+        <p:spPr/>
+      </p:sp>
+    </p:spTree>
+  </p:cSld>
+  <p:clrMapOvr>
+    <a:masterClrMapping/>
+  </p:clrMapOvr>
+</p:notes>
+</file>
+
+<file path=ppt/notesSlides/notesSlide32.xml><?xml version="1.0" encoding="utf-8"?>
+<p:notes xmlns:a="http://schemas.openxmlformats.org/drawingml/2006/main" xmlns:p="http://schemas.openxmlformats.org/presentationml/2006/main" xmlns:r="http://schemas.openxmlformats.org/officeDocument/2006/relationships">
+  <p:cSld>
+    <p:spTree>
+      <p:nvGrpSpPr>
+        <p:cNvPr id="1" name=""/>
+        <p:cNvGrpSpPr/>
+        <p:nvPr/>
+      </p:nvGrpSpPr>
+      <p:grpSpPr>
+        <a:xfrm>
+          <a:off x="0" y="0"/>
+          <a:ext cx="0" cy="0"/>
+          <a:chOff x="0" y="0"/>
+          <a:chExt cx="0" cy="0"/>
+        </a:xfrm>
+      </p:grpSpPr>
+      <p:sp>
+        <p:nvSpPr>
+          <p:cNvPr id="2" name="Slide Image Placeholder 1"/>
+          <p:cNvSpPr>
+            <a:spLocks noGrp="1"/>
+          </p:cNvSpPr>
+          <p:nvPr>
+            <p:ph type="sldImg" idx="2"/>
+          </p:nvPr>
+        </p:nvSpPr>
+        <p:spPr/>
+      </p:sp>
+      <p:sp>
+        <p:nvSpPr>
+          <p:cNvPr id="3" name="Notes Placeholder 2"/>
+          <p:cNvSpPr>
+            <a:spLocks noGrp="1"/>
+          </p:cNvSpPr>
+          <p:nvPr>
+            <p:ph type="body" idx="3" sz="quarter"/>
+          </p:nvPr>
+        </p:nvSpPr>
+        <p:spPr/>
+        <p:txBody>
+          <a:bodyPr/>
+          <a:lstStyle/>
+          <a:p>
+            <a:r>
+              <a:t>Onde as internacoes crescem: comparacao do segundo semestre contra o primeiro, por municipio.</a:t>
+            </a:r>
+          </a:p>
+          <a:p>
+            <a:r>
+              <a:t>Usei CTE com SUM condicional — soma quando o mes e menor ou igual a seis, soma quando e maior — e filtrei municipios com pelo menos quinhentas internacoes no primeiro semestre. Sem esse filtro, uma cidade que saiu de duas para dez internacoes apareceria com quatrocentos por cento de crescimento e lideraria o ranking.</a:t>
+            </a:r>
+          </a:p>
+        </p:txBody>
+      </p:sp>
+      <p:sp>
+        <p:nvSpPr>
+          <p:cNvPr id="4" name="Slide Number Placeholder 3"/>
+          <p:cNvSpPr>
+            <a:spLocks noGrp="1"/>
+          </p:cNvSpPr>
+          <p:nvPr>
+            <p:ph type="sldNum" idx="5" sz="quarter"/>
+          </p:nvPr>
+        </p:nvSpPr>
+        <p:spPr/>
+      </p:sp>
+    </p:spTree>
+  </p:cSld>
+  <p:clrMapOvr>
+    <a:masterClrMapping/>
+  </p:clrMapOvr>
+</p:notes>
+</file>
+
+<file path=ppt/notesSlides/notesSlide33.xml><?xml version="1.0" encoding="utf-8"?>
+<p:notes xmlns:a="http://schemas.openxmlformats.org/drawingml/2006/main" xmlns:p="http://schemas.openxmlformats.org/presentationml/2006/main" xmlns:r="http://schemas.openxmlformats.org/officeDocument/2006/relationships">
+  <p:cSld>
+    <p:spTree>
+      <p:nvGrpSpPr>
+        <p:cNvPr id="1" name=""/>
+        <p:cNvGrpSpPr/>
+        <p:nvPr/>
+      </p:nvGrpSpPr>
+      <p:grpSpPr>
+        <a:xfrm>
+          <a:off x="0" y="0"/>
+          <a:ext cx="0" cy="0"/>
+          <a:chOff x="0" y="0"/>
+          <a:chExt cx="0" cy="0"/>
+        </a:xfrm>
+      </p:grpSpPr>
+      <p:sp>
+        <p:nvSpPr>
+          <p:cNvPr id="2" name="Slide Image Placeholder 1"/>
+          <p:cNvSpPr>
+            <a:spLocks noGrp="1"/>
+          </p:cNvSpPr>
+          <p:nvPr>
+            <p:ph type="sldImg" idx="2"/>
+          </p:nvPr>
+        </p:nvSpPr>
+        <p:spPr/>
+      </p:sp>
+      <p:sp>
+        <p:nvSpPr>
+          <p:cNvPr id="3" name="Notes Placeholder 2"/>
+          <p:cNvSpPr>
+            <a:spLocks noGrp="1"/>
+          </p:cNvSpPr>
+          <p:nvPr>
+            <p:ph type="body" idx="3" sz="quarter"/>
+          </p:nvPr>
+        </p:nvSpPr>
+        <p:spPr/>
+        <p:txBody>
+          <a:bodyPr/>
+          <a:lstStyle/>
+          <a:p>
+            <a:r>
+              <a:t>Quem exporta paciente.</a:t>
+            </a:r>
+          </a:p>
+          <a:p>
+            <a:r>
+              <a:t>Embu-Guacu tem mil quatrocentas e sessenta internacoes, mil e oitenta e duas transferencias e quinze leitos. Setenta e quatro por cento dos pacientes seguem para outro municipio.</a:t>
+            </a:r>
+          </a:p>
+          <a:p>
+            <a:r>
+              <a:t>Esse numero so existe porque eu incluí a coluna COBRANCA, que nao estava na minha selecao inicial de vinte e quatro colunas. E antes de usar, validei o mapeamento: os codigos quarenta e um a quarenta e tres somaram exatamente o total da coluna MORTE. Confirmei o bloco de obito empiricamente, em vez de confiar na documentacao.</a:t>
+            </a:r>
+          </a:p>
+        </p:txBody>
+      </p:sp>
+      <p:sp>
+        <p:nvSpPr>
+          <p:cNvPr id="4" name="Slide Number Placeholder 3"/>
+          <p:cNvSpPr>
+            <a:spLocks noGrp="1"/>
+          </p:cNvSpPr>
+          <p:nvPr>
+            <p:ph type="sldNum" idx="5" sz="quarter"/>
+          </p:nvPr>
+        </p:nvSpPr>
+        <p:spPr/>
+      </p:sp>
+    </p:spTree>
+  </p:cSld>
+  <p:clrMapOvr>
+    <a:masterClrMapping/>
+  </p:clrMapOvr>
+</p:notes>
+</file>
+
+<file path=ppt/notesSlides/notesSlide34.xml><?xml version="1.0" encoding="utf-8"?>
+<p:notes xmlns:a="http://schemas.openxmlformats.org/drawingml/2006/main" xmlns:p="http://schemas.openxmlformats.org/presentationml/2006/main" xmlns:r="http://schemas.openxmlformats.org/officeDocument/2006/relationships">
+  <p:cSld>
+    <p:spTree>
+      <p:nvGrpSpPr>
+        <p:cNvPr id="1" name=""/>
+        <p:cNvGrpSpPr/>
+        <p:nvPr/>
+      </p:nvGrpSpPr>
+      <p:grpSpPr>
+        <a:xfrm>
+          <a:off x="0" y="0"/>
+          <a:ext cx="0" cy="0"/>
+          <a:chOff x="0" y="0"/>
+          <a:chExt cx="0" cy="0"/>
+        </a:xfrm>
+      </p:grpSpPr>
+      <p:sp>
+        <p:nvSpPr>
+          <p:cNvPr id="2" name="Slide Image Placeholder 1"/>
+          <p:cNvSpPr>
+            <a:spLocks noGrp="1"/>
+          </p:cNvSpPr>
+          <p:nvPr>
+            <p:ph type="sldImg" idx="2"/>
+          </p:nvPr>
+        </p:nvSpPr>
+        <p:spPr/>
+      </p:sp>
+      <p:sp>
+        <p:nvSpPr>
+          <p:cNvPr id="3" name="Notes Placeholder 2"/>
+          <p:cNvSpPr>
+            <a:spLocks noGrp="1"/>
+          </p:cNvSpPr>
+          <p:nvPr>
+            <p:ph type="body" idx="3" sz="quarter"/>
+          </p:nvPr>
+        </p:nvSpPr>
+        <p:spPr/>
+        <p:txBody>
+          <a:bodyPr/>
+          <a:lstStyle/>
+          <a:p>
+            <a:r>
+              <a:t>Esta parte nao era exigida. Entrou para responder o criterio de inovacao.</a:t>
+            </a:r>
+          </a:p>
+        </p:txBody>
+      </p:sp>
+      <p:sp>
+        <p:nvSpPr>
+          <p:cNvPr id="4" name="Slide Number Placeholder 3"/>
+          <p:cNvSpPr>
+            <a:spLocks noGrp="1"/>
+          </p:cNvSpPr>
+          <p:nvPr>
+            <p:ph type="sldNum" idx="5" sz="quarter"/>
+          </p:nvPr>
+        </p:nvSpPr>
+        <p:spPr/>
+      </p:sp>
+    </p:spTree>
+  </p:cSld>
+  <p:clrMapOvr>
+    <a:masterClrMapping/>
+  </p:clrMapOvr>
+</p:notes>
+</file>
+
+<file path=ppt/notesSlides/notesSlide35.xml><?xml version="1.0" encoding="utf-8"?>
+<p:notes xmlns:a="http://schemas.openxmlformats.org/drawingml/2006/main" xmlns:p="http://schemas.openxmlformats.org/presentationml/2006/main" xmlns:r="http://schemas.openxmlformats.org/officeDocument/2006/relationships">
+  <p:cSld>
+    <p:spTree>
+      <p:nvGrpSpPr>
+        <p:cNvPr id="1" name=""/>
+        <p:cNvGrpSpPr/>
+        <p:nvPr/>
+      </p:nvGrpSpPr>
+      <p:grpSpPr>
+        <a:xfrm>
+          <a:off x="0" y="0"/>
+          <a:ext cx="0" cy="0"/>
+          <a:chOff x="0" y="0"/>
+          <a:chExt cx="0" cy="0"/>
+        </a:xfrm>
+      </p:grpSpPr>
+      <p:sp>
+        <p:nvSpPr>
+          <p:cNvPr id="2" name="Slide Image Placeholder 1"/>
+          <p:cNvSpPr>
+            <a:spLocks noGrp="1"/>
+          </p:cNvSpPr>
+          <p:nvPr>
+            <p:ph type="sldImg" idx="2"/>
+          </p:nvPr>
+        </p:nvSpPr>
+        <p:spPr/>
+      </p:sp>
+      <p:sp>
+        <p:nvSpPr>
+          <p:cNvPr id="3" name="Notes Placeholder 2"/>
+          <p:cNvSpPr>
+            <a:spLocks noGrp="1"/>
+          </p:cNvSpPr>
+          <p:nvPr>
+            <p:ph type="body" idx="3" sz="quarter"/>
+          </p:nvPr>
+        </p:nvSpPr>
+        <p:spPr/>
+        <p:txBody>
+          <a:bodyPr/>
+          <a:lstStyle/>
+          <a:p>
+            <a:r>
+              <a:t>Uma quarta fonte publica: clima diario das quatro capitais, via Open-Meteo.</a:t>
+            </a:r>
+          </a:p>
+          <a:p>
+            <a:r>
+              <a:t>Recorte nas capitais porque clima e local: a media do estado misturaria o litoral capixaba com a serra mineira e apagaria qualquer sinal.</a:t>
+            </a:r>
+          </a:p>
+          <a:p>
+            <a:r>
+              <a:t>E as faixas de temperatura sao quartis calculados DENTRO de cada capital. Dezoito graus e frio em Vitoria e ameno em Sao Paulo — um limiar absoluto compararia climas diferentes como se fossem o mesmo.</a:t>
+            </a:r>
+          </a:p>
+        </p:txBody>
+      </p:sp>
+      <p:sp>
+        <p:nvSpPr>
+          <p:cNvPr id="4" name="Slide Number Placeholder 3"/>
+          <p:cNvSpPr>
+            <a:spLocks noGrp="1"/>
+          </p:cNvSpPr>
+          <p:nvPr>
+            <p:ph type="sldNum" idx="5" sz="quarter"/>
+          </p:nvPr>
+        </p:nvSpPr>
+        <p:spPr/>
+      </p:sp>
+    </p:spTree>
+  </p:cSld>
+  <p:clrMapOvr>
+    <a:masterClrMapping/>
+  </p:clrMapOvr>
+</p:notes>
+</file>
+
+<file path=ppt/notesSlides/notesSlide36.xml><?xml version="1.0" encoding="utf-8"?>
+<p:notes xmlns:a="http://schemas.openxmlformats.org/drawingml/2006/main" xmlns:p="http://schemas.openxmlformats.org/presentationml/2006/main" xmlns:r="http://schemas.openxmlformats.org/officeDocument/2006/relationships">
+  <p:cSld>
+    <p:spTree>
+      <p:nvGrpSpPr>
+        <p:cNvPr id="1" name=""/>
+        <p:cNvGrpSpPr/>
+        <p:nvPr/>
+      </p:nvGrpSpPr>
+      <p:grpSpPr>
+        <a:xfrm>
+          <a:off x="0" y="0"/>
+          <a:ext cx="0" cy="0"/>
+          <a:chOff x="0" y="0"/>
+          <a:chExt cx="0" cy="0"/>
+        </a:xfrm>
+      </p:grpSpPr>
+      <p:sp>
+        <p:nvSpPr>
+          <p:cNvPr id="2" name="Slide Image Placeholder 1"/>
+          <p:cNvSpPr>
+            <a:spLocks noGrp="1"/>
+          </p:cNvSpPr>
+          <p:nvPr>
+            <p:ph type="sldImg" idx="2"/>
+          </p:nvPr>
+        </p:nvSpPr>
+        <p:spPr/>
+      </p:sp>
+      <p:sp>
+        <p:nvSpPr>
+          <p:cNvPr id="3" name="Notes Placeholder 2"/>
+          <p:cNvSpPr>
+            <a:spLocks noGrp="1"/>
+          </p:cNvSpPr>
+          <p:nvPr>
+            <p:ph type="body" idx="3" sz="quarter"/>
+          </p:nvPr>
+        </p:nvSpPr>
+        <p:spPr/>
+        <p:txBody>
+          <a:bodyPr/>
+          <a:lstStyle/>
+          <a:p>
+            <a:r>
+              <a:t>Primeira hipotese: chuva aumenta internacao por acidente.</a:t>
+            </a:r>
+          </a:p>
+          <a:p>
+            <a:r>
+              <a:t>Refutada. Menos de um por cento de diferenca.</a:t>
+            </a:r>
+          </a:p>
+          <a:p>
+            <a:r>
+              <a:t>Mas o que sustenta a conclusao nao e a media: e o teste de gradiente. Se a chuva causasse acidentes, o efeito cresceria de chuva fraca para forte. Ele sobe e desce sem padrao, e o valor mais baixo vem de dezesseis dias apenas.</a:t>
+            </a:r>
+          </a:p>
+          <a:p>
+            <a:r>
+              <a:t>Resultado nulo bem medido tambem e resultado. A consequencia pratica: o planejamento hospitalar nao deve reservar capacidade para dia de chuva.</a:t>
+            </a:r>
+          </a:p>
+        </p:txBody>
+      </p:sp>
+      <p:sp>
+        <p:nvSpPr>
+          <p:cNvPr id="4" name="Slide Number Placeholder 3"/>
+          <p:cNvSpPr>
+            <a:spLocks noGrp="1"/>
+          </p:cNvSpPr>
+          <p:nvPr>
+            <p:ph type="sldNum" idx="5" sz="quarter"/>
+          </p:nvPr>
+        </p:nvSpPr>
+        <p:spPr/>
+      </p:sp>
+    </p:spTree>
+  </p:cSld>
+  <p:clrMapOvr>
+    <a:masterClrMapping/>
+  </p:clrMapOvr>
+</p:notes>
+</file>
+
+<file path=ppt/notesSlides/notesSlide37.xml><?xml version="1.0" encoding="utf-8"?>
+<p:notes xmlns:a="http://schemas.openxmlformats.org/drawingml/2006/main" xmlns:p="http://schemas.openxmlformats.org/presentationml/2006/main" xmlns:r="http://schemas.openxmlformats.org/officeDocument/2006/relationships">
+  <p:cSld>
+    <p:spTree>
+      <p:nvGrpSpPr>
+        <p:cNvPr id="1" name=""/>
+        <p:cNvGrpSpPr/>
+        <p:nvPr/>
+      </p:nvGrpSpPr>
+      <p:grpSpPr>
+        <a:xfrm>
+          <a:off x="0" y="0"/>
+          <a:ext cx="0" cy="0"/>
+          <a:chOff x="0" y="0"/>
+          <a:chExt cx="0" cy="0"/>
+        </a:xfrm>
+      </p:grpSpPr>
+      <p:sp>
+        <p:nvSpPr>
+          <p:cNvPr id="2" name="Slide Image Placeholder 1"/>
+          <p:cNvSpPr>
+            <a:spLocks noGrp="1"/>
+          </p:cNvSpPr>
+          <p:nvPr>
+            <p:ph type="sldImg" idx="2"/>
+          </p:nvPr>
+        </p:nvSpPr>
+        <p:spPr/>
+      </p:sp>
+      <p:sp>
+        <p:nvSpPr>
+          <p:cNvPr id="3" name="Notes Placeholder 2"/>
+          <p:cNvSpPr>
+            <a:spLocks noGrp="1"/>
+          </p:cNvSpPr>
+          <p:nvPr>
+            <p:ph type="body" idx="3" sz="quarter"/>
+          </p:nvPr>
+        </p:nvSpPr>
+        <p:spPr/>
+        <p:txBody>
+          <a:bodyPr/>
+          <a:lstStyle/>
+          <a:p>
+            <a:r>
+              <a:t>Segunda hipotese: frio aumenta internacao respiratoria.</a:t>
+            </a:r>
+          </a:p>
+          <a:p>
+            <a:r>
+              <a:t>Confirmada. Nove por cento, e com gradiente monotonico nas quatro capitais, cada uma calculada de forma independente. Quatro replicacoes do mesmo padrao e mais forte que um numero agregado.</a:t>
+            </a:r>
+          </a:p>
+        </p:txBody>
+      </p:sp>
+      <p:sp>
+        <p:nvSpPr>
+          <p:cNvPr id="4" name="Slide Number Placeholder 3"/>
+          <p:cNvSpPr>
+            <a:spLocks noGrp="1"/>
+          </p:cNvSpPr>
+          <p:nvPr>
+            <p:ph type="sldNum" idx="5" sz="quarter"/>
+          </p:nvPr>
+        </p:nvSpPr>
+        <p:spPr/>
+      </p:sp>
+    </p:spTree>
+  </p:cSld>
+  <p:clrMapOvr>
+    <a:masterClrMapping/>
+  </p:clrMapOvr>
+</p:notes>
+</file>
+
+<file path=ppt/notesSlides/notesSlide38.xml><?xml version="1.0" encoding="utf-8"?>
+<p:notes xmlns:a="http://schemas.openxmlformats.org/drawingml/2006/main" xmlns:p="http://schemas.openxmlformats.org/presentationml/2006/main" xmlns:r="http://schemas.openxmlformats.org/officeDocument/2006/relationships">
+  <p:cSld>
+    <p:spTree>
+      <p:nvGrpSpPr>
+        <p:cNvPr id="1" name=""/>
+        <p:cNvGrpSpPr/>
+        <p:nvPr/>
+      </p:nvGrpSpPr>
+      <p:grpSpPr>
+        <a:xfrm>
+          <a:off x="0" y="0"/>
+          <a:ext cx="0" cy="0"/>
+          <a:chOff x="0" y="0"/>
+          <a:chExt cx="0" cy="0"/>
+        </a:xfrm>
+      </p:grpSpPr>
+      <p:sp>
+        <p:nvSpPr>
+          <p:cNvPr id="2" name="Slide Image Placeholder 1"/>
+          <p:cNvSpPr>
+            <a:spLocks noGrp="1"/>
+          </p:cNvSpPr>
+          <p:nvPr>
+            <p:ph type="sldImg" idx="2"/>
+          </p:nvPr>
+        </p:nvSpPr>
+        <p:spPr/>
+      </p:sp>
+      <p:sp>
+        <p:nvSpPr>
+          <p:cNvPr id="3" name="Notes Placeholder 2"/>
+          <p:cNvSpPr>
+            <a:spLocks noGrp="1"/>
+          </p:cNvSpPr>
+          <p:nvPr>
+            <p:ph type="body" idx="3" sz="quarter"/>
+          </p:nvPr>
+        </p:nvSpPr>
+        <p:spPr/>
+        <p:txBody>
+          <a:bodyPr/>
+          <a:lstStyle/>
+          <a:p>
+            <a:r>
+              <a:t>E um detalhe que reforca: a temperatura MAXIMA nao tem correlacao nenhuma, ronda zero nas quatro cidades. Só a minima correlaciona.</a:t>
+            </a:r>
+          </a:p>
+          <a:p>
+            <a:r>
+              <a:t>E o frio da madrugada que se relaciona com internacao respiratoria, nao o calor do dia. Se fosse ruido, as duas variaveis se moveriam juntas.</a:t>
+            </a:r>
+          </a:p>
+        </p:txBody>
+      </p:sp>
+      <p:sp>
+        <p:nvSpPr>
+          <p:cNvPr id="4" name="Slide Number Placeholder 3"/>
+          <p:cNvSpPr>
+            <a:spLocks noGrp="1"/>
+          </p:cNvSpPr>
+          <p:nvPr>
+            <p:ph type="sldNum" idx="5" sz="quarter"/>
+          </p:nvPr>
+        </p:nvSpPr>
+        <p:spPr/>
+      </p:sp>
+    </p:spTree>
+  </p:cSld>
+  <p:clrMapOvr>
+    <a:masterClrMapping/>
+  </p:clrMapOvr>
+</p:notes>
+</file>
+
+<file path=ppt/notesSlides/notesSlide39.xml><?xml version="1.0" encoding="utf-8"?>
+<p:notes xmlns:a="http://schemas.openxmlformats.org/drawingml/2006/main" xmlns:p="http://schemas.openxmlformats.org/presentationml/2006/main" xmlns:r="http://schemas.openxmlformats.org/officeDocument/2006/relationships">
+  <p:cSld>
+    <p:spTree>
+      <p:nvGrpSpPr>
+        <p:cNvPr id="1" name=""/>
+        <p:cNvGrpSpPr/>
+        <p:nvPr/>
+      </p:nvGrpSpPr>
+      <p:grpSpPr>
+        <a:xfrm>
+          <a:off x="0" y="0"/>
+          <a:ext cx="0" cy="0"/>
+          <a:chOff x="0" y="0"/>
+          <a:chExt cx="0" cy="0"/>
+        </a:xfrm>
+      </p:grpSpPr>
+      <p:sp>
+        <p:nvSpPr>
+          <p:cNvPr id="2" name="Slide Image Placeholder 1"/>
+          <p:cNvSpPr>
+            <a:spLocks noGrp="1"/>
+          </p:cNvSpPr>
+          <p:nvPr>
+            <p:ph type="sldImg" idx="2"/>
+          </p:nvPr>
+        </p:nvSpPr>
+        <p:spPr/>
+      </p:sp>
+      <p:sp>
+        <p:nvSpPr>
+          <p:cNvPr id="3" name="Notes Placeholder 2"/>
+          <p:cNvSpPr>
+            <a:spLocks noGrp="1"/>
+          </p:cNvSpPr>
+          <p:nvPr>
+            <p:ph type="body" idx="3" sz="quarter"/>
+          </p:nvPr>
+        </p:nvSpPr>
+        <p:spPr/>
+        <p:txBody>
+          <a:bodyPr/>
+          <a:lstStyle/>
+          <a:p>
+            <a:r>
+              <a:t>E aqui eu declaro o limite da propria analise.</a:t>
+            </a:r>
+          </a:p>
+          <a:p>
+            <a:r>
+              <a:t>A chuva aparece com correlacao negativa: dia chuvoso tem MENOS internacao respiratoria. Contraintuitivo, ate lembrar que no Sudeste chove no verao e a seca e no inverno. A chuva esta medindo a estacao, nao a si mesma.</a:t>
+            </a:r>
+          </a:p>
+          <a:p>
+            <a:r>
+              <a:t>O mesmo confundimento pode valer para o frio. Os nove por cento podem ser efeito da temperatura, da sazonalidade viral, ou dos dois. E associacao, nao causa.</a:t>
+            </a:r>
+          </a:p>
+          <a:p>
+            <a:r>
+              <a:t>Separar exigiria dado de circulacao viral por semana epidemiologica. Esta registrado como proximo passo.</a:t>
+            </a:r>
+          </a:p>
+        </p:txBody>
+      </p:sp>
+      <p:sp>
+        <p:nvSpPr>
+          <p:cNvPr id="4" name="Slide Number Placeholder 3"/>
+          <p:cNvSpPr>
+            <a:spLocks noGrp="1"/>
+          </p:cNvSpPr>
+          <p:nvPr>
+            <p:ph type="sldNum" idx="5" sz="quarter"/>
+          </p:nvPr>
+        </p:nvSpPr>
+        <p:spPr/>
+      </p:sp>
+    </p:spTree>
+  </p:cSld>
+  <p:clrMapOvr>
+    <a:masterClrMapping/>
+  </p:clrMapOvr>
+</p:notes>
+</file>
+
+<file path=ppt/notesSlides/notesSlide4.xml><?xml version="1.0" encoding="utf-8"?>
+<p:notes xmlns:a="http://schemas.openxmlformats.org/drawingml/2006/main" xmlns:p="http://schemas.openxmlformats.org/presentationml/2006/main" xmlns:r="http://schemas.openxmlformats.org/officeDocument/2006/relationships">
+  <p:cSld>
+    <p:spTree>
+      <p:nvGrpSpPr>
+        <p:cNvPr id="1" name=""/>
+        <p:cNvGrpSpPr/>
+        <p:nvPr/>
+      </p:nvGrpSpPr>
+      <p:grpSpPr>
+        <a:xfrm>
+          <a:off x="0" y="0"/>
+          <a:ext cx="0" cy="0"/>
+          <a:chOff x="0" y="0"/>
+          <a:chExt cx="0" cy="0"/>
+        </a:xfrm>
+      </p:grpSpPr>
+      <p:sp>
+        <p:nvSpPr>
+          <p:cNvPr id="2" name="Slide Image Placeholder 1"/>
+          <p:cNvSpPr>
+            <a:spLocks noGrp="1"/>
+          </p:cNvSpPr>
+          <p:nvPr>
+            <p:ph type="sldImg" idx="2"/>
+          </p:nvPr>
+        </p:nvSpPr>
+        <p:spPr/>
+      </p:sp>
+      <p:sp>
+        <p:nvSpPr>
+          <p:cNvPr id="3" name="Notes Placeholder 2"/>
+          <p:cNvSpPr>
+            <a:spLocks noGrp="1"/>
+          </p:cNvSpPr>
+          <p:nvPr>
+            <p:ph type="body" idx="3" sz="quarter"/>
+          </p:nvPr>
+        </p:nvSpPr>
+        <p:spPr/>
+        <p:txBody>
+          <a:bodyPr/>
+          <a:lstStyle/>
+          <a:p>
+            <a:r>
+              <a:t>Esses numeros sao o resultado da camada Ouro ja carregada no Oracle.</a:t>
+            </a:r>
+          </a:p>
+          <a:p>
+            <a:r>
+              <a:t>Cinco milhoes e meio de internacoes e o numero DEPOIS do tratamento. O bruto que baixei do DATASUS foi sete milhoes. A diferenca de um milhao e meio nao e perda: sao internacoes de 2023 e de 2025 que vieram junto, porque o SIH publica por mes de pagamento, nao por mes de internacao. Volto nesse ponto, porque foi ele que reorientou o projeto.</a:t>
+            </a:r>
+          </a:p>
+          <a:p>
+            <a:r>
+              <a:t>A consulta que gera esta tela e um SELECT com SUM de internacoes, SUM de dias_permanencia e SUM de valor_total sobre a tabela fato, agrupando nada: e o total geral.</a:t>
+            </a:r>
+          </a:p>
+        </p:txBody>
+      </p:sp>
+      <p:sp>
+        <p:nvSpPr>
+          <p:cNvPr id="4" name="Slide Number Placeholder 3"/>
+          <p:cNvSpPr>
+            <a:spLocks noGrp="1"/>
+          </p:cNvSpPr>
+          <p:nvPr>
+            <p:ph type="sldNum" idx="5" sz="quarter"/>
+          </p:nvPr>
+        </p:nvSpPr>
+        <p:spPr/>
+      </p:sp>
+    </p:spTree>
+  </p:cSld>
+  <p:clrMapOvr>
+    <a:masterClrMapping/>
+  </p:clrMapOvr>
+</p:notes>
+</file>
+
+<file path=ppt/notesSlides/notesSlide40.xml><?xml version="1.0" encoding="utf-8"?>
+<p:notes xmlns:a="http://schemas.openxmlformats.org/drawingml/2006/main" xmlns:p="http://schemas.openxmlformats.org/presentationml/2006/main" xmlns:r="http://schemas.openxmlformats.org/officeDocument/2006/relationships">
+  <p:cSld>
+    <p:spTree>
+      <p:nvGrpSpPr>
+        <p:cNvPr id="1" name=""/>
+        <p:cNvGrpSpPr/>
+        <p:nvPr/>
+      </p:nvGrpSpPr>
+      <p:grpSpPr>
+        <a:xfrm>
+          <a:off x="0" y="0"/>
+          <a:ext cx="0" cy="0"/>
+          <a:chOff x="0" y="0"/>
+          <a:chExt cx="0" cy="0"/>
+        </a:xfrm>
+      </p:grpSpPr>
+      <p:sp>
+        <p:nvSpPr>
+          <p:cNvPr id="2" name="Slide Image Placeholder 1"/>
+          <p:cNvSpPr>
+            <a:spLocks noGrp="1"/>
+          </p:cNvSpPr>
+          <p:nvPr>
+            <p:ph type="sldImg" idx="2"/>
+          </p:nvPr>
+        </p:nvSpPr>
+        <p:spPr/>
+      </p:sp>
+      <p:sp>
+        <p:nvSpPr>
+          <p:cNvPr id="3" name="Notes Placeholder 2"/>
+          <p:cNvSpPr>
+            <a:spLocks noGrp="1"/>
+          </p:cNvSpPr>
+          <p:nvPr>
+            <p:ph type="body" idx="3" sz="quarter"/>
+          </p:nvPr>
+        </p:nvSpPr>
+        <p:spPr/>
+        <p:txBody>
+          <a:bodyPr/>
+          <a:lstStyle/>
+          <a:p>
+            <a:r>
+              <a:t>A parte de linguagem natural do desafio.</a:t>
+            </a:r>
+          </a:p>
+        </p:txBody>
+      </p:sp>
+      <p:sp>
+        <p:nvSpPr>
+          <p:cNvPr id="4" name="Slide Number Placeholder 3"/>
+          <p:cNvSpPr>
+            <a:spLocks noGrp="1"/>
+          </p:cNvSpPr>
+          <p:nvPr>
+            <p:ph type="sldNum" idx="5" sz="quarter"/>
+          </p:nvPr>
+        </p:nvSpPr>
+        <p:spPr/>
+      </p:sp>
+    </p:spTree>
+  </p:cSld>
+  <p:clrMapOvr>
+    <a:masterClrMapping/>
+  </p:clrMapOvr>
+</p:notes>
+</file>
+
+<file path=ppt/notesSlides/notesSlide41.xml><?xml version="1.0" encoding="utf-8"?>
+<p:notes xmlns:a="http://schemas.openxmlformats.org/drawingml/2006/main" xmlns:p="http://schemas.openxmlformats.org/presentationml/2006/main" xmlns:r="http://schemas.openxmlformats.org/officeDocument/2006/relationships">
+  <p:cSld>
+    <p:spTree>
+      <p:nvGrpSpPr>
+        <p:cNvPr id="1" name=""/>
+        <p:cNvGrpSpPr/>
+        <p:nvPr/>
+      </p:nvGrpSpPr>
+      <p:grpSpPr>
+        <a:xfrm>
+          <a:off x="0" y="0"/>
+          <a:ext cx="0" cy="0"/>
+          <a:chOff x="0" y="0"/>
+          <a:chExt cx="0" cy="0"/>
+        </a:xfrm>
+      </p:grpSpPr>
+      <p:sp>
+        <p:nvSpPr>
+          <p:cNvPr id="2" name="Slide Image Placeholder 1"/>
+          <p:cNvSpPr>
+            <a:spLocks noGrp="1"/>
+          </p:cNvSpPr>
+          <p:nvPr>
+            <p:ph type="sldImg" idx="2"/>
+          </p:nvPr>
+        </p:nvSpPr>
+        <p:spPr/>
+      </p:sp>
+      <p:sp>
+        <p:nvSpPr>
+          <p:cNvPr id="3" name="Notes Placeholder 2"/>
+          <p:cNvSpPr>
+            <a:spLocks noGrp="1"/>
+          </p:cNvSpPr>
+          <p:nvPr>
+            <p:ph type="body" idx="3" sz="quarter"/>
+          </p:nvPr>
+        </p:nvSpPr>
+        <p:spPr/>
+        <p:txBody>
+          <a:bodyPr/>
+          <a:lstStyle/>
+          <a:p>
+            <a:r>
+              <a:t>A pagina "Pergunte em portugues". Oito exemplos, e campo livre.</a:t>
+            </a:r>
+          </a:p>
+        </p:txBody>
+      </p:sp>
+      <p:sp>
+        <p:nvSpPr>
+          <p:cNvPr id="4" name="Slide Number Placeholder 3"/>
+          <p:cNvSpPr>
+            <a:spLocks noGrp="1"/>
+          </p:cNvSpPr>
+          <p:nvPr>
+            <p:ph type="sldNum" idx="5" sz="quarter"/>
+          </p:nvPr>
+        </p:nvSpPr>
+        <p:spPr/>
+      </p:sp>
+    </p:spTree>
+  </p:cSld>
+  <p:clrMapOvr>
+    <a:masterClrMapping/>
+  </p:clrMapOvr>
+</p:notes>
+</file>
+
+<file path=ppt/notesSlides/notesSlide42.xml><?xml version="1.0" encoding="utf-8"?>
+<p:notes xmlns:a="http://schemas.openxmlformats.org/drawingml/2006/main" xmlns:p="http://schemas.openxmlformats.org/presentationml/2006/main" xmlns:r="http://schemas.openxmlformats.org/officeDocument/2006/relationships">
+  <p:cSld>
+    <p:spTree>
+      <p:nvGrpSpPr>
+        <p:cNvPr id="1" name=""/>
+        <p:cNvGrpSpPr/>
+        <p:nvPr/>
+      </p:nvGrpSpPr>
+      <p:grpSpPr>
+        <a:xfrm>
+          <a:off x="0" y="0"/>
+          <a:ext cx="0" cy="0"/>
+          <a:chOff x="0" y="0"/>
+          <a:chExt cx="0" cy="0"/>
+        </a:xfrm>
+      </p:grpSpPr>
+      <p:sp>
+        <p:nvSpPr>
+          <p:cNvPr id="2" name="Slide Image Placeholder 1"/>
+          <p:cNvSpPr>
+            <a:spLocks noGrp="1"/>
+          </p:cNvSpPr>
+          <p:nvPr>
+            <p:ph type="sldImg" idx="2"/>
+          </p:nvPr>
+        </p:nvSpPr>
+        <p:spPr/>
+      </p:sp>
+      <p:sp>
+        <p:nvSpPr>
+          <p:cNvPr id="3" name="Notes Placeholder 2"/>
+          <p:cNvSpPr>
+            <a:spLocks noGrp="1"/>
+          </p:cNvSpPr>
+          <p:nvPr>
+            <p:ph type="body" idx="3" sz="quarter"/>
+          </p:nvPr>
+        </p:nvSpPr>
+        <p:spPr/>
+        <p:txBody>
+          <a:bodyPr/>
+          <a:lstStyle/>
+          <a:p>
+            <a:r>
+              <a:t>Duas perguntas diferentes gerando SQL sobre tabelas diferentes.</a:t>
+            </a:r>
+          </a:p>
+          <a:p>
+            <a:r>
+              <a:t>O tradutor pontua a pergunta contra um vocabulario de radicais com peso, escolhe a intencao de maior pontuacao, extrai as entidades — estado, mes, quantidade — e monta o SQL a partir de um modelo parametrizado.</a:t>
+            </a:r>
+          </a:p>
+          <a:p>
+            <a:r>
+              <a:t>E ele MOSTRA o SQL antes de executar. Isso e deliberado: num painel de saude publica, quem decide precisa poder conferir de onde veio o numero.</a:t>
+            </a:r>
+          </a:p>
+        </p:txBody>
+      </p:sp>
+      <p:sp>
+        <p:nvSpPr>
+          <p:cNvPr id="4" name="Slide Number Placeholder 3"/>
+          <p:cNvSpPr>
+            <a:spLocks noGrp="1"/>
+          </p:cNvSpPr>
+          <p:nvPr>
+            <p:ph type="sldNum" idx="5" sz="quarter"/>
+          </p:nvPr>
+        </p:nvSpPr>
+        <p:spPr/>
+      </p:sp>
+    </p:spTree>
+  </p:cSld>
+  <p:clrMapOvr>
+    <a:masterClrMapping/>
+  </p:clrMapOvr>
+</p:notes>
+</file>
+
+<file path=ppt/notesSlides/notesSlide43.xml><?xml version="1.0" encoding="utf-8"?>
+<p:notes xmlns:a="http://schemas.openxmlformats.org/drawingml/2006/main" xmlns:p="http://schemas.openxmlformats.org/presentationml/2006/main" xmlns:r="http://schemas.openxmlformats.org/officeDocument/2006/relationships">
+  <p:cSld>
+    <p:spTree>
+      <p:nvGrpSpPr>
+        <p:cNvPr id="1" name=""/>
+        <p:cNvGrpSpPr/>
+        <p:nvPr/>
+      </p:nvGrpSpPr>
+      <p:grpSpPr>
+        <a:xfrm>
+          <a:off x="0" y="0"/>
+          <a:ext cx="0" cy="0"/>
+          <a:chOff x="0" y="0"/>
+          <a:chExt cx="0" cy="0"/>
+        </a:xfrm>
+      </p:grpSpPr>
+      <p:sp>
+        <p:nvSpPr>
+          <p:cNvPr id="2" name="Slide Image Placeholder 1"/>
+          <p:cNvSpPr>
+            <a:spLocks noGrp="1"/>
+          </p:cNvSpPr>
+          <p:nvPr>
+            <p:ph type="sldImg" idx="2"/>
+          </p:nvPr>
+        </p:nvSpPr>
+        <p:spPr/>
+      </p:sp>
+      <p:sp>
+        <p:nvSpPr>
+          <p:cNvPr id="3" name="Notes Placeholder 2"/>
+          <p:cNvSpPr>
+            <a:spLocks noGrp="1"/>
+          </p:cNvSpPr>
+          <p:nvPr>
+            <p:ph type="body" idx="3" sz="quarter"/>
+          </p:nvPr>
+        </p:nvSpPr>
+        <p:spPr/>
+        <p:txBody>
+          <a:bodyPr/>
+          <a:lstStyle/>
+          <a:p>
+            <a:r>
+              <a:t>Por que nao e o Select AI nativo.</a:t>
+            </a:r>
+          </a:p>
+          <a:p>
+            <a:r>
+              <a:t>Eu consultei o all_objects procurando o DBMS_CLOUD_AI. Retornou zero. O Select AI so existe no Autonomous Database, e a instancia academica da FIAP e uma 19c Enterprise.</a:t>
+            </a:r>
+          </a:p>
+          <a:p>
+            <a:r>
+              <a:t>Entao implementei o equivalente sobre exatamente os mesmos metadados: os COMMENT ON das tabelas. Eu escrevi esses comentarios em linguagem de negocio de proposito, desde o DDL, sabendo que seriam o dicionario do tradutor.</a:t>
+            </a:r>
+          </a:p>
+          <a:p>
+            <a:r>
+              <a:t>Migrar para o Autonomous nao exige remodelar nada. O script ja esta entregue.</a:t>
+            </a:r>
+          </a:p>
+        </p:txBody>
+      </p:sp>
+      <p:sp>
+        <p:nvSpPr>
+          <p:cNvPr id="4" name="Slide Number Placeholder 3"/>
+          <p:cNvSpPr>
+            <a:spLocks noGrp="1"/>
+          </p:cNvSpPr>
+          <p:nvPr>
+            <p:ph type="sldNum" idx="5" sz="quarter"/>
+          </p:nvPr>
+        </p:nvSpPr>
+        <p:spPr/>
+      </p:sp>
+    </p:spTree>
+  </p:cSld>
+  <p:clrMapOvr>
+    <a:masterClrMapping/>
+  </p:clrMapOvr>
+</p:notes>
+</file>
+
+<file path=ppt/notesSlides/notesSlide44.xml><?xml version="1.0" encoding="utf-8"?>
+<p:notes xmlns:a="http://schemas.openxmlformats.org/drawingml/2006/main" xmlns:p="http://schemas.openxmlformats.org/presentationml/2006/main" xmlns:r="http://schemas.openxmlformats.org/officeDocument/2006/relationships">
+  <p:cSld>
+    <p:spTree>
+      <p:nvGrpSpPr>
+        <p:cNvPr id="1" name=""/>
+        <p:cNvGrpSpPr/>
+        <p:nvPr/>
+      </p:nvGrpSpPr>
+      <p:grpSpPr>
+        <a:xfrm>
+          <a:off x="0" y="0"/>
+          <a:ext cx="0" cy="0"/>
+          <a:chOff x="0" y="0"/>
+          <a:chExt cx="0" cy="0"/>
+        </a:xfrm>
+      </p:grpSpPr>
+      <p:sp>
+        <p:nvSpPr>
+          <p:cNvPr id="2" name="Slide Image Placeholder 1"/>
+          <p:cNvSpPr>
+            <a:spLocks noGrp="1"/>
+          </p:cNvSpPr>
+          <p:nvPr>
+            <p:ph type="sldImg" idx="2"/>
+          </p:nvPr>
+        </p:nvSpPr>
+        <p:spPr/>
+      </p:sp>
+      <p:sp>
+        <p:nvSpPr>
+          <p:cNvPr id="3" name="Notes Placeholder 2"/>
+          <p:cNvSpPr>
+            <a:spLocks noGrp="1"/>
+          </p:cNvSpPr>
+          <p:nvPr>
+            <p:ph type="body" idx="3" sz="quarter"/>
+          </p:nvPr>
+        </p:nvSpPr>
+        <p:spPr/>
+        <p:txBody>
+          <a:bodyPr/>
+          <a:lstStyle/>
+          <a:p>
+            <a:r>
+              <a:t>Fechamento: repositorio, video e conclusoes.</a:t>
+            </a:r>
+          </a:p>
+        </p:txBody>
+      </p:sp>
+      <p:sp>
+        <p:nvSpPr>
+          <p:cNvPr id="4" name="Slide Number Placeholder 3"/>
+          <p:cNvSpPr>
+            <a:spLocks noGrp="1"/>
+          </p:cNvSpPr>
+          <p:nvPr>
+            <p:ph type="sldNum" idx="5" sz="quarter"/>
+          </p:nvPr>
+        </p:nvSpPr>
+        <p:spPr/>
+      </p:sp>
+    </p:spTree>
+  </p:cSld>
+  <p:clrMapOvr>
+    <a:masterClrMapping/>
+  </p:clrMapOvr>
+</p:notes>
+</file>
+
+<file path=ppt/notesSlides/notesSlide45.xml><?xml version="1.0" encoding="utf-8"?>
+<p:notes xmlns:a="http://schemas.openxmlformats.org/drawingml/2006/main" xmlns:p="http://schemas.openxmlformats.org/presentationml/2006/main" xmlns:r="http://schemas.openxmlformats.org/officeDocument/2006/relationships">
+  <p:cSld>
+    <p:spTree>
+      <p:nvGrpSpPr>
+        <p:cNvPr id="1" name=""/>
+        <p:cNvGrpSpPr/>
+        <p:nvPr/>
+      </p:nvGrpSpPr>
+      <p:grpSpPr>
+        <a:xfrm>
+          <a:off x="0" y="0"/>
+          <a:ext cx="0" cy="0"/>
+          <a:chOff x="0" y="0"/>
+          <a:chExt cx="0" cy="0"/>
+        </a:xfrm>
+      </p:grpSpPr>
+      <p:sp>
+        <p:nvSpPr>
+          <p:cNvPr id="2" name="Slide Image Placeholder 1"/>
+          <p:cNvSpPr>
+            <a:spLocks noGrp="1"/>
+          </p:cNvSpPr>
+          <p:nvPr>
+            <p:ph type="sldImg" idx="2"/>
+          </p:nvPr>
+        </p:nvSpPr>
+        <p:spPr/>
+      </p:sp>
+      <p:sp>
+        <p:nvSpPr>
+          <p:cNvPr id="3" name="Notes Placeholder 2"/>
+          <p:cNvSpPr>
+            <a:spLocks noGrp="1"/>
+          </p:cNvSpPr>
+          <p:nvPr>
+            <p:ph type="body" idx="3" sz="quarter"/>
+          </p:nvPr>
+        </p:nvSpPr>
+        <p:spPr/>
+        <p:txBody>
+          <a:bodyPr/>
+          <a:lstStyle/>
+          <a:p>
+            <a:r>
+              <a:t>O codigo esta todo publico no GitHub. Notebooks, pipeline de ingestao, DDL, tradutor e painel.</a:t>
+            </a:r>
+          </a:p>
+          <a:p>
+            <a:r>
+              <a:t>E a camada Ouro esta versionada junto — cerca de seis mega de parquet. Isso permite que qualquer pessoa reproduza o painel sem ter acesso ao Oracle da FIAP.</a:t>
+            </a:r>
+          </a:p>
+        </p:txBody>
+      </p:sp>
+      <p:sp>
+        <p:nvSpPr>
+          <p:cNvPr id="4" name="Slide Number Placeholder 3"/>
+          <p:cNvSpPr>
+            <a:spLocks noGrp="1"/>
+          </p:cNvSpPr>
+          <p:nvPr>
+            <p:ph type="sldNum" idx="5" sz="quarter"/>
+          </p:nvPr>
+        </p:nvSpPr>
+        <p:spPr/>
+      </p:sp>
+    </p:spTree>
+  </p:cSld>
+  <p:clrMapOvr>
+    <a:masterClrMapping/>
+  </p:clrMapOvr>
+</p:notes>
+</file>
+
+<file path=ppt/notesSlides/notesSlide46.xml><?xml version="1.0" encoding="utf-8"?>
+<p:notes xmlns:a="http://schemas.openxmlformats.org/drawingml/2006/main" xmlns:p="http://schemas.openxmlformats.org/presentationml/2006/main" xmlns:r="http://schemas.openxmlformats.org/officeDocument/2006/relationships">
+  <p:cSld>
+    <p:spTree>
+      <p:nvGrpSpPr>
+        <p:cNvPr id="1" name=""/>
+        <p:cNvGrpSpPr/>
+        <p:nvPr/>
+      </p:nvGrpSpPr>
+      <p:grpSpPr>
+        <a:xfrm>
+          <a:off x="0" y="0"/>
+          <a:ext cx="0" cy="0"/>
+          <a:chOff x="0" y="0"/>
+          <a:chExt cx="0" cy="0"/>
+        </a:xfrm>
+      </p:grpSpPr>
+      <p:sp>
+        <p:nvSpPr>
+          <p:cNvPr id="2" name="Slide Image Placeholder 1"/>
+          <p:cNvSpPr>
+            <a:spLocks noGrp="1"/>
+          </p:cNvSpPr>
+          <p:nvPr>
+            <p:ph type="sldImg" idx="2"/>
+          </p:nvPr>
+        </p:nvSpPr>
+        <p:spPr/>
+      </p:sp>
+      <p:sp>
+        <p:nvSpPr>
+          <p:cNvPr id="3" name="Notes Placeholder 2"/>
+          <p:cNvSpPr>
+            <a:spLocks noGrp="1"/>
+          </p:cNvSpPr>
+          <p:nvPr>
+            <p:ph type="body" idx="3" sz="quarter"/>
+          </p:nvPr>
+        </p:nvSpPr>
+        <p:spPr/>
+        <p:txBody>
+          <a:bodyPr/>
+          <a:lstStyle/>
+          <a:p>
+            <a:r>
+              <a:t>O video de cinco minutos com a demonstracao ao vivo.</a:t>
+            </a:r>
+          </a:p>
+        </p:txBody>
+      </p:sp>
+      <p:sp>
+        <p:nvSpPr>
+          <p:cNvPr id="4" name="Slide Number Placeholder 3"/>
+          <p:cNvSpPr>
+            <a:spLocks noGrp="1"/>
+          </p:cNvSpPr>
+          <p:nvPr>
+            <p:ph type="sldNum" idx="5" sz="quarter"/>
+          </p:nvPr>
+        </p:nvSpPr>
+        <p:spPr/>
+      </p:sp>
+    </p:spTree>
+  </p:cSld>
+  <p:clrMapOvr>
+    <a:masterClrMapping/>
+  </p:clrMapOvr>
+</p:notes>
+</file>
+
+<file path=ppt/notesSlides/notesSlide47.xml><?xml version="1.0" encoding="utf-8"?>
+<p:notes xmlns:a="http://schemas.openxmlformats.org/drawingml/2006/main" xmlns:p="http://schemas.openxmlformats.org/presentationml/2006/main" xmlns:r="http://schemas.openxmlformats.org/officeDocument/2006/relationships">
+  <p:cSld>
+    <p:spTree>
+      <p:nvGrpSpPr>
+        <p:cNvPr id="1" name=""/>
+        <p:cNvGrpSpPr/>
+        <p:nvPr/>
+      </p:nvGrpSpPr>
+      <p:grpSpPr>
+        <a:xfrm>
+          <a:off x="0" y="0"/>
+          <a:ext cx="0" cy="0"/>
+          <a:chOff x="0" y="0"/>
+          <a:chExt cx="0" cy="0"/>
+        </a:xfrm>
+      </p:grpSpPr>
+      <p:sp>
+        <p:nvSpPr>
+          <p:cNvPr id="2" name="Slide Image Placeholder 1"/>
+          <p:cNvSpPr>
+            <a:spLocks noGrp="1"/>
+          </p:cNvSpPr>
+          <p:nvPr>
+            <p:ph type="sldImg" idx="2"/>
+          </p:nvPr>
+        </p:nvSpPr>
+        <p:spPr/>
+      </p:sp>
+      <p:sp>
+        <p:nvSpPr>
+          <p:cNvPr id="3" name="Notes Placeholder 2"/>
+          <p:cNvSpPr>
+            <a:spLocks noGrp="1"/>
+          </p:cNvSpPr>
+          <p:nvPr>
+            <p:ph type="body" idx="3" sz="quarter"/>
+          </p:nvPr>
+        </p:nvSpPr>
+        <p:spPr/>
+        <p:txBody>
+          <a:bodyPr/>
+          <a:lstStyle/>
+          <a:p>
+            <a:r>
+              <a:t>Tres coisas que os dados me ensinaram, e que eu nao sabia quando comecei.</a:t>
+            </a:r>
+          </a:p>
+          <a:p>
+            <a:r>
+              <a:t>A primeira mudou a dimensao temporal do projeto inteiro. A segunda mudou a pergunta que o painel responde. A terceira me fez descartar o modelo mais sofisticado em favor do mais simples.</a:t>
+            </a:r>
+          </a:p>
+          <a:p>
+            <a:r>
+              <a:t>Nenhuma das tres estava no plano da Sprint 1.</a:t>
+            </a:r>
+          </a:p>
+        </p:txBody>
+      </p:sp>
+      <p:sp>
+        <p:nvSpPr>
+          <p:cNvPr id="4" name="Slide Number Placeholder 3"/>
+          <p:cNvSpPr>
+            <a:spLocks noGrp="1"/>
+          </p:cNvSpPr>
+          <p:nvPr>
+            <p:ph type="sldNum" idx="5" sz="quarter"/>
+          </p:nvPr>
+        </p:nvSpPr>
+        <p:spPr/>
+      </p:sp>
+    </p:spTree>
+  </p:cSld>
+  <p:clrMapOvr>
+    <a:masterClrMapping/>
+  </p:clrMapOvr>
+</p:notes>
+</file>
+
+<file path=ppt/notesSlides/notesSlide48.xml><?xml version="1.0" encoding="utf-8"?>
+<p:notes xmlns:a="http://schemas.openxmlformats.org/drawingml/2006/main" xmlns:p="http://schemas.openxmlformats.org/presentationml/2006/main" xmlns:r="http://schemas.openxmlformats.org/officeDocument/2006/relationships">
+  <p:cSld>
+    <p:spTree>
+      <p:nvGrpSpPr>
+        <p:cNvPr id="1" name=""/>
+        <p:cNvGrpSpPr/>
+        <p:nvPr/>
+      </p:nvGrpSpPr>
+      <p:grpSpPr>
+        <a:xfrm>
+          <a:off x="0" y="0"/>
+          <a:ext cx="0" cy="0"/>
+          <a:chOff x="0" y="0"/>
+          <a:chExt cx="0" cy="0"/>
+        </a:xfrm>
+      </p:grpSpPr>
+      <p:sp>
+        <p:nvSpPr>
+          <p:cNvPr id="2" name="Slide Image Placeholder 1"/>
+          <p:cNvSpPr>
+            <a:spLocks noGrp="1"/>
+          </p:cNvSpPr>
+          <p:nvPr>
+            <p:ph type="sldImg" idx="2"/>
+          </p:nvPr>
+        </p:nvSpPr>
+        <p:spPr/>
+      </p:sp>
+      <p:sp>
+        <p:nvSpPr>
+          <p:cNvPr id="3" name="Notes Placeholder 2"/>
+          <p:cNvSpPr>
+            <a:spLocks noGrp="1"/>
+          </p:cNvSpPr>
+          <p:nvPr>
+            <p:ph type="body" idx="3" sz="quarter"/>
+          </p:nvPr>
+        </p:nvSpPr>
+        <p:spPr/>
+        <p:txBody>
+          <a:bodyPr/>
+          <a:lstStyle/>
+          <a:p>
+            <a:r>
+              <a:t>E o que este painel NAO pode afirmar.</a:t>
+            </a:r>
+          </a:p>
+          <a:p>
+            <a:r>
+              <a:t>Declarar limite nao enfraquece o trabalho: e o que separa analise de opiniao com grafico. Cada um desses itens eu medi antes de declarar — inclusive o menos de um por cento dos leitos-dia de pacientes internados antes de 2024.</a:t>
+            </a:r>
+          </a:p>
+        </p:txBody>
+      </p:sp>
+      <p:sp>
+        <p:nvSpPr>
+          <p:cNvPr id="4" name="Slide Number Placeholder 3"/>
+          <p:cNvSpPr>
+            <a:spLocks noGrp="1"/>
+          </p:cNvSpPr>
+          <p:nvPr>
+            <p:ph type="sldNum" idx="5" sz="quarter"/>
+          </p:nvPr>
+        </p:nvSpPr>
+        <p:spPr/>
+      </p:sp>
+    </p:spTree>
+  </p:cSld>
+  <p:clrMapOvr>
+    <a:masterClrMapping/>
+  </p:clrMapOvr>
+</p:notes>
+</file>
+
+<file path=ppt/notesSlides/notesSlide49.xml><?xml version="1.0" encoding="utf-8"?>
+<p:notes xmlns:a="http://schemas.openxmlformats.org/drawingml/2006/main" xmlns:p="http://schemas.openxmlformats.org/presentationml/2006/main" xmlns:r="http://schemas.openxmlformats.org/officeDocument/2006/relationships">
+  <p:cSld>
+    <p:spTree>
+      <p:nvGrpSpPr>
+        <p:cNvPr id="1" name=""/>
+        <p:cNvGrpSpPr/>
+        <p:nvPr/>
+      </p:nvGrpSpPr>
+      <p:grpSpPr>
+        <a:xfrm>
+          <a:off x="0" y="0"/>
+          <a:ext cx="0" cy="0"/>
+          <a:chOff x="0" y="0"/>
+          <a:chExt cx="0" cy="0"/>
+        </a:xfrm>
+      </p:grpSpPr>
+      <p:sp>
+        <p:nvSpPr>
+          <p:cNvPr id="2" name="Slide Image Placeholder 1"/>
+          <p:cNvSpPr>
+            <a:spLocks noGrp="1"/>
+          </p:cNvSpPr>
+          <p:nvPr>
+            <p:ph type="sldImg" idx="2"/>
+          </p:nvPr>
+        </p:nvSpPr>
+        <p:spPr/>
+      </p:sp>
+      <p:sp>
+        <p:nvSpPr>
+          <p:cNvPr id="3" name="Notes Placeholder 2"/>
+          <p:cNvSpPr>
+            <a:spLocks noGrp="1"/>
+          </p:cNvSpPr>
+          <p:nvPr>
+            <p:ph type="body" idx="3" sz="quarter"/>
+          </p:nvPr>
+        </p:nvSpPr>
+        <p:spPr/>
+        <p:txBody>
+          <a:bodyPr/>
+          <a:lstStyle/>
+          <a:p>
+            <a:r>
+              <a:t>Os proximos passos saem direto das limitacoes do slide anterior.</a:t>
+            </a:r>
+          </a:p>
+          <a:p>
+            <a:r>
+              <a:t>Nenhum deles exige refazer o que esta feito: o pipeline ja e parametrizado por estado, e a migracao para o Autonomous e troca de motor, nao de modelo.</a:t>
+            </a:r>
+          </a:p>
+        </p:txBody>
+      </p:sp>
+      <p:sp>
+        <p:nvSpPr>
+          <p:cNvPr id="4" name="Slide Number Placeholder 3"/>
+          <p:cNvSpPr>
+            <a:spLocks noGrp="1"/>
+          </p:cNvSpPr>
+          <p:nvPr>
+            <p:ph type="sldNum" idx="5" sz="quarter"/>
+          </p:nvPr>
+        </p:nvSpPr>
+        <p:spPr/>
+      </p:sp>
+    </p:spTree>
+  </p:cSld>
+  <p:clrMapOvr>
+    <a:masterClrMapping/>
+  </p:clrMapOvr>
+</p:notes>
+</file>
+
+<file path=ppt/notesSlides/notesSlide5.xml><?xml version="1.0" encoding="utf-8"?>
+<p:notes xmlns:a="http://schemas.openxmlformats.org/drawingml/2006/main" xmlns:p="http://schemas.openxmlformats.org/presentationml/2006/main" xmlns:r="http://schemas.openxmlformats.org/officeDocument/2006/relationships">
+  <p:cSld>
+    <p:spTree>
+      <p:nvGrpSpPr>
+        <p:cNvPr id="1" name=""/>
+        <p:cNvGrpSpPr/>
+        <p:nvPr/>
+      </p:nvGrpSpPr>
+      <p:grpSpPr>
+        <a:xfrm>
+          <a:off x="0" y="0"/>
+          <a:ext cx="0" cy="0"/>
+          <a:chOff x="0" y="0"/>
+          <a:chExt cx="0" cy="0"/>
+        </a:xfrm>
+      </p:grpSpPr>
+      <p:sp>
+        <p:nvSpPr>
+          <p:cNvPr id="2" name="Slide Image Placeholder 1"/>
+          <p:cNvSpPr>
+            <a:spLocks noGrp="1"/>
+          </p:cNvSpPr>
+          <p:nvPr>
+            <p:ph type="sldImg" idx="2"/>
+          </p:nvPr>
+        </p:nvSpPr>
+        <p:spPr/>
+      </p:sp>
+      <p:sp>
+        <p:nvSpPr>
+          <p:cNvPr id="3" name="Notes Placeholder 2"/>
+          <p:cNvSpPr>
+            <a:spLocks noGrp="1"/>
+          </p:cNvSpPr>
+          <p:nvPr>
+            <p:ph type="body" idx="3" sz="quarter"/>
+          </p:nvPr>
+        </p:nvSpPr>
+        <p:spPr/>
+        <p:txBody>
+          <a:bodyPr/>
+          <a:lstStyle/>
+          <a:p>
+            <a:r>
+              <a:t>Primeira entrega: o que prometi na Sprint 1 e o que de fato saiu.</a:t>
+            </a:r>
+          </a:p>
+        </p:txBody>
+      </p:sp>
+      <p:sp>
+        <p:nvSpPr>
+          <p:cNvPr id="4" name="Slide Number Placeholder 3"/>
+          <p:cNvSpPr>
+            <a:spLocks noGrp="1"/>
+          </p:cNvSpPr>
+          <p:nvPr>
+            <p:ph type="sldNum" idx="5" sz="quarter"/>
+          </p:nvPr>
+        </p:nvSpPr>
+        <p:spPr/>
+      </p:sp>
+    </p:spTree>
+  </p:cSld>
+  <p:clrMapOvr>
+    <a:masterClrMapping/>
+  </p:clrMapOvr>
+</p:notes>
+</file>
+
+<file path=ppt/notesSlides/notesSlide6.xml><?xml version="1.0" encoding="utf-8"?>
+<p:notes xmlns:a="http://schemas.openxmlformats.org/drawingml/2006/main" xmlns:p="http://schemas.openxmlformats.org/presentationml/2006/main" xmlns:r="http://schemas.openxmlformats.org/officeDocument/2006/relationships">
+  <p:cSld>
+    <p:spTree>
+      <p:nvGrpSpPr>
+        <p:cNvPr id="1" name=""/>
+        <p:cNvGrpSpPr/>
+        <p:nvPr/>
+      </p:nvGrpSpPr>
+      <p:grpSpPr>
+        <a:xfrm>
+          <a:off x="0" y="0"/>
+          <a:ext cx="0" cy="0"/>
+          <a:chOff x="0" y="0"/>
+          <a:chExt cx="0" cy="0"/>
+        </a:xfrm>
+      </p:grpSpPr>
+      <p:sp>
+        <p:nvSpPr>
+          <p:cNvPr id="2" name="Slide Image Placeholder 1"/>
+          <p:cNvSpPr>
+            <a:spLocks noGrp="1"/>
+          </p:cNvSpPr>
+          <p:nvPr>
+            <p:ph type="sldImg" idx="2"/>
+          </p:nvPr>
+        </p:nvSpPr>
+        <p:spPr/>
+      </p:sp>
+      <p:sp>
+        <p:nvSpPr>
+          <p:cNvPr id="3" name="Notes Placeholder 2"/>
+          <p:cNvSpPr>
+            <a:spLocks noGrp="1"/>
+          </p:cNvSpPr>
+          <p:nvPr>
+            <p:ph type="body" idx="3" sz="quarter"/>
+          </p:nvPr>
+        </p:nvSpPr>
+        <p:spPr/>
+        <p:txBody>
+          <a:bodyPr/>
+          <a:lstStyle/>
+          <a:p>
+            <a:r>
+              <a:t>Quatro itens entregues como prometido, dois entregues de forma diferente, dois substituidos.</a:t>
+            </a:r>
+          </a:p>
+          <a:p>
+            <a:r>
+              <a:t>Os dois amarelos sao limitacao do ambiente, nao minha: o Select AI exige Autonomous Database e a conta academica nao tem privilegio de criar diretorio. Nos dois casos eu entreguei o script pronto e um substituto funcional.</a:t>
+            </a:r>
+          </a:p>
+          <a:p>
+            <a:r>
+              <a:t>Os dois cinzas sao decisao minha, e eu defendo cada uma na hora certa.</a:t>
+            </a:r>
+          </a:p>
+        </p:txBody>
+      </p:sp>
+      <p:sp>
+        <p:nvSpPr>
+          <p:cNvPr id="4" name="Slide Number Placeholder 3"/>
+          <p:cNvSpPr>
+            <a:spLocks noGrp="1"/>
+          </p:cNvSpPr>
+          <p:nvPr>
+            <p:ph type="sldNum" idx="5" sz="quarter"/>
+          </p:nvPr>
+        </p:nvSpPr>
+        <p:spPr/>
+      </p:sp>
+    </p:spTree>
+  </p:cSld>
+  <p:clrMapOvr>
+    <a:masterClrMapping/>
+  </p:clrMapOvr>
+</p:notes>
+</file>
+
+<file path=ppt/notesSlides/notesSlide7.xml><?xml version="1.0" encoding="utf-8"?>
+<p:notes xmlns:a="http://schemas.openxmlformats.org/drawingml/2006/main" xmlns:p="http://schemas.openxmlformats.org/presentationml/2006/main" xmlns:r="http://schemas.openxmlformats.org/officeDocument/2006/relationships">
+  <p:cSld>
+    <p:spTree>
+      <p:nvGrpSpPr>
+        <p:cNvPr id="1" name=""/>
+        <p:cNvGrpSpPr/>
+        <p:nvPr/>
+      </p:nvGrpSpPr>
+      <p:grpSpPr>
+        <a:xfrm>
+          <a:off x="0" y="0"/>
+          <a:ext cx="0" cy="0"/>
+          <a:chOff x="0" y="0"/>
+          <a:chExt cx="0" cy="0"/>
+        </a:xfrm>
+      </p:grpSpPr>
+      <p:sp>
+        <p:nvSpPr>
+          <p:cNvPr id="2" name="Slide Image Placeholder 1"/>
+          <p:cNvSpPr>
+            <a:spLocks noGrp="1"/>
+          </p:cNvSpPr>
+          <p:nvPr>
+            <p:ph type="sldImg" idx="2"/>
+          </p:nvPr>
+        </p:nvSpPr>
+        <p:spPr/>
+      </p:sp>
+      <p:sp>
+        <p:nvSpPr>
+          <p:cNvPr id="3" name="Notes Placeholder 2"/>
+          <p:cNvSpPr>
+            <a:spLocks noGrp="1"/>
+          </p:cNvSpPr>
+          <p:nvPr>
+            <p:ph type="body" idx="3" sz="quarter"/>
+          </p:nvPr>
+        </p:nvSpPr>
+        <p:spPr/>
+        <p:txBody>
+          <a:bodyPr/>
+          <a:lstStyle/>
+          <a:p>
+            <a:r>
+              <a:t>Quadro publico no Trello, 44 cartoes.</a:t>
+            </a:r>
+          </a:p>
+          <a:p>
+            <a:r>
+              <a:t>A quinta lista e a que interessa numa apresentacao academica: "nao implementado, com justificativa". Um quadro todo verde esconde as decisoes de escopo, que sao parte do trabalho. Cada cartao dessa lista tem o motivo tecnico e o que foi entregue no lugar.</a:t>
+            </a:r>
+          </a:p>
+        </p:txBody>
+      </p:sp>
+      <p:sp>
+        <p:nvSpPr>
+          <p:cNvPr id="4" name="Slide Number Placeholder 3"/>
+          <p:cNvSpPr>
+            <a:spLocks noGrp="1"/>
+          </p:cNvSpPr>
+          <p:nvPr>
+            <p:ph type="sldNum" idx="5" sz="quarter"/>
+          </p:nvPr>
+        </p:nvSpPr>
+        <p:spPr/>
+      </p:sp>
+    </p:spTree>
+  </p:cSld>
+  <p:clrMapOvr>
+    <a:masterClrMapping/>
+  </p:clrMapOvr>
+</p:notes>
+</file>
+
+<file path=ppt/notesSlides/notesSlide8.xml><?xml version="1.0" encoding="utf-8"?>
+<p:notes xmlns:a="http://schemas.openxmlformats.org/drawingml/2006/main" xmlns:p="http://schemas.openxmlformats.org/presentationml/2006/main" xmlns:r="http://schemas.openxmlformats.org/officeDocument/2006/relationships">
+  <p:cSld>
+    <p:spTree>
+      <p:nvGrpSpPr>
+        <p:cNvPr id="1" name=""/>
+        <p:cNvGrpSpPr/>
+        <p:nvPr/>
+      </p:nvGrpSpPr>
+      <p:grpSpPr>
+        <a:xfrm>
+          <a:off x="0" y="0"/>
+          <a:ext cx="0" cy="0"/>
+          <a:chOff x="0" y="0"/>
+          <a:chExt cx="0" cy="0"/>
+        </a:xfrm>
+      </p:grpSpPr>
+      <p:sp>
+        <p:nvSpPr>
+          <p:cNvPr id="2" name="Slide Image Placeholder 1"/>
+          <p:cNvSpPr>
+            <a:spLocks noGrp="1"/>
+          </p:cNvSpPr>
+          <p:nvPr>
+            <p:ph type="sldImg" idx="2"/>
+          </p:nvPr>
+        </p:nvSpPr>
+        <p:spPr/>
+      </p:sp>
+      <p:sp>
+        <p:nvSpPr>
+          <p:cNvPr id="3" name="Notes Placeholder 2"/>
+          <p:cNvSpPr>
+            <a:spLocks noGrp="1"/>
+          </p:cNvSpPr>
+          <p:nvPr>
+            <p:ph type="body" idx="3" sz="quarter"/>
+          </p:nvPr>
+        </p:nvSpPr>
+        <p:spPr/>
+        <p:txBody>
+          <a:bodyPr/>
+          <a:lstStyle/>
+          <a:p>
+            <a:r>
+              <a:t>Segunda entrega: o MVP funcionando.</a:t>
+            </a:r>
+          </a:p>
+        </p:txBody>
+      </p:sp>
+      <p:sp>
+        <p:nvSpPr>
+          <p:cNvPr id="4" name="Slide Number Placeholder 3"/>
+          <p:cNvSpPr>
+            <a:spLocks noGrp="1"/>
+          </p:cNvSpPr>
+          <p:nvPr>
+            <p:ph type="sldNum" idx="5" sz="quarter"/>
+          </p:nvPr>
+        </p:nvSpPr>
+        <p:spPr/>
+      </p:sp>
+    </p:spTree>
+  </p:cSld>
+  <p:clrMapOvr>
+    <a:masterClrMapping/>
+  </p:clrMapOvr>
+</p:notes>
+</file>
+
+<file path=ppt/notesSlides/notesSlide9.xml><?xml version="1.0" encoding="utf-8"?>
+<p:notes xmlns:a="http://schemas.openxmlformats.org/drawingml/2006/main" xmlns:p="http://schemas.openxmlformats.org/presentationml/2006/main" xmlns:r="http://schemas.openxmlformats.org/officeDocument/2006/relationships">
+  <p:cSld>
+    <p:spTree>
+      <p:nvGrpSpPr>
+        <p:cNvPr id="1" name=""/>
+        <p:cNvGrpSpPr/>
+        <p:nvPr/>
+      </p:nvGrpSpPr>
+      <p:grpSpPr>
+        <a:xfrm>
+          <a:off x="0" y="0"/>
+          <a:ext cx="0" cy="0"/>
+          <a:chOff x="0" y="0"/>
+          <a:chExt cx="0" cy="0"/>
+        </a:xfrm>
+      </p:grpSpPr>
+      <p:sp>
+        <p:nvSpPr>
+          <p:cNvPr id="2" name="Slide Image Placeholder 1"/>
+          <p:cNvSpPr>
+            <a:spLocks noGrp="1"/>
+          </p:cNvSpPr>
+          <p:nvPr>
+            <p:ph type="sldImg" idx="2"/>
+          </p:nvPr>
+        </p:nvSpPr>
+        <p:spPr/>
+      </p:sp>
+      <p:sp>
+        <p:nvSpPr>
+          <p:cNvPr id="3" name="Notes Placeholder 2"/>
+          <p:cNvSpPr>
+            <a:spLocks noGrp="1"/>
+          </p:cNvSpPr>
+          <p:nvPr>
+            <p:ph type="body" idx="3" sz="quarter"/>
+          </p:nvPr>
+        </p:nvSpPr>
+        <p:spPr/>
+        <p:txBody>
+          <a:bodyPr/>
+          <a:lstStyle/>
+          <a:p>
+            <a:r>
+              <a:t>Este e o painel, publicado e conectado ao Oracle da FIAP.</a:t>
+            </a:r>
+          </a:p>
+          <a:p>
+            <a:r>
+              <a:t>Cada numero desta tela vem de uma consulta com agregacao empurrada para o banco. Eu nao carrego a tabela e somo no Python: mando SUM e COUNT para o Oracle e trago so o resultado. Isso importa porque a tabela fato tem centenas de milhares de linhas, e trazer tudo para o cliente travava a tela.</a:t>
+            </a:r>
+          </a:p>
+        </p:txBody>
+      </p:sp>
+      <p:sp>
+        <p:nvSpPr>
+          <p:cNvPr id="4" name="Slide Number Placeholder 3"/>
+          <p:cNvSpPr>
+            <a:spLocks noGrp="1"/>
+          </p:cNvSpPr>
+          <p:nvPr>
+            <p:ph type="sldNum" idx="5" sz="quarter"/>
+          </p:nvPr>
+        </p:nvSpPr>
+        <p:spPr/>
+      </p:sp>
+    </p:spTree>
+  </p:cSld>
+  <p:clrMapOvr>
+    <a:masterClrMapping/>
+  </p:clrMapOvr>
+</p:notes>
 </file>
 
 <file path=ppt/slideLayouts/slideLayout1.xml><?xml version="1.0" encoding="utf-8"?>
@@ -4638,8 +8758,8 @@
         </p:blipFill>
         <p:spPr>
           <a:xfrm>
-            <a:off x="137160" y="354330"/>
-            <a:ext cx="8869680" cy="4434840"/>
+            <a:off x="215365" y="137160"/>
+            <a:ext cx="8713269" cy="4869180"/>
           </a:xfrm>
           <a:prstGeom prst="rect">
             <a:avLst/>
@@ -27291,4 +31411,324 @@
   </a:objectDefaults>
   <a:extraClrSchemeLst/>
 </a:theme>
+</file>
+
+<file path=ppt/theme/theme2.xml><?xml version="1.0" encoding="utf-8"?>
+<a:theme xmlns:a="http://schemas.openxmlformats.org/drawingml/2006/main" name="Office Theme">
+  <a:themeElements>
+    <a:clrScheme name="Office">
+      <a:dk1>
+        <a:sysClr val="windowText" lastClr="000000"/>
+      </a:dk1>
+      <a:lt1>
+        <a:sysClr val="window" lastClr="FFFFFF"/>
+      </a:lt1>
+      <a:dk2>
+        <a:srgbClr val="1F497D"/>
+      </a:dk2>
+      <a:lt2>
+        <a:srgbClr val="EEECE1"/>
+      </a:lt2>
+      <a:accent1>
+        <a:srgbClr val="4F81BD"/>
+      </a:accent1>
+      <a:accent2>
+        <a:srgbClr val="C0504D"/>
+      </a:accent2>
+      <a:accent3>
+        <a:srgbClr val="9BBB59"/>
+      </a:accent3>
+      <a:accent4>
+        <a:srgbClr val="8064A2"/>
+      </a:accent4>
+      <a:accent5>
+        <a:srgbClr val="4BACC6"/>
+      </a:accent5>
+      <a:accent6>
+        <a:srgbClr val="F79646"/>
+      </a:accent6>
+      <a:hlink>
+        <a:srgbClr val="0000FF"/>
+      </a:hlink>
+      <a:folHlink>
+        <a:srgbClr val="800080"/>
+      </a:folHlink>
+    </a:clrScheme>
+    <a:fontScheme name="Office">
+      <a:majorFont>
+        <a:latin typeface="Calibri"/>
+        <a:ea typeface=""/>
+        <a:cs typeface=""/>
+        <a:font script="Jpan" typeface="ＭＳ Ｐゴシック"/>
+        <a:font script="Hang" typeface="맑은 고딕"/>
+        <a:font script="Hans" typeface="宋体"/>
+        <a:font script="Hant" typeface="新細明體"/>
+        <a:font script="Arab" typeface="Times New Roman"/>
+        <a:font script="Hebr" typeface="Times New Roman"/>
+        <a:font script="Thai" typeface="Angsana New"/>
+        <a:font script="Ethi" typeface="Nyala"/>
+        <a:font script="Beng" typeface="Vrinda"/>
+        <a:font script="Gujr" typeface="Shruti"/>
+        <a:font script="Khmr" typeface="MoolBoran"/>
+        <a:font script="Knda" typeface="Tunga"/>
+        <a:font script="Guru" typeface="Raavi"/>
+        <a:font script="Cans" typeface="Euphemia"/>
+        <a:font script="Cher" typeface="Plantagenet Cherokee"/>
+        <a:font script="Yiii" typeface="Microsoft Yi Baiti"/>
+        <a:font script="Tibt" typeface="Microsoft Himalaya"/>
+        <a:font script="Thaa" typeface="MV Boli"/>
+        <a:font script="Deva" typeface="Mangal"/>
+        <a:font script="Telu" typeface="Gautami"/>
+        <a:font script="Taml" typeface="Latha"/>
+        <a:font script="Syrc" typeface="Estrangelo Edessa"/>
+        <a:font script="Orya" typeface="Kalinga"/>
+        <a:font script="Mlym" typeface="Kartika"/>
+        <a:font script="Laoo" typeface="DokChampa"/>
+        <a:font script="Sinh" typeface="Iskoola Pota"/>
+        <a:font script="Mong" typeface="Mongolian Baiti"/>
+        <a:font script="Viet" typeface="Times New Roman"/>
+        <a:font script="Uigh" typeface="Microsoft Uighur"/>
+        <a:font script="Geor" typeface="Sylfaen"/>
+      </a:majorFont>
+      <a:minorFont>
+        <a:latin typeface="Calibri"/>
+        <a:ea typeface=""/>
+        <a:cs typeface=""/>
+        <a:font script="Jpan" typeface="ＭＳ Ｐゴシック"/>
+        <a:font script="Hang" typeface="맑은 고딕"/>
+        <a:font script="Hans" typeface="宋体"/>
+        <a:font script="Hant" typeface="新細明體"/>
+        <a:font script="Arab" typeface="Arial"/>
+        <a:font script="Hebr" typeface="Arial"/>
+        <a:font script="Thai" typeface="Cordia New"/>
+        <a:font script="Ethi" typeface="Nyala"/>
+        <a:font script="Beng" typeface="Vrinda"/>
+        <a:font script="Gujr" typeface="Shruti"/>
+        <a:font script="Khmr" typeface="DaunPenh"/>
+        <a:font script="Knda" typeface="Tunga"/>
+        <a:font script="Guru" typeface="Raavi"/>
+        <a:font script="Cans" typeface="Euphemia"/>
+        <a:font script="Cher" typeface="Plantagenet Cherokee"/>
+        <a:font script="Yiii" typeface="Microsoft Yi Baiti"/>
+        <a:font script="Tibt" typeface="Microsoft Himalaya"/>
+        <a:font script="Thaa" typeface="MV Boli"/>
+        <a:font script="Deva" typeface="Mangal"/>
+        <a:font script="Telu" typeface="Gautami"/>
+        <a:font script="Taml" typeface="Latha"/>
+        <a:font script="Syrc" typeface="Estrangelo Edessa"/>
+        <a:font script="Orya" typeface="Kalinga"/>
+        <a:font script="Mlym" typeface="Kartika"/>
+        <a:font script="Laoo" typeface="DokChampa"/>
+        <a:font script="Sinh" typeface="Iskoola Pota"/>
+        <a:font script="Mong" typeface="Mongolian Baiti"/>
+        <a:font script="Viet" typeface="Arial"/>
+        <a:font script="Uigh" typeface="Microsoft Uighur"/>
+        <a:font script="Geor" typeface="Sylfaen"/>
+      </a:minorFont>
+    </a:fontScheme>
+    <a:fmtScheme name="Office">
+      <a:fillStyleLst>
+        <a:solidFill>
+          <a:schemeClr val="phClr"/>
+        </a:solidFill>
+        <a:gradFill rotWithShape="1">
+          <a:gsLst>
+            <a:gs pos="0">
+              <a:schemeClr val="phClr">
+                <a:tint val="50000"/>
+                <a:satMod val="300000"/>
+              </a:schemeClr>
+            </a:gs>
+            <a:gs pos="35000">
+              <a:schemeClr val="phClr">
+                <a:tint val="37000"/>
+                <a:satMod val="300000"/>
+              </a:schemeClr>
+            </a:gs>
+            <a:gs pos="100000">
+              <a:schemeClr val="phClr">
+                <a:tint val="15000"/>
+                <a:satMod val="350000"/>
+              </a:schemeClr>
+            </a:gs>
+          </a:gsLst>
+          <a:lin ang="16200000" scaled="1"/>
+        </a:gradFill>
+        <a:gradFill rotWithShape="1">
+          <a:gsLst>
+            <a:gs pos="0">
+              <a:schemeClr val="phClr">
+                <a:tint val="100000"/>
+                <a:shade val="100000"/>
+                <a:satMod val="130000"/>
+              </a:schemeClr>
+            </a:gs>
+            <a:gs pos="100000">
+              <a:schemeClr val="phClr">
+                <a:tint val="50000"/>
+                <a:shade val="100000"/>
+                <a:satMod val="350000"/>
+              </a:schemeClr>
+            </a:gs>
+          </a:gsLst>
+          <a:lin ang="16200000" scaled="0"/>
+        </a:gradFill>
+      </a:fillStyleLst>
+      <a:lnStyleLst>
+        <a:ln w="9525" cap="flat" cmpd="sng" algn="ctr">
+          <a:solidFill>
+            <a:schemeClr val="phClr">
+              <a:shade val="95000"/>
+              <a:satMod val="105000"/>
+            </a:schemeClr>
+          </a:solidFill>
+          <a:prstDash val="solid"/>
+        </a:ln>
+        <a:ln w="25400" cap="flat" cmpd="sng" algn="ctr">
+          <a:solidFill>
+            <a:schemeClr val="phClr"/>
+          </a:solidFill>
+          <a:prstDash val="solid"/>
+        </a:ln>
+        <a:ln w="38100" cap="flat" cmpd="sng" algn="ctr">
+          <a:solidFill>
+            <a:schemeClr val="phClr"/>
+          </a:solidFill>
+          <a:prstDash val="solid"/>
+        </a:ln>
+      </a:lnStyleLst>
+      <a:effectStyleLst>
+        <a:effectStyle>
+          <a:effectLst>
+            <a:outerShdw blurRad="40000" dist="20000" dir="5400000" rotWithShape="0">
+              <a:srgbClr val="000000">
+                <a:alpha val="38000"/>
+              </a:srgbClr>
+            </a:outerShdw>
+          </a:effectLst>
+        </a:effectStyle>
+        <a:effectStyle>
+          <a:effectLst>
+            <a:outerShdw blurRad="40000" dist="23000" dir="5400000" rotWithShape="0">
+              <a:srgbClr val="000000">
+                <a:alpha val="35000"/>
+              </a:srgbClr>
+            </a:outerShdw>
+          </a:effectLst>
+        </a:effectStyle>
+        <a:effectStyle>
+          <a:effectLst>
+            <a:outerShdw blurRad="40000" dist="23000" dir="5400000" rotWithShape="0">
+              <a:srgbClr val="000000">
+                <a:alpha val="35000"/>
+              </a:srgbClr>
+            </a:outerShdw>
+          </a:effectLst>
+          <a:scene3d>
+            <a:camera prst="orthographicFront">
+              <a:rot lat="0" lon="0" rev="0"/>
+            </a:camera>
+            <a:lightRig rig="threePt" dir="t">
+              <a:rot lat="0" lon="0" rev="1200000"/>
+            </a:lightRig>
+          </a:scene3d>
+          <a:sp3d>
+            <a:bevelT w="63500" h="25400"/>
+          </a:sp3d>
+        </a:effectStyle>
+      </a:effectStyleLst>
+      <a:bgFillStyleLst>
+        <a:solidFill>
+          <a:schemeClr val="phClr"/>
+        </a:solidFill>
+        <a:gradFill rotWithShape="1">
+          <a:gsLst>
+            <a:gs pos="0">
+              <a:schemeClr val="phClr">
+                <a:tint val="40000"/>
+                <a:satMod val="350000"/>
+              </a:schemeClr>
+            </a:gs>
+            <a:gs pos="40000">
+              <a:schemeClr val="phClr">
+                <a:tint val="45000"/>
+                <a:shade val="99000"/>
+                <a:satMod val="350000"/>
+              </a:schemeClr>
+            </a:gs>
+            <a:gs pos="100000">
+              <a:schemeClr val="phClr">
+                <a:shade val="20000"/>
+                <a:satMod val="255000"/>
+              </a:schemeClr>
+            </a:gs>
+          </a:gsLst>
+          <a:path path="circle">
+            <a:fillToRect l="50000" t="-80000" r="50000" b="180000"/>
+          </a:path>
+        </a:gradFill>
+        <a:gradFill rotWithShape="1">
+          <a:gsLst>
+            <a:gs pos="0">
+              <a:schemeClr val="phClr">
+                <a:tint val="80000"/>
+                <a:satMod val="300000"/>
+              </a:schemeClr>
+            </a:gs>
+            <a:gs pos="100000">
+              <a:schemeClr val="phClr">
+                <a:shade val="30000"/>
+                <a:satMod val="200000"/>
+              </a:schemeClr>
+            </a:gs>
+          </a:gsLst>
+          <a:path path="circle">
+            <a:fillToRect l="50000" t="50000" r="50000" b="50000"/>
+          </a:path>
+        </a:gradFill>
+      </a:bgFillStyleLst>
+    </a:fmtScheme>
+  </a:themeElements>
+  <a:objectDefaults>
+    <a:spDef>
+      <a:spPr/>
+      <a:bodyPr/>
+      <a:lstStyle/>
+      <a:style>
+        <a:lnRef idx="1">
+          <a:schemeClr val="accent1"/>
+        </a:lnRef>
+        <a:fillRef idx="3">
+          <a:schemeClr val="accent1"/>
+        </a:fillRef>
+        <a:effectRef idx="2">
+          <a:schemeClr val="accent1"/>
+        </a:effectRef>
+        <a:fontRef idx="minor">
+          <a:schemeClr val="lt1"/>
+        </a:fontRef>
+      </a:style>
+    </a:spDef>
+    <a:lnDef>
+      <a:spPr/>
+      <a:bodyPr/>
+      <a:lstStyle/>
+      <a:style>
+        <a:lnRef idx="2">
+          <a:schemeClr val="accent1"/>
+        </a:lnRef>
+        <a:fillRef idx="0">
+          <a:schemeClr val="accent1"/>
+        </a:fillRef>
+        <a:effectRef idx="1">
+          <a:schemeClr val="accent1"/>
+        </a:effectRef>
+        <a:fontRef idx="minor">
+          <a:schemeClr val="tx1"/>
+        </a:fontRef>
+      </a:style>
+    </a:lnDef>
+  </a:objectDefaults>
+  <a:extraClrSchemeLst/>
+</a:theme>
 </file>
</xml_diff>

<commit_message>
Gera o teleprompter da apresentacao slide a slide
O teleprompter existente era do pitch de 5 minutos. A apresentacao em sala
precisa de outro: 49 slides, 18min30s, com o tempo de cada um e o acumulado
para saber onde se esta do orcamento no meio da fala.

Corrige um bug que eu mesmo introduzi ao gravar as notas: a capa nao
consumia numero de slide, entao NOTAS[1] caía nela E no slide 2, e todas
as notas seguintes ficavam deslocadas em um — a do slide 49 nunca entrava.
Agora sao 49 notas distintas em 49 slides.

O gerador le docs/slides.json, um manifesto de titulos que gera_ppt.py
grava, em vez de abrir o .pptx: o arquivo fica travado enquanto estiver
aberto no PowerPoint, que e justamente quando se quer regerar. Pelo mesmo
motivo o manifesto e gravado antes do deck.

Co-Authored-By: Claude Opus 5 <noreply@anthropic.com>
</commit_message>
<xml_diff>
--- a/EC_Sprint_2_1TSCO_EvidenciasConstrucao_SaudeViz_Lucas_Colen.pptx
+++ b/EC_Sprint_2_1TSCO_EvidenciasConstrucao_SaudeViz_Lucas_Colen.pptx
@@ -625,17 +625,12 @@
           <a:lstStyle/>
           <a:p>
             <a:r>
-              <a:t>A pergunta e "onde a capacidade foi ultrapassada".</a:t>
-            </a:r>
-          </a:p>
-          <a:p>
-            <a:r>
-              <a:t>Para responder eu precisei cruzar duas fontes que nao se conhecem: as internacoes do SIH e os leitos do CNES. O join e por codigo IBGE de seis digitos do municipio. Somo os leitos SUS de todos os estabelecimentos de cada municipio, somo os dias de permanencia consumidos naquele mes, divido um pelo outro e pelo numero de dias do mes. Isso da a taxa de ocupacao.</a:t>
-            </a:r>
-          </a:p>
-          <a:p>
-            <a:r>
-              <a:t>Repare nos dois numeros lado a lado: media simples e ponderada. A simples trata um municipio de tres leitos igual a Sao Paulo. A distancia entre as barras e o tamanho do erro que eu teria cometido se usasse a media ingenua.</a:t>
+              <a:t>A lista de municipios criticos sai de um filtro sobre a tabela de indicador: situacao igual a 'Critica', ordenado por taxa de ocupacao decrescente.</a:t>
+            </a:r>
+          </a:p>
+          <a:p>
+            <a:r>
+              <a:t>E eu declaro na tela que ocupacao acima de um e alerta para investigar, nao prova de colapso. Pode ser leito desatualizado no CNES, ou municipio-polo atendendo a regiao inteira. A ferramenta reduz mil seiscentos e sessenta e oito municipios a uma lista de dezenas. A decisao continua humana.</a:t>
             </a:r>
           </a:p>
         </p:txBody>
@@ -705,12 +700,17 @@
           <a:lstStyle/>
           <a:p>
             <a:r>
-              <a:t>A lista de municipios criticos sai de um filtro sobre a tabela de indicador: situacao igual a 'Critica', ordenado por taxa de ocupacao decrescente.</a:t>
-            </a:r>
-          </a:p>
-          <a:p>
-            <a:r>
-              <a:t>E eu declaro na tela que ocupacao acima de um e alerta para investigar, nao prova de colapso. Pode ser leito desatualizado no CNES, ou municipio-polo atendendo a regiao inteira. A ferramenta reduz mil seiscentos e sessenta e oito municipios a uma lista de dezenas. A decisao continua humana.</a:t>
+              <a:t>Esta tela responde "quais perfis pressionam mais".</a:t>
+            </a:r>
+          </a:p>
+          <a:p>
+            <a:r>
+              <a:t>O perfil de atendimento nao existe no dado bruto: eu derivei do CID principal, pegando os tres primeiros caracteres e classificando por faixa. J00 a J99 vira respiratorio, S00 a T98 vira causa externa, F00 a F99 vira saude mental.</a:t>
+            </a:r>
+          </a:p>
+          <a:p>
+            <a:r>
+              <a:t>E o ranking nao e por volume. Eu ordeno por pressao relativa: a participacao no total de leitos-dia dividida pela participacao no total de internacoes. Saude mental fica no topo com 2,15 — ocupa o dobro de leito por internacao que a media. Num painel ordenado por volume ela nem apareceria.</a:t>
             </a:r>
           </a:p>
         </p:txBody>
@@ -780,17 +780,7 @@
           <a:lstStyle/>
           <a:p>
             <a:r>
-              <a:t>Esta tela responde "quais perfis pressionam mais".</a:t>
-            </a:r>
-          </a:p>
-          <a:p>
-            <a:r>
-              <a:t>O perfil de atendimento nao existe no dado bruto: eu derivei do CID principal, pegando os tres primeiros caracteres e classificando por faixa. J00 a J99 vira respiratorio, S00 a T98 vira causa externa, F00 a F99 vira saude mental.</a:t>
-            </a:r>
-          </a:p>
-          <a:p>
-            <a:r>
-              <a:t>E o ranking nao e por volume. Eu ordeno por pressao relativa: a participacao no total de leitos-dia dividida pela participacao no total de internacoes. Saude mental fica no topo com 2,15 — ocupa o dobro de leito por internacao que a media. Num painel ordenado por volume ela nem apareceria.</a:t>
+              <a:t>Terceira entrega: a arquitetura que de fato foi implementada.</a:t>
             </a:r>
           </a:p>
         </p:txBody>
@@ -860,7 +850,17 @@
           <a:lstStyle/>
           <a:p>
             <a:r>
-              <a:t>Terceira entrega: a arquitetura que de fato foi implementada.</a:t>
+              <a:t>O caminho completo do dado.</a:t>
+            </a:r>
+          </a:p>
+          <a:p>
+            <a:r>
+              <a:t>Quatro fontes publicas. A ingestao baixa e converte, o Databricks processa em tres camadas, o Oracle guarda a camada de consumo, o Streamlit consulta.</a:t>
+            </a:r>
+          </a:p>
+          <a:p>
+            <a:r>
+              <a:t>A conversao do .dbc roda fora do Databricks de proposito: e formato proprietario do DATASUS que exige extensao compilada em C e acesso FTP, os dois pouco praticos em compute serverless.</a:t>
             </a:r>
           </a:p>
         </p:txBody>
@@ -930,17 +930,17 @@
           <a:lstStyle/>
           <a:p>
             <a:r>
-              <a:t>O caminho completo do dado.</a:t>
-            </a:r>
-          </a:p>
-          <a:p>
-            <a:r>
-              <a:t>Quatro fontes publicas. A ingestao baixa e converte, o Databricks processa em tres camadas, o Oracle guarda a camada de consumo, o Streamlit consulta.</a:t>
-            </a:r>
-          </a:p>
-          <a:p>
-            <a:r>
-              <a:t>A conversao do .dbc roda fora do Databricks de proposito: e formato proprietario do DATASUS que exige extensao compilada em C e acesso FTP, os dois pouco praticos em compute serverless.</a:t>
+              <a:t>Cada etapa esta onde esta por um motivo, e vale explicar a escolha.</a:t>
+            </a:r>
+          </a:p>
+          <a:p>
+            <a:r>
+              <a:t>O download local e por causa da biblioteca compilada. O processamento no Databricks e porque sao sete milhoes de linhas — em pandas na minha maquina isso daria quatorze giga de memoria e eu tenho cinco livres. Medi antes de migrar.</a:t>
+            </a:r>
+          </a:p>
+          <a:p>
+            <a:r>
+              <a:t>O Oracle e a camada de servico: e dele que o painel consulta, e e nele que estao os COMMENT ON que alimentam o tradutor de linguagem natural.</a:t>
             </a:r>
           </a:p>
         </p:txBody>
@@ -1010,17 +1010,12 @@
           <a:lstStyle/>
           <a:p>
             <a:r>
-              <a:t>Cada etapa esta onde esta por um motivo, e vale explicar a escolha.</a:t>
-            </a:r>
-          </a:p>
-          <a:p>
-            <a:r>
-              <a:t>O download local e por causa da biblioteca compilada. O processamento no Databricks e porque sao sete milhoes de linhas — em pandas na minha maquina isso daria quatorze giga de memoria e eu tenho cinco livres. Medi antes de migrar.</a:t>
-            </a:r>
-          </a:p>
-          <a:p>
-            <a:r>
-              <a:t>O Oracle e a camada de servico: e dele que o painel consulta, e e nele que estao os COMMENT ON que alimentam o tradutor de linguagem natural.</a:t>
+              <a:t>Isto nao e diagrama, e o catalogo real do Databricks.</a:t>
+            </a:r>
+          </a:p>
+          <a:p>
+            <a:r>
+              <a:t>As tres camadas existem como schemas separados. Bronze guarda o dado cru sem transformar nada — se eu errar na Prata, reprocesso sem baixar sessenta arquivos do DATASUS de novo. Essa e a razao de existir da camada Bronze.</a:t>
             </a:r>
           </a:p>
         </p:txBody>
@@ -1090,12 +1085,12 @@
           <a:lstStyle/>
           <a:p>
             <a:r>
-              <a:t>Isto nao e diagrama, e o catalogo real do Databricks.</a:t>
-            </a:r>
-          </a:p>
-          <a:p>
-            <a:r>
-              <a:t>As tres camadas existem como schemas separados. Bronze guarda o dado cru sem transformar nada — se eu errar na Prata, reprocesso sem baixar sessenta arquivos do DATASUS de novo. Essa e a razao de existir da camada Bronze.</a:t>
+              <a:t>A camada Ouro no Oracle: onze tabelas T_SAUDE.</a:t>
+            </a:r>
+          </a:p>
+          <a:p>
+            <a:r>
+              <a:t>Fatos, dimensoes e tabelas de indicador ja agregadas. O painel nao calcula nada em tempo de tela: ele consulta indicador pronto. Isso e o que faz a tela responder em segundos.</a:t>
             </a:r>
           </a:p>
         </p:txBody>
@@ -1165,12 +1160,17 @@
           <a:lstStyle/>
           <a:p>
             <a:r>
-              <a:t>A camada Ouro no Oracle: onze tabelas T_SAUDE.</a:t>
-            </a:r>
-          </a:p>
-          <a:p>
-            <a:r>
-              <a:t>Fatos, dimensoes e tabelas de indicador ja agregadas. O painel nao calcula nada em tempo de tela: ele consulta indicador pronto. Isso e o que faz a tela responder em segundos.</a:t>
+              <a:t>Esta e a prova de que o modelo esta integro.</a:t>
+            </a:r>
+          </a:p>
+          <a:p>
+            <a:r>
+              <a:t>Eu tenho tres tabelas construidas por caminhos diferentes: o fato agregado por municipio e mes, o indicador de capacidade que faz join com os leitos, e o ranking de hospitais agregado por CNES. Sao tres agregacoes independentes, partindo de granularidades diferentes.</a:t>
+            </a:r>
+          </a:p>
+          <a:p>
+            <a:r>
+              <a:t>As tres somam exatamente cinco milhoes quinhentos e quarenta e seis mil oitocentos e dezessete. Se eu tivesse duplicado linha num join ou perdido registro num filtro, esses numeros divergiriam.</a:t>
             </a:r>
           </a:p>
         </p:txBody>
@@ -1240,17 +1240,12 @@
           <a:lstStyle/>
           <a:p>
             <a:r>
-              <a:t>Esta e a prova de que o modelo esta integro.</a:t>
-            </a:r>
-          </a:p>
-          <a:p>
-            <a:r>
-              <a:t>Eu tenho tres tabelas construidas por caminhos diferentes: o fato agregado por municipio e mes, o indicador de capacidade que faz join com os leitos, e o ranking de hospitais agregado por CNES. Sao tres agregacoes independentes, partindo de granularidades diferentes.</a:t>
-            </a:r>
-          </a:p>
-          <a:p>
-            <a:r>
-              <a:t>As tres somam exatamente cinco milhoes quinhentos e quarenta e seis mil oitocentos e dezessete. Se eu tivesse duplicado linha num join ou perdido registro num filtro, esses numeros divergiriam.</a:t>
+              <a:t>O que nao foi implementado, e por que.</a:t>
+            </a:r>
+          </a:p>
+          <a:p>
+            <a:r>
+              <a:t>Nos dois primeiros eu verifiquei no banco antes de desistir — nao presumi. No Select AI, consultei o all_objects. Na External Table, consultei o all_directories. Os dois retornaram vazio, e eu entreguei o DDL documentado junto com a consulta que comprova.</a:t>
             </a:r>
           </a:p>
         </p:txBody>
@@ -1320,12 +1315,7 @@
           <a:lstStyle/>
           <a:p>
             <a:r>
-              <a:t>O que nao foi implementado, e por que.</a:t>
-            </a:r>
-          </a:p>
-          <a:p>
-            <a:r>
-              <a:t>Nos dois primeiros eu verifiquei no banco antes de desistir — nao presumi. No Select AI, consultei o all_objects. Na External Table, consultei o all_directories. Os dois retornaram vazio, e eu entreguei o DDL documentado junto com a consulta que comprova.</a:t>
+              <a:t>Quarta entrega: como os dados foram obtidos, tratados e transformados.</a:t>
             </a:r>
           </a:p>
         </p:txBody>
@@ -1395,12 +1385,7 @@
           <a:lstStyle/>
           <a:p>
             <a:r>
-              <a:t>Bom dia. SaudeViz: um painel que transforma microdados publicos de saude em resposta que um gestor consegue usar.</a:t>
-            </a:r>
-          </a:p>
-          <a:p>
-            <a:r>
-              <a:t>Vou mostrar de onde os dados vieram, o que precisou ser feito com eles, e como viraram informacao. O produto final esta no ar e eu demonstro ao vivo no fim.</a:t>
+              <a:t>Trabalho individual. Lucas Colen, RM 569173, turma 1TSCOA.</a:t>
             </a:r>
           </a:p>
         </p:txBody>
@@ -1470,7 +1455,17 @@
           <a:lstStyle/>
           <a:p>
             <a:r>
-              <a:t>Quarta entrega: como os dados foram obtidos, tratados e transformados.</a:t>
+              <a:t>As fontes, e como cada uma e lida.</a:t>
+            </a:r>
+          </a:p>
+          <a:p>
+            <a:r>
+              <a:t>O SIH vem por FTP, em arquivo .dbc, um por estado e por mes: sessenta arquivos. O CNES vem por API REST em JSON — e aqui teve armadilha: o parametro de UF da API e silenciosamente ignorado. Eu recebia trinta e dois mil registros com apenas mil e duzentos unicos, repetidos vinte e sete vezes. Descobri contando distintos, e troquei para busca dirigida por codigo de estabelecimento.</a:t>
+            </a:r>
+          </a:p>
+          <a:p>
+            <a:r>
+              <a:t>O IBGE vem em CSV, e cumpre a exigencia do terceiro formato. A quarta fonte, de clima, eu acrescentei por conta.</a:t>
             </a:r>
           </a:p>
         </p:txBody>
@@ -1540,17 +1535,17 @@
           <a:lstStyle/>
           <a:p>
             <a:r>
-              <a:t>As fontes, e como cada uma e lida.</a:t>
-            </a:r>
-          </a:p>
-          <a:p>
-            <a:r>
-              <a:t>O SIH vem por FTP, em arquivo .dbc, um por estado e por mes: sessenta arquivos. O CNES vem por API REST em JSON — e aqui teve armadilha: o parametro de UF da API e silenciosamente ignorado. Eu recebia trinta e dois mil registros com apenas mil e duzentos unicos, repetidos vinte e sete vezes. Descobri contando distintos, e troquei para busca dirigida por codigo de estabelecimento.</a:t>
-            </a:r>
-          </a:p>
-          <a:p>
-            <a:r>
-              <a:t>O IBGE vem em CSV, e cumpre a exigencia do terceiro formato. A quarta fonte, de clima, eu acrescentei por conta.</a:t>
+              <a:t>O .dbc do DATASUS e um DBF comprimido com um algoritmo antigo, o PKWare DCL. Nenhuma biblioteca padrao le.</a:t>
+            </a:r>
+          </a:p>
+          <a:p>
+            <a:r>
+              <a:t>E teve um detalhe que custou tempo: a extensao C nao aceita acento no caminho do arquivo. O projeto mora numa pasta chamada "Educacao/Ciencia de Dados", com cedilha e acento. A solucao foi copiar cada arquivo para um diretorio temporario de nome ASCII, converter la, e devolver.</a:t>
+            </a:r>
+          </a:p>
+          <a:p>
+            <a:r>
+              <a:t>E o tipo de problema que nao aparece em tutorial.</a:t>
             </a:r>
           </a:p>
         </p:txBody>
@@ -1620,17 +1615,27 @@
           <a:lstStyle/>
           <a:p>
             <a:r>
-              <a:t>O .dbc do DATASUS e um DBF comprimido com um algoritmo antigo, o PKWare DCL. Nenhuma biblioteca padrao le.</a:t>
-            </a:r>
-          </a:p>
-          <a:p>
-            <a:r>
-              <a:t>E teve um detalhe que custou tempo: a extensao C nao aceita acento no caminho do arquivo. O projeto mora numa pasta chamada "Educacao/Ciencia de Dados", com cedilha e acento. A solucao foi copiar cada arquivo para um diretorio temporario de nome ASCII, converter la, e devolver.</a:t>
-            </a:r>
-          </a:p>
-          <a:p>
-            <a:r>
-              <a:t>E o tipo de problema que nao aparece em tutorial.</a:t>
+              <a:t>Esta e a descoberta que reorientou o projeto inteiro.</a:t>
+            </a:r>
+          </a:p>
+          <a:p>
+            <a:r>
+              <a:t>Eu criei uma coluna calculada chamada defasagem_faturamento: a diferenca em meses entre a competencia do arquivo e o mes real da internacao. Agrupei por ela e contei.</a:t>
+            </a:r>
+          </a:p>
+          <a:p>
+            <a:r>
+              <a:t>Sessenta por cento no mesmo mes. Quarenta por cento espalhados nos tres meses seguintes. Ou seja: a competencia do SIH e o mes de PAGAMENTO da AIH, nao o da internacao.</a:t>
+            </a:r>
+          </a:p>
+          <a:p>
+            <a:r>
+              <a:t>Se eu tivesse usado a competencia como eixo de tempo, meu painel responderia uma pergunta financeira prometendo uma assistencial. Troquei a dimensao temporal para a data de internacao e ampliei a ingestao ate marco de 2025, para recuperar dezembro faturado com atraso.</a:t>
+            </a:r>
+          </a:p>
+          <a:p>
+            <a:r>
+              <a:t>Aqui tambem entram os filtros de qualidade: deduplicacao por numero de AIH mantendo a versao mais recente, via row_number sobre uma janela particionada por n_aih; descarte de permanencia fora de zero a trezentos e sessenta e cinco dias; e descarte de valor negativo.</a:t>
             </a:r>
           </a:p>
         </p:txBody>
@@ -1700,27 +1705,17 @@
           <a:lstStyle/>
           <a:p>
             <a:r>
-              <a:t>Esta e a descoberta que reorientou o projeto inteiro.</a:t>
-            </a:r>
-          </a:p>
-          <a:p>
-            <a:r>
-              <a:t>Eu criei uma coluna calculada chamada defasagem_faturamento: a diferenca em meses entre a competencia do arquivo e o mes real da internacao. Agrupei por ela e contei.</a:t>
-            </a:r>
-          </a:p>
-          <a:p>
-            <a:r>
-              <a:t>Sessenta por cento no mesmo mes. Quarenta por cento espalhados nos tres meses seguintes. Ou seja: a competencia do SIH e o mes de PAGAMENTO da AIH, nao o da internacao.</a:t>
-            </a:r>
-          </a:p>
-          <a:p>
-            <a:r>
-              <a:t>Se eu tivesse usado a competencia como eixo de tempo, meu painel responderia uma pergunta financeira prometendo uma assistencial. Troquei a dimensao temporal para a data de internacao e ampliei a ingestao ate marco de 2025, para recuperar dezembro faturado com atraso.</a:t>
-            </a:r>
-          </a:p>
-          <a:p>
-            <a:r>
-              <a:t>Aqui tambem entram os filtros de qualidade: deduplicacao por numero de AIH mantendo a versao mais recente, via row_number sobre uma janela particionada por n_aih; descarte de permanencia fora de zero a trezentos e sessenta e cinco dias; e descarte de valor negativo.</a:t>
+              <a:t>Dezesseis consultas SQL documentadas, cobrindo as quatro frentes do desafio.</a:t>
+            </a:r>
+          </a:p>
+          <a:p>
+            <a:r>
+              <a:t>Cada uma tem a pergunta de negocio escrita antes do SQL, e a leitura do resultado escrita depois. Nao e SQL solto: e pergunta, consulta, resposta.</a:t>
+            </a:r>
+          </a:p>
+          <a:p>
+            <a:r>
+              <a:t>Uma delas eu precisei reescrever depois de revisar: a Q11 calculava media simples de leitos por cem mil habitantes entre municipios, o que da o mesmo peso a uma cidade de cinco mil e a uma de doze milhoes. Reescrevi com CTE por municipio, e a conclusao mudou: o Rio passou a ser o pior estado, nao Sao Paulo.</a:t>
             </a:r>
           </a:p>
         </p:txBody>
@@ -1790,17 +1785,17 @@
           <a:lstStyle/>
           <a:p>
             <a:r>
-              <a:t>Dezesseis consultas SQL documentadas, cobrindo as quatro frentes do desafio.</a:t>
-            </a:r>
-          </a:p>
-          <a:p>
-            <a:r>
-              <a:t>Cada uma tem a pergunta de negocio escrita antes do SQL, e a leitura do resultado escrita depois. Nao e SQL solto: e pergunta, consulta, resposta.</a:t>
-            </a:r>
-          </a:p>
-          <a:p>
-            <a:r>
-              <a:t>Uma delas eu precisei reescrever depois de revisar: a Q11 calculava media simples de leitos por cem mil habitantes entre municipios, o que da o mesmo peso a uma cidade de cinco mil e a uma de doze milhoes. Reescrevi com CTE por municipio, e a conclusao mudou: o Rio passou a ser o pior estado, nao Sao Paulo.</a:t>
+              <a:t>Duas tecnicas estatisticas, e as duas com proposito.</a:t>
+            </a:r>
+          </a:p>
+          <a:p>
+            <a:r>
+              <a:t>O IQR de Tukey define o limite de outlier em 1,172. Eu tinha escolhido 1,0 como limiar de alerta por raciocinio de negocio, antes de calcular isso. O criterio estatistico, que nao sabe do meu limiar, confirma que ocupacao acima de um e anomala nesta distribuicao.</a:t>
+            </a:r>
+          </a:p>
+          <a:p>
+            <a:r>
+              <a:t>A correlacao de Pearson entre ocupacao e transferencia da menos 0,305. Negativa: municipios com baixa ocupacao transferem MAIS. Nao e contradicao — e a assinatura de quem nao tem capacidade resolutiva, estabiliza o paciente e encaminha.</a:t>
             </a:r>
           </a:p>
         </p:txBody>
@@ -1870,17 +1865,27 @@
           <a:lstStyle/>
           <a:p>
             <a:r>
-              <a:t>Duas tecnicas estatisticas, e as duas com proposito.</a:t>
-            </a:r>
-          </a:p>
-          <a:p>
-            <a:r>
-              <a:t>O IQR de Tukey define o limite de outlier em 1,172. Eu tinha escolhido 1,0 como limiar de alerta por raciocinio de negocio, antes de calcular isso. O criterio estatistico, que nao sabe do meu limiar, confirma que ocupacao acima de um e anomala nesta distribuicao.</a:t>
-            </a:r>
-          </a:p>
-          <a:p>
-            <a:r>
-              <a:t>A correlacao de Pearson entre ocupacao e transferencia da menos 0,305. Negativa: municipios com baixa ocupacao transferem MAIS. Nao e contradicao — e a assinatura de quem nao tem capacidade resolutiva, estabiliza o paciente e encaminha.</a:t>
+              <a:t>Aqui eu testei duas abordagens e deixei o dado escolher.</a:t>
+            </a:r>
+          </a:p>
+          <a:p>
+            <a:r>
+              <a:t>A primeira: regressao com tendencia linear, sazonalidade em termos de Fourier e variavel de feriado. A segunda: perfil semanal simples, que so aprende quanto cada dia da semana desvia da media.</a:t>
+            </a:r>
+          </a:p>
+          <a:p>
+            <a:r>
+              <a:t>Validei com janela expansivel — treino no passado, teste no futuro, avancando. Nunca com dado aleatorio, porque em serie temporal isso vaza o futuro para o treino.</a:t>
+            </a:r>
+          </a:p>
+          <a:p>
+            <a:r>
+              <a:t>A regressao perdeu. O erro dela sobe de seis para vinte e sete por cento conforme o horizonte cresce, porque a tendencia linear extrapola. O modelo simples fica estavel em cinco e meio.</a:t>
+            </a:r>
+          </a:p>
+          <a:p>
+            <a:r>
+              <a:t>Reconhecer que a serie nao tem tendencia explorável valeu mais do que forcar complexidade.</a:t>
             </a:r>
           </a:p>
         </p:txBody>
@@ -1950,27 +1955,17 @@
           <a:lstStyle/>
           <a:p>
             <a:r>
-              <a:t>Aqui eu testei duas abordagens e deixei o dado escolher.</a:t>
-            </a:r>
-          </a:p>
-          <a:p>
-            <a:r>
-              <a:t>A primeira: regressao com tendencia linear, sazonalidade em termos de Fourier e variavel de feriado. A segunda: perfil semanal simples, que so aprende quanto cada dia da semana desvia da media.</a:t>
-            </a:r>
-          </a:p>
-          <a:p>
-            <a:r>
-              <a:t>Validei com janela expansivel — treino no passado, teste no futuro, avancando. Nunca com dado aleatorio, porque em serie temporal isso vaza o futuro para o treino.</a:t>
-            </a:r>
-          </a:p>
-          <a:p>
-            <a:r>
-              <a:t>A regressao perdeu. O erro dela sobe de seis para vinte e sete por cento conforme o horizonte cresce, porque a tendencia linear extrapola. O modelo simples fica estavel em cinco e meio.</a:t>
-            </a:r>
-          </a:p>
-          <a:p>
-            <a:r>
-              <a:t>Reconhecer que a serie nao tem tendencia explorável valeu mais do que forcar complexidade.</a:t>
+              <a:t>O sinal previsivel esta no calendario.</a:t>
+            </a:r>
+          </a:p>
+          <a:p>
+            <a:r>
+              <a:t>Sabado cai trinta e oito por cento, domingo quarenta e um, feriado vinte e seis. E consistente nos quatro estados, com variacao de tres pontos entre eles.</a:t>
+            </a:r>
+          </a:p>
+          <a:p>
+            <a:r>
+              <a:t>E a leitura importa: isso nao e menos gente doente no fim de semana. E a rede eletiva parada. Cirurgia programada nao acontece no domingo.</a:t>
             </a:r>
           </a:p>
         </p:txBody>
@@ -2040,17 +2035,7 @@
           <a:lstStyle/>
           <a:p>
             <a:r>
-              <a:t>O sinal previsivel esta no calendario.</a:t>
-            </a:r>
-          </a:p>
-          <a:p>
-            <a:r>
-              <a:t>Sabado cai trinta e oito por cento, domingo quarenta e um, feriado vinte e seis. E consistente nos quatro estados, com variacao de tres pontos entre eles.</a:t>
-            </a:r>
-          </a:p>
-          <a:p>
-            <a:r>
-              <a:t>E a leitura importa: isso nao e menos gente doente no fim de semana. E a rede eletiva parada. Cirurgia programada nao acontece no domingo.</a:t>
+              <a:t>Quinta entrega: as evidencias visuais do que foi construido.</a:t>
             </a:r>
           </a:p>
         </p:txBody>
@@ -2120,7 +2105,12 @@
           <a:lstStyle/>
           <a:p>
             <a:r>
-              <a:t>Quinta entrega: as evidencias visuais do que foi construido.</a:t>
+              <a:t>A previsao no painel, com intervalo de noventa e cinco por cento.</a:t>
+            </a:r>
+          </a:p>
+          <a:p>
+            <a:r>
+              <a:t>O intervalo vem do desvio dos residuos por dia da semana — nao e uma faixa arbitraria: cada dia tem a sua propria incerteza histórica.</a:t>
             </a:r>
           </a:p>
         </p:txBody>
@@ -2190,12 +2180,22 @@
           <a:lstStyle/>
           <a:p>
             <a:r>
-              <a:t>A previsao no painel, com intervalo de noventa e cinco por cento.</a:t>
-            </a:r>
-          </a:p>
-          <a:p>
-            <a:r>
-              <a:t>O intervalo vem do desvio dos residuos por dia da semana — nao e uma faixa arbitraria: cada dia tem a sua propria incerteza histórica.</a:t>
+              <a:t>Este e o slide onde o painel deixa de descrever e passa a decidir.</a:t>
+            </a:r>
+          </a:p>
+          <a:p>
+            <a:r>
+              <a:t>O calculo: dias de permanencia consumidos no mes, divididos pelos dias do mes, da o numero medio de leitos ocupados. Divido isso pela taxa de ocupacao alvo — oitenta e cinco por cento — e tenho quantos leitos precisam estar abertos.</a:t>
+            </a:r>
+          </a:p>
+          <a:p>
+            <a:r>
+              <a:t>O mes de menor necessidade vira a demanda comum: o piso que a rede nao pode desmobilizar. O que passa disso e capacidade sazonal.</a:t>
+            </a:r>
+          </a:p>
+          <a:p>
+            <a:r>
+              <a:t>Belo Horizonte: piso de 5.107, pico em abril de 5.904, e so 408 leitos de folga. Seis por cento. O painel dispara o alerta sozinho.</a:t>
             </a:r>
           </a:p>
         </p:txBody>
@@ -2265,7 +2265,17 @@
           <a:lstStyle/>
           <a:p>
             <a:r>
-              <a:t>Trabalho individual. Lucas Colen, RM 569173, turma 1TSCOA.</a:t>
+              <a:t>Esses numeros sao o resultado da camada Ouro ja carregada no Oracle.</a:t>
+            </a:r>
+          </a:p>
+          <a:p>
+            <a:r>
+              <a:t>Cinco milhoes e meio de internacoes e o numero DEPOIS do tratamento. O bruto que baixei do DATASUS foi sete milhoes. A diferenca de um milhao e meio nao e perda: sao internacoes de 2023 e de 2025 que vieram junto, porque o SIH publica por mes de pagamento, nao por mes de internacao. Volto nesse ponto, porque foi ele que reorientou o projeto.</a:t>
+            </a:r>
+          </a:p>
+          <a:p>
+            <a:r>
+              <a:t>A consulta que gera esta tela e um SELECT com SUM de internacoes, SUM de dias_permanencia e SUM de valor_total sobre a tabela fato, agrupando nada: e o total geral.</a:t>
             </a:r>
           </a:p>
         </p:txBody>
@@ -2335,22 +2345,12 @@
           <a:lstStyle/>
           <a:p>
             <a:r>
-              <a:t>Este e o slide onde o painel deixa de descrever e passa a decidir.</a:t>
-            </a:r>
-          </a:p>
-          <a:p>
-            <a:r>
-              <a:t>O calculo: dias de permanencia consumidos no mes, divididos pelos dias do mes, da o numero medio de leitos ocupados. Divido isso pela taxa de ocupacao alvo — oitenta e cinco por cento — e tenho quantos leitos precisam estar abertos.</a:t>
-            </a:r>
-          </a:p>
-          <a:p>
-            <a:r>
-              <a:t>O mes de menor necessidade vira a demanda comum: o piso que a rede nao pode desmobilizar. O que passa disso e capacidade sazonal.</a:t>
-            </a:r>
-          </a:p>
-          <a:p>
-            <a:r>
-              <a:t>Belo Horizonte: piso de 5.107, pico em abril de 5.904, e so 408 leitos de folga. Seis por cento. O painel dispara o alerta sozinho.</a:t>
+              <a:t>Consultas de negocio rodando no Oracle, nao em parquet.</a:t>
+            </a:r>
+          </a:p>
+          <a:p>
+            <a:r>
+              <a:t>Este e o top dez de hospitais por volume, com a taxa de transferencia ao lado. A Santa Casa de BH tem cinquenta e quatro mil internacoes e transfere zero virgula dois por cento. E o perfil de quem resolve dentro de casa.</a:t>
             </a:r>
           </a:p>
         </p:txBody>
@@ -2420,12 +2420,12 @@
           <a:lstStyle/>
           <a:p>
             <a:r>
-              <a:t>Consultas de negocio rodando no Oracle, nao em parquet.</a:t>
-            </a:r>
-          </a:p>
-          <a:p>
-            <a:r>
-              <a:t>Este e o top dez de hospitais por volume, com a taxa de transferencia ao lado. A Santa Casa de BH tem cinquenta e quatro mil internacoes e transfere zero virgula dois por cento. E o perfil de quem resolve dentro de casa.</a:t>
+              <a:t>Onde as internacoes crescem: comparacao do segundo semestre contra o primeiro, por municipio.</a:t>
+            </a:r>
+          </a:p>
+          <a:p>
+            <a:r>
+              <a:t>Usei CTE com SUM condicional — soma quando o mes e menor ou igual a seis, soma quando e maior — e filtrei municipios com pelo menos quinhentas internacoes no primeiro semestre. Sem esse filtro, uma cidade que saiu de duas para dez internacoes apareceria com quatrocentos por cento de crescimento e lideraria o ranking.</a:t>
             </a:r>
           </a:p>
         </p:txBody>
@@ -2495,12 +2495,17 @@
           <a:lstStyle/>
           <a:p>
             <a:r>
-              <a:t>Onde as internacoes crescem: comparacao do segundo semestre contra o primeiro, por municipio.</a:t>
-            </a:r>
-          </a:p>
-          <a:p>
-            <a:r>
-              <a:t>Usei CTE com SUM condicional — soma quando o mes e menor ou igual a seis, soma quando e maior — e filtrei municipios com pelo menos quinhentas internacoes no primeiro semestre. Sem esse filtro, uma cidade que saiu de duas para dez internacoes apareceria com quatrocentos por cento de crescimento e lideraria o ranking.</a:t>
+              <a:t>Quem exporta paciente.</a:t>
+            </a:r>
+          </a:p>
+          <a:p>
+            <a:r>
+              <a:t>Embu-Guacu tem mil quatrocentas e sessenta internacoes, mil e oitenta e duas transferencias e quinze leitos. Setenta e quatro por cento dos pacientes seguem para outro municipio.</a:t>
+            </a:r>
+          </a:p>
+          <a:p>
+            <a:r>
+              <a:t>Esse numero so existe porque eu incluí a coluna COBRANCA, que nao estava na minha selecao inicial de vinte e quatro colunas. E antes de usar, validei o mapeamento: os codigos quarenta e um a quarenta e tres somaram exatamente o total da coluna MORTE. Confirmei o bloco de obito empiricamente, em vez de confiar na documentacao.</a:t>
             </a:r>
           </a:p>
         </p:txBody>
@@ -2570,17 +2575,7 @@
           <a:lstStyle/>
           <a:p>
             <a:r>
-              <a:t>Quem exporta paciente.</a:t>
-            </a:r>
-          </a:p>
-          <a:p>
-            <a:r>
-              <a:t>Embu-Guacu tem mil quatrocentas e sessenta internacoes, mil e oitenta e duas transferencias e quinze leitos. Setenta e quatro por cento dos pacientes seguem para outro municipio.</a:t>
-            </a:r>
-          </a:p>
-          <a:p>
-            <a:r>
-              <a:t>Esse numero so existe porque eu incluí a coluna COBRANCA, que nao estava na minha selecao inicial de vinte e quatro colunas. E antes de usar, validei o mapeamento: os codigos quarenta e um a quarenta e tres somaram exatamente o total da coluna MORTE. Confirmei o bloco de obito empiricamente, em vez de confiar na documentacao.</a:t>
+              <a:t>Esta parte nao era exigida. Entrou para responder o criterio de inovacao.</a:t>
             </a:r>
           </a:p>
         </p:txBody>
@@ -2650,7 +2645,17 @@
           <a:lstStyle/>
           <a:p>
             <a:r>
-              <a:t>Esta parte nao era exigida. Entrou para responder o criterio de inovacao.</a:t>
+              <a:t>Uma quarta fonte publica: clima diario das quatro capitais, via Open-Meteo.</a:t>
+            </a:r>
+          </a:p>
+          <a:p>
+            <a:r>
+              <a:t>Recorte nas capitais porque clima e local: a media do estado misturaria o litoral capixaba com a serra mineira e apagaria qualquer sinal.</a:t>
+            </a:r>
+          </a:p>
+          <a:p>
+            <a:r>
+              <a:t>E as faixas de temperatura sao quartis calculados DENTRO de cada capital. Dezoito graus e frio em Vitoria e ameno em Sao Paulo — um limiar absoluto compararia climas diferentes como se fossem o mesmo.</a:t>
             </a:r>
           </a:p>
         </p:txBody>
@@ -2720,17 +2725,22 @@
           <a:lstStyle/>
           <a:p>
             <a:r>
-              <a:t>Uma quarta fonte publica: clima diario das quatro capitais, via Open-Meteo.</a:t>
-            </a:r>
-          </a:p>
-          <a:p>
-            <a:r>
-              <a:t>Recorte nas capitais porque clima e local: a media do estado misturaria o litoral capixaba com a serra mineira e apagaria qualquer sinal.</a:t>
-            </a:r>
-          </a:p>
-          <a:p>
-            <a:r>
-              <a:t>E as faixas de temperatura sao quartis calculados DENTRO de cada capital. Dezoito graus e frio em Vitoria e ameno em Sao Paulo — um limiar absoluto compararia climas diferentes como se fossem o mesmo.</a:t>
+              <a:t>Primeira hipotese: chuva aumenta internacao por acidente.</a:t>
+            </a:r>
+          </a:p>
+          <a:p>
+            <a:r>
+              <a:t>Refutada. Menos de um por cento de diferenca.</a:t>
+            </a:r>
+          </a:p>
+          <a:p>
+            <a:r>
+              <a:t>Mas o que sustenta a conclusao nao e a media: e o teste de gradiente. Se a chuva causasse acidentes, o efeito cresceria de chuva fraca para forte. Ele sobe e desce sem padrao, e o valor mais baixo vem de dezesseis dias apenas.</a:t>
+            </a:r>
+          </a:p>
+          <a:p>
+            <a:r>
+              <a:t>Resultado nulo bem medido tambem e resultado. A consequencia pratica: o planejamento hospitalar nao deve reservar capacidade para dia de chuva.</a:t>
             </a:r>
           </a:p>
         </p:txBody>
@@ -2800,22 +2810,12 @@
           <a:lstStyle/>
           <a:p>
             <a:r>
-              <a:t>Primeira hipotese: chuva aumenta internacao por acidente.</a:t>
-            </a:r>
-          </a:p>
-          <a:p>
-            <a:r>
-              <a:t>Refutada. Menos de um por cento de diferenca.</a:t>
-            </a:r>
-          </a:p>
-          <a:p>
-            <a:r>
-              <a:t>Mas o que sustenta a conclusao nao e a media: e o teste de gradiente. Se a chuva causasse acidentes, o efeito cresceria de chuva fraca para forte. Ele sobe e desce sem padrao, e o valor mais baixo vem de dezesseis dias apenas.</a:t>
-            </a:r>
-          </a:p>
-          <a:p>
-            <a:r>
-              <a:t>Resultado nulo bem medido tambem e resultado. A consequencia pratica: o planejamento hospitalar nao deve reservar capacidade para dia de chuva.</a:t>
+              <a:t>Segunda hipotese: frio aumenta internacao respiratoria.</a:t>
+            </a:r>
+          </a:p>
+          <a:p>
+            <a:r>
+              <a:t>Confirmada. Nove por cento, e com gradiente monotonico nas quatro capitais, cada uma calculada de forma independente. Quatro replicacoes do mesmo padrao e mais forte que um numero agregado.</a:t>
             </a:r>
           </a:p>
         </p:txBody>
@@ -2885,12 +2885,12 @@
           <a:lstStyle/>
           <a:p>
             <a:r>
-              <a:t>Segunda hipotese: frio aumenta internacao respiratoria.</a:t>
-            </a:r>
-          </a:p>
-          <a:p>
-            <a:r>
-              <a:t>Confirmada. Nove por cento, e com gradiente monotonico nas quatro capitais, cada uma calculada de forma independente. Quatro replicacoes do mesmo padrao e mais forte que um numero agregado.</a:t>
+              <a:t>E um detalhe que reforca: a temperatura MAXIMA nao tem correlacao nenhuma, ronda zero nas quatro cidades. Só a minima correlaciona.</a:t>
+            </a:r>
+          </a:p>
+          <a:p>
+            <a:r>
+              <a:t>E o frio da madrugada que se relaciona com internacao respiratoria, nao o calor do dia. Se fosse ruido, as duas variaveis se moveriam juntas.</a:t>
             </a:r>
           </a:p>
         </p:txBody>
@@ -2960,12 +2960,22 @@
           <a:lstStyle/>
           <a:p>
             <a:r>
-              <a:t>E um detalhe que reforca: a temperatura MAXIMA nao tem correlacao nenhuma, ronda zero nas quatro cidades. Só a minima correlaciona.</a:t>
-            </a:r>
-          </a:p>
-          <a:p>
-            <a:r>
-              <a:t>E o frio da madrugada que se relaciona com internacao respiratoria, nao o calor do dia. Se fosse ruido, as duas variaveis se moveriam juntas.</a:t>
+              <a:t>E aqui eu declaro o limite da propria analise.</a:t>
+            </a:r>
+          </a:p>
+          <a:p>
+            <a:r>
+              <a:t>A chuva aparece com correlacao negativa: dia chuvoso tem MENOS internacao respiratoria. Contraintuitivo, ate lembrar que no Sudeste chove no verao e a seca e no inverno. A chuva esta medindo a estacao, nao a si mesma.</a:t>
+            </a:r>
+          </a:p>
+          <a:p>
+            <a:r>
+              <a:t>O mesmo confundimento pode valer para o frio. Os nove por cento podem ser efeito da temperatura, da sazonalidade viral, ou dos dois. E associacao, nao causa.</a:t>
+            </a:r>
+          </a:p>
+          <a:p>
+            <a:r>
+              <a:t>Separar exigiria dado de circulacao viral por semana epidemiologica. Esta registrado como proximo passo.</a:t>
             </a:r>
           </a:p>
         </p:txBody>
@@ -3035,22 +3045,7 @@
           <a:lstStyle/>
           <a:p>
             <a:r>
-              <a:t>E aqui eu declaro o limite da propria analise.</a:t>
-            </a:r>
-          </a:p>
-          <a:p>
-            <a:r>
-              <a:t>A chuva aparece com correlacao negativa: dia chuvoso tem MENOS internacao respiratoria. Contraintuitivo, ate lembrar que no Sudeste chove no verao e a seca e no inverno. A chuva esta medindo a estacao, nao a si mesma.</a:t>
-            </a:r>
-          </a:p>
-          <a:p>
-            <a:r>
-              <a:t>O mesmo confundimento pode valer para o frio. Os nove por cento podem ser efeito da temperatura, da sazonalidade viral, ou dos dois. E associacao, nao causa.</a:t>
-            </a:r>
-          </a:p>
-          <a:p>
-            <a:r>
-              <a:t>Separar exigiria dado de circulacao viral por semana epidemiologica. Esta registrado como proximo passo.</a:t>
+              <a:t>A parte de linguagem natural do desafio.</a:t>
             </a:r>
           </a:p>
         </p:txBody>
@@ -3120,17 +3115,7 @@
           <a:lstStyle/>
           <a:p>
             <a:r>
-              <a:t>Esses numeros sao o resultado da camada Ouro ja carregada no Oracle.</a:t>
-            </a:r>
-          </a:p>
-          <a:p>
-            <a:r>
-              <a:t>Cinco milhoes e meio de internacoes e o numero DEPOIS do tratamento. O bruto que baixei do DATASUS foi sete milhoes. A diferenca de um milhao e meio nao e perda: sao internacoes de 2023 e de 2025 que vieram junto, porque o SIH publica por mes de pagamento, nao por mes de internacao. Volto nesse ponto, porque foi ele que reorientou o projeto.</a:t>
-            </a:r>
-          </a:p>
-          <a:p>
-            <a:r>
-              <a:t>A consulta que gera esta tela e um SELECT com SUM de internacoes, SUM de dias_permanencia e SUM de valor_total sobre a tabela fato, agrupando nada: e o total geral.</a:t>
+              <a:t>Primeira entrega: o que prometi na Sprint 1 e o que de fato saiu.</a:t>
             </a:r>
           </a:p>
         </p:txBody>
@@ -3200,7 +3185,7 @@
           <a:lstStyle/>
           <a:p>
             <a:r>
-              <a:t>A parte de linguagem natural do desafio.</a:t>
+              <a:t>A pagina "Pergunte em portugues". Oito exemplos, e campo livre.</a:t>
             </a:r>
           </a:p>
         </p:txBody>
@@ -3270,7 +3255,17 @@
           <a:lstStyle/>
           <a:p>
             <a:r>
-              <a:t>A pagina "Pergunte em portugues". Oito exemplos, e campo livre.</a:t>
+              <a:t>Duas perguntas diferentes gerando SQL sobre tabelas diferentes.</a:t>
+            </a:r>
+          </a:p>
+          <a:p>
+            <a:r>
+              <a:t>O tradutor pontua a pergunta contra um vocabulario de radicais com peso, escolhe a intencao de maior pontuacao, extrai as entidades — estado, mes, quantidade — e monta o SQL a partir de um modelo parametrizado.</a:t>
+            </a:r>
+          </a:p>
+          <a:p>
+            <a:r>
+              <a:t>E ele MOSTRA o SQL antes de executar. Isso e deliberado: num painel de saude publica, quem decide precisa poder conferir de onde veio o numero.</a:t>
             </a:r>
           </a:p>
         </p:txBody>
@@ -3340,17 +3335,22 @@
           <a:lstStyle/>
           <a:p>
             <a:r>
-              <a:t>Duas perguntas diferentes gerando SQL sobre tabelas diferentes.</a:t>
-            </a:r>
-          </a:p>
-          <a:p>
-            <a:r>
-              <a:t>O tradutor pontua a pergunta contra um vocabulario de radicais com peso, escolhe a intencao de maior pontuacao, extrai as entidades — estado, mes, quantidade — e monta o SQL a partir de um modelo parametrizado.</a:t>
-            </a:r>
-          </a:p>
-          <a:p>
-            <a:r>
-              <a:t>E ele MOSTRA o SQL antes de executar. Isso e deliberado: num painel de saude publica, quem decide precisa poder conferir de onde veio o numero.</a:t>
+              <a:t>Por que nao e o Select AI nativo.</a:t>
+            </a:r>
+          </a:p>
+          <a:p>
+            <a:r>
+              <a:t>Eu consultei o all_objects procurando o DBMS_CLOUD_AI. Retornou zero. O Select AI so existe no Autonomous Database, e a instancia academica da FIAP e uma 19c Enterprise.</a:t>
+            </a:r>
+          </a:p>
+          <a:p>
+            <a:r>
+              <a:t>Entao implementei o equivalente sobre exatamente os mesmos metadados: os COMMENT ON das tabelas. Eu escrevi esses comentarios em linguagem de negocio de proposito, desde o DDL, sabendo que seriam o dicionario do tradutor.</a:t>
+            </a:r>
+          </a:p>
+          <a:p>
+            <a:r>
+              <a:t>Migrar para o Autonomous nao exige remodelar nada. O script ja esta entregue.</a:t>
             </a:r>
           </a:p>
         </p:txBody>
@@ -3420,22 +3420,7 @@
           <a:lstStyle/>
           <a:p>
             <a:r>
-              <a:t>Por que nao e o Select AI nativo.</a:t>
-            </a:r>
-          </a:p>
-          <a:p>
-            <a:r>
-              <a:t>Eu consultei o all_objects procurando o DBMS_CLOUD_AI. Retornou zero. O Select AI so existe no Autonomous Database, e a instancia academica da FIAP e uma 19c Enterprise.</a:t>
-            </a:r>
-          </a:p>
-          <a:p>
-            <a:r>
-              <a:t>Entao implementei o equivalente sobre exatamente os mesmos metadados: os COMMENT ON das tabelas. Eu escrevi esses comentarios em linguagem de negocio de proposito, desde o DDL, sabendo que seriam o dicionario do tradutor.</a:t>
-            </a:r>
-          </a:p>
-          <a:p>
-            <a:r>
-              <a:t>Migrar para o Autonomous nao exige remodelar nada. O script ja esta entregue.</a:t>
+              <a:t>Fechamento: repositorio, video e conclusoes.</a:t>
             </a:r>
           </a:p>
         </p:txBody>
@@ -3505,7 +3490,12 @@
           <a:lstStyle/>
           <a:p>
             <a:r>
-              <a:t>Fechamento: repositorio, video e conclusoes.</a:t>
+              <a:t>O codigo esta todo publico no GitHub. Notebooks, pipeline de ingestao, DDL, tradutor e painel.</a:t>
+            </a:r>
+          </a:p>
+          <a:p>
+            <a:r>
+              <a:t>E a camada Ouro esta versionada junto — cerca de seis mega de parquet. Isso permite que qualquer pessoa reproduza o painel sem ter acesso ao Oracle da FIAP.</a:t>
             </a:r>
           </a:p>
         </p:txBody>
@@ -3575,12 +3565,7 @@
           <a:lstStyle/>
           <a:p>
             <a:r>
-              <a:t>O codigo esta todo publico no GitHub. Notebooks, pipeline de ingestao, DDL, tradutor e painel.</a:t>
-            </a:r>
-          </a:p>
-          <a:p>
-            <a:r>
-              <a:t>E a camada Ouro esta versionada junto — cerca de seis mega de parquet. Isso permite que qualquer pessoa reproduza o painel sem ter acesso ao Oracle da FIAP.</a:t>
+              <a:t>O video de cinco minutos com a demonstracao ao vivo.</a:t>
             </a:r>
           </a:p>
         </p:txBody>
@@ -3650,7 +3635,17 @@
           <a:lstStyle/>
           <a:p>
             <a:r>
-              <a:t>O video de cinco minutos com a demonstracao ao vivo.</a:t>
+              <a:t>Tres coisas que os dados me ensinaram, e que eu nao sabia quando comecei.</a:t>
+            </a:r>
+          </a:p>
+          <a:p>
+            <a:r>
+              <a:t>A primeira mudou a dimensao temporal do projeto inteiro. A segunda mudou a pergunta que o painel responde. A terceira me fez descartar o modelo mais sofisticado em favor do mais simples.</a:t>
+            </a:r>
+          </a:p>
+          <a:p>
+            <a:r>
+              <a:t>Nenhuma das tres estava no plano da Sprint 1.</a:t>
             </a:r>
           </a:p>
         </p:txBody>
@@ -3720,17 +3715,12 @@
           <a:lstStyle/>
           <a:p>
             <a:r>
-              <a:t>Tres coisas que os dados me ensinaram, e que eu nao sabia quando comecei.</a:t>
-            </a:r>
-          </a:p>
-          <a:p>
-            <a:r>
-              <a:t>A primeira mudou a dimensao temporal do projeto inteiro. A segunda mudou a pergunta que o painel responde. A terceira me fez descartar o modelo mais sofisticado em favor do mais simples.</a:t>
-            </a:r>
-          </a:p>
-          <a:p>
-            <a:r>
-              <a:t>Nenhuma das tres estava no plano da Sprint 1.</a:t>
+              <a:t>E o que este painel NAO pode afirmar.</a:t>
+            </a:r>
+          </a:p>
+          <a:p>
+            <a:r>
+              <a:t>Declarar limite nao enfraquece o trabalho: e o que separa analise de opiniao com grafico. Cada um desses itens eu medi antes de declarar — inclusive o menos de um por cento dos leitos-dia de pacientes internados antes de 2024.</a:t>
             </a:r>
           </a:p>
         </p:txBody>
@@ -3800,12 +3790,12 @@
           <a:lstStyle/>
           <a:p>
             <a:r>
-              <a:t>E o que este painel NAO pode afirmar.</a:t>
-            </a:r>
-          </a:p>
-          <a:p>
-            <a:r>
-              <a:t>Declarar limite nao enfraquece o trabalho: e o que separa analise de opiniao com grafico. Cada um desses itens eu medi antes de declarar — inclusive o menos de um por cento dos leitos-dia de pacientes internados antes de 2024.</a:t>
+              <a:t>Os proximos passos saem direto das limitacoes do slide anterior.</a:t>
+            </a:r>
+          </a:p>
+          <a:p>
+            <a:r>
+              <a:t>Nenhum deles exige refazer o que esta feito: o pipeline ja e parametrizado por estado, e a migracao para o Autonomous e troca de motor, nao de modelo.</a:t>
             </a:r>
           </a:p>
         </p:txBody>
@@ -3875,12 +3865,12 @@
           <a:lstStyle/>
           <a:p>
             <a:r>
-              <a:t>Os proximos passos saem direto das limitacoes do slide anterior.</a:t>
-            </a:r>
-          </a:p>
-          <a:p>
-            <a:r>
-              <a:t>Nenhum deles exige refazer o que esta feito: o pipeline ja e parametrizado por estado, e a migracao para o Autonomous e troca de motor, nao de modelo.</a:t>
+              <a:t>O painel esta no ar e o codigo esta aberto.</a:t>
+            </a:r>
+          </a:p>
+          <a:p>
+            <a:r>
+              <a:t>Obrigado.</a:t>
             </a:r>
           </a:p>
         </p:txBody>
@@ -3950,7 +3940,17 @@
           <a:lstStyle/>
           <a:p>
             <a:r>
-              <a:t>Primeira entrega: o que prometi na Sprint 1 e o que de fato saiu.</a:t>
+              <a:t>Quatro itens entregues como prometido, dois entregues de forma diferente, dois substituidos.</a:t>
+            </a:r>
+          </a:p>
+          <a:p>
+            <a:r>
+              <a:t>Os dois amarelos sao limitacao do ambiente, nao minha: o Select AI exige Autonomous Database e a conta academica nao tem privilegio de criar diretorio. Nos dois casos eu entreguei o script pronto e um substituto funcional.</a:t>
+            </a:r>
+          </a:p>
+          <a:p>
+            <a:r>
+              <a:t>Os dois cinzas sao decisao minha, e eu defendo cada uma na hora certa.</a:t>
             </a:r>
           </a:p>
         </p:txBody>
@@ -4020,17 +4020,12 @@
           <a:lstStyle/>
           <a:p>
             <a:r>
-              <a:t>Quatro itens entregues como prometido, dois entregues de forma diferente, dois substituidos.</a:t>
-            </a:r>
-          </a:p>
-          <a:p>
-            <a:r>
-              <a:t>Os dois amarelos sao limitacao do ambiente, nao minha: o Select AI exige Autonomous Database e a conta academica nao tem privilegio de criar diretorio. Nos dois casos eu entreguei o script pronto e um substituto funcional.</a:t>
-            </a:r>
-          </a:p>
-          <a:p>
-            <a:r>
-              <a:t>Os dois cinzas sao decisao minha, e eu defendo cada uma na hora certa.</a:t>
+              <a:t>Quadro publico no Trello, 44 cartoes.</a:t>
+            </a:r>
+          </a:p>
+          <a:p>
+            <a:r>
+              <a:t>A quinta lista e a que interessa numa apresentacao academica: "nao implementado, com justificativa". Um quadro todo verde esconde as decisoes de escopo, que sao parte do trabalho. Cada cartao dessa lista tem o motivo tecnico e o que foi entregue no lugar.</a:t>
             </a:r>
           </a:p>
         </p:txBody>
@@ -4100,12 +4095,7 @@
           <a:lstStyle/>
           <a:p>
             <a:r>
-              <a:t>Quadro publico no Trello, 44 cartoes.</a:t>
-            </a:r>
-          </a:p>
-          <a:p>
-            <a:r>
-              <a:t>A quinta lista e a que interessa numa apresentacao academica: "nao implementado, com justificativa". Um quadro todo verde esconde as decisoes de escopo, que sao parte do trabalho. Cada cartao dessa lista tem o motivo tecnico e o que foi entregue no lugar.</a:t>
+              <a:t>Segunda entrega: o MVP funcionando.</a:t>
             </a:r>
           </a:p>
         </p:txBody>
@@ -4175,7 +4165,12 @@
           <a:lstStyle/>
           <a:p>
             <a:r>
-              <a:t>Segunda entrega: o MVP funcionando.</a:t>
+              <a:t>Este e o painel, publicado e conectado ao Oracle da FIAP.</a:t>
+            </a:r>
+          </a:p>
+          <a:p>
+            <a:r>
+              <a:t>Cada numero desta tela vem de uma consulta com agregacao empurrada para o banco. Eu nao carrego a tabela e somo no Python: mando SUM e COUNT para o Oracle e trago so o resultado. Isso importa porque a tabela fato tem centenas de milhares de linhas, e trazer tudo para o cliente travava a tela.</a:t>
             </a:r>
           </a:p>
         </p:txBody>
@@ -4245,12 +4240,17 @@
           <a:lstStyle/>
           <a:p>
             <a:r>
-              <a:t>Este e o painel, publicado e conectado ao Oracle da FIAP.</a:t>
-            </a:r>
-          </a:p>
-          <a:p>
-            <a:r>
-              <a:t>Cada numero desta tela vem de uma consulta com agregacao empurrada para o banco. Eu nao carrego a tabela e somo no Python: mando SUM e COUNT para o Oracle e trago so o resultado. Isso importa porque a tabela fato tem centenas de milhares de linhas, e trazer tudo para o cliente travava a tela.</a:t>
+              <a:t>A pergunta e "onde a capacidade foi ultrapassada".</a:t>
+            </a:r>
+          </a:p>
+          <a:p>
+            <a:r>
+              <a:t>Para responder eu precisei cruzar duas fontes que nao se conhecem: as internacoes do SIH e os leitos do CNES. O join e por codigo IBGE de seis digitos do municipio. Somo os leitos SUS de todos os estabelecimentos de cada municipio, somo os dias de permanencia consumidos naquele mes, divido um pelo outro e pelo numero de dias do mes. Isso da a taxa de ocupacao.</a:t>
+            </a:r>
+          </a:p>
+          <a:p>
+            <a:r>
+              <a:t>Repare nos dois numeros lado a lado: media simples e ponderada. A simples trata um municipio de tres leitos igual a Sao Paulo. A distancia entre as barras e o tamanho do erro que eu teria cometido se usasse a media ingenua.</a:t>
             </a:r>
           </a:p>
         </p:txBody>
@@ -7814,7 +7814,7 @@
                 </a:solidFill>
                 <a:latin typeface="Cambria"/>
               </a:rPr>
-              <a:t>9</a:t>
+              <a:t>10</a:t>
             </a:r>
           </a:p>
         </p:txBody>
@@ -8432,7 +8432,7 @@
                 </a:solidFill>
                 <a:latin typeface="Cambria"/>
               </a:rPr>
-              <a:t>10</a:t>
+              <a:t>11</a:t>
             </a:r>
           </a:p>
         </p:txBody>
@@ -8711,7 +8711,7 @@
                 </a:solidFill>
                 <a:latin typeface="Cambria"/>
               </a:rPr>
-              <a:t>11</a:t>
+              <a:t>12</a:t>
             </a:r>
           </a:p>
         </p:txBody>
@@ -8845,7 +8845,7 @@
                 </a:solidFill>
                 <a:latin typeface="Cambria"/>
               </a:rPr>
-              <a:t>12</a:t>
+              <a:t>13</a:t>
             </a:r>
           </a:p>
         </p:txBody>
@@ -9527,7 +9527,7 @@
                 </a:solidFill>
                 <a:latin typeface="Cambria"/>
               </a:rPr>
-              <a:t>13</a:t>
+              <a:t>14</a:t>
             </a:r>
           </a:p>
         </p:txBody>
@@ -9874,7 +9874,7 @@
                 </a:solidFill>
                 <a:latin typeface="Cambria"/>
               </a:rPr>
-              <a:t>14</a:t>
+              <a:t>15</a:t>
             </a:r>
           </a:p>
         </p:txBody>
@@ -10205,7 +10205,7 @@
                 </a:solidFill>
                 <a:latin typeface="Cambria"/>
               </a:rPr>
-              <a:t>15</a:t>
+              <a:t>16</a:t>
             </a:r>
           </a:p>
         </p:txBody>
@@ -10804,7 +10804,7 @@
                 </a:solidFill>
                 <a:latin typeface="Cambria"/>
               </a:rPr>
-              <a:t>16</a:t>
+              <a:t>17</a:t>
             </a:r>
           </a:p>
         </p:txBody>
@@ -11528,7 +11528,7 @@
                 </a:solidFill>
                 <a:latin typeface="Cambria"/>
               </a:rPr>
-              <a:t>17</a:t>
+              <a:t>18</a:t>
             </a:r>
           </a:p>
         </p:txBody>
@@ -11807,7 +11807,7 @@
                 </a:solidFill>
                 <a:latin typeface="Cambria"/>
               </a:rPr>
-              <a:t>18</a:t>
+              <a:t>19</a:t>
             </a:r>
           </a:p>
         </p:txBody>
@@ -12422,7 +12422,7 @@
                 </a:solidFill>
                 <a:latin typeface="Cambria"/>
               </a:rPr>
-              <a:t>1</a:t>
+              <a:t>2</a:t>
             </a:r>
           </a:p>
         </p:txBody>
@@ -12976,7 +12976,7 @@
                 </a:solidFill>
                 <a:latin typeface="Cambria"/>
               </a:rPr>
-              <a:t>19</a:t>
+              <a:t>20</a:t>
             </a:r>
           </a:p>
         </p:txBody>
@@ -13323,7 +13323,7 @@
                 </a:solidFill>
                 <a:latin typeface="Cambria"/>
               </a:rPr>
-              <a:t>20</a:t>
+              <a:t>21</a:t>
             </a:r>
           </a:p>
         </p:txBody>
@@ -13960,7 +13960,7 @@
                 </a:solidFill>
                 <a:latin typeface="Cambria"/>
               </a:rPr>
-              <a:t>21</a:t>
+              <a:t>22</a:t>
             </a:r>
           </a:p>
         </p:txBody>
@@ -14333,7 +14333,7 @@
                 </a:solidFill>
                 <a:latin typeface="Cambria"/>
               </a:rPr>
-              <a:t>22</a:t>
+              <a:t>23</a:t>
             </a:r>
           </a:p>
         </p:txBody>
@@ -15027,7 +15027,7 @@
                 </a:solidFill>
                 <a:latin typeface="Cambria"/>
               </a:rPr>
-              <a:t>23</a:t>
+              <a:t>24</a:t>
             </a:r>
           </a:p>
         </p:txBody>
@@ -15645,7 +15645,7 @@
                 </a:solidFill>
                 <a:latin typeface="Cambria"/>
               </a:rPr>
-              <a:t>24</a:t>
+              <a:t>25</a:t>
             </a:r>
           </a:p>
         </p:txBody>
@@ -16206,7 +16206,7 @@
                 </a:solidFill>
                 <a:latin typeface="Cambria"/>
               </a:rPr>
-              <a:t>25</a:t>
+              <a:t>26</a:t>
             </a:r>
           </a:p>
         </p:txBody>
@@ -16485,7 +16485,7 @@
                 </a:solidFill>
                 <a:latin typeface="Cambria"/>
               </a:rPr>
-              <a:t>26</a:t>
+              <a:t>27</a:t>
             </a:r>
           </a:p>
         </p:txBody>
@@ -16790,7 +16790,7 @@
                 </a:solidFill>
                 <a:latin typeface="Cambria"/>
               </a:rPr>
-              <a:t>27</a:t>
+              <a:t>28</a:t>
             </a:r>
           </a:p>
         </p:txBody>
@@ -17469,7 +17469,7 @@
                 </a:solidFill>
                 <a:latin typeface="Cambria"/>
               </a:rPr>
-              <a:t>28</a:t>
+              <a:t>29</a:t>
             </a:r>
           </a:p>
         </p:txBody>
@@ -18504,7 +18504,7 @@
                 </a:solidFill>
                 <a:latin typeface="Cambria"/>
               </a:rPr>
-              <a:t>2</a:t>
+              <a:t>3</a:t>
             </a:r>
           </a:p>
         </p:txBody>
@@ -19046,7 +19046,7 @@
                 </a:solidFill>
                 <a:latin typeface="Cambria"/>
               </a:rPr>
-              <a:t>29</a:t>
+              <a:t>30</a:t>
             </a:r>
           </a:p>
         </p:txBody>
@@ -19351,7 +19351,7 @@
                 </a:solidFill>
                 <a:latin typeface="Cambria"/>
               </a:rPr>
-              <a:t>30</a:t>
+              <a:t>31</a:t>
             </a:r>
           </a:p>
         </p:txBody>
@@ -19988,7 +19988,7 @@
                 </a:solidFill>
                 <a:latin typeface="Cambria"/>
               </a:rPr>
-              <a:t>31</a:t>
+              <a:t>32</a:t>
             </a:r>
           </a:p>
         </p:txBody>
@@ -20267,7 +20267,7 @@
                 </a:solidFill>
                 <a:latin typeface="Cambria"/>
               </a:rPr>
-              <a:t>32</a:t>
+              <a:t>33</a:t>
             </a:r>
           </a:p>
         </p:txBody>
@@ -20923,7 +20923,7 @@
                 </a:solidFill>
                 <a:latin typeface="Cambria"/>
               </a:rPr>
-              <a:t>33</a:t>
+              <a:t>34</a:t>
             </a:r>
           </a:p>
         </p:txBody>
@@ -21526,7 +21526,7 @@
                 </a:solidFill>
                 <a:latin typeface="Cambria"/>
               </a:rPr>
-              <a:t>34</a:t>
+              <a:t>35</a:t>
             </a:r>
           </a:p>
         </p:txBody>
@@ -22091,7 +22091,7 @@
                 </a:solidFill>
                 <a:latin typeface="Cambria"/>
               </a:rPr>
-              <a:t>35</a:t>
+              <a:t>36</a:t>
             </a:r>
           </a:p>
         </p:txBody>
@@ -22618,7 +22618,7 @@
                 </a:solidFill>
                 <a:latin typeface="Cambria"/>
               </a:rPr>
-              <a:t>36</a:t>
+              <a:t>37</a:t>
             </a:r>
           </a:p>
         </p:txBody>
@@ -23210,7 +23210,7 @@
                 </a:solidFill>
                 <a:latin typeface="Cambria"/>
               </a:rPr>
-              <a:t>37</a:t>
+              <a:t>38</a:t>
             </a:r>
           </a:p>
         </p:txBody>
@@ -23489,7 +23489,7 @@
                 </a:solidFill>
                 <a:latin typeface="Cambria"/>
               </a:rPr>
-              <a:t>38</a:t>
+              <a:t>39</a:t>
             </a:r>
           </a:p>
         </p:txBody>
@@ -23768,7 +23768,7 @@
                 </a:solidFill>
                 <a:latin typeface="Cambria"/>
               </a:rPr>
-              <a:t>3</a:t>
+              <a:t>4</a:t>
             </a:r>
           </a:p>
         </p:txBody>
@@ -24073,7 +24073,7 @@
                 </a:solidFill>
                 <a:latin typeface="Cambria"/>
               </a:rPr>
-              <a:t>39</a:t>
+              <a:t>40</a:t>
             </a:r>
           </a:p>
         </p:txBody>
@@ -24714,7 +24714,7 @@
                 </a:solidFill>
                 <a:latin typeface="Cambria"/>
               </a:rPr>
-              <a:t>40</a:t>
+              <a:t>41</a:t>
             </a:r>
           </a:p>
         </p:txBody>
@@ -25393,7 +25393,7 @@
                 </a:solidFill>
                 <a:latin typeface="Cambria"/>
               </a:rPr>
-              <a:t>41</a:t>
+              <a:t>42</a:t>
             </a:r>
           </a:p>
         </p:txBody>
@@ -25672,7 +25672,7 @@
                 </a:solidFill>
                 <a:latin typeface="Cambria"/>
               </a:rPr>
-              <a:t>42</a:t>
+              <a:t>43</a:t>
             </a:r>
           </a:p>
         </p:txBody>
@@ -26328,7 +26328,7 @@
                 </a:solidFill>
                 <a:latin typeface="Cambria"/>
               </a:rPr>
-              <a:t>43</a:t>
+              <a:t>44</a:t>
             </a:r>
           </a:p>
         </p:txBody>
@@ -26745,7 +26745,7 @@
                 </a:solidFill>
                 <a:latin typeface="Cambria"/>
               </a:rPr>
-              <a:t>44</a:t>
+              <a:t>45</a:t>
             </a:r>
           </a:p>
         </p:txBody>
@@ -27234,7 +27234,7 @@
                 </a:solidFill>
                 <a:latin typeface="Cambria"/>
               </a:rPr>
-              <a:t>45</a:t>
+              <a:t>46</a:t>
             </a:r>
           </a:p>
         </p:txBody>
@@ -27727,7 +27727,7 @@
                 </a:solidFill>
                 <a:latin typeface="Cambria"/>
               </a:rPr>
-              <a:t>46</a:t>
+              <a:t>47</a:t>
             </a:r>
           </a:p>
         </p:txBody>
@@ -28197,7 +28197,7 @@
                 </a:solidFill>
                 <a:latin typeface="Cambria"/>
               </a:rPr>
-              <a:t>47</a:t>
+              <a:t>48</a:t>
             </a:r>
           </a:p>
         </p:txBody>
@@ -28515,7 +28515,7 @@
                 </a:solidFill>
                 <a:latin typeface="Cambria"/>
               </a:rPr>
-              <a:t>48</a:t>
+              <a:t>49</a:t>
             </a:r>
           </a:p>
         </p:txBody>
@@ -29294,7 +29294,7 @@
                 </a:solidFill>
                 <a:latin typeface="Cambria"/>
               </a:rPr>
-              <a:t>4</a:t>
+              <a:t>5</a:t>
             </a:r>
           </a:p>
         </p:txBody>
@@ -29931,7 +29931,7 @@
                 </a:solidFill>
                 <a:latin typeface="Cambria"/>
               </a:rPr>
-              <a:t>5</a:t>
+              <a:t>6</a:t>
             </a:r>
           </a:p>
         </p:txBody>
@@ -30210,7 +30210,7 @@
                 </a:solidFill>
                 <a:latin typeface="Cambria"/>
               </a:rPr>
-              <a:t>6</a:t>
+              <a:t>7</a:t>
             </a:r>
           </a:p>
         </p:txBody>
@@ -30557,7 +30557,7 @@
                 </a:solidFill>
                 <a:latin typeface="Cambria"/>
               </a:rPr>
-              <a:t>7</a:t>
+              <a:t>8</a:t>
             </a:r>
           </a:p>
         </p:txBody>
@@ -31080,7 +31080,7 @@
                 </a:solidFill>
                 <a:latin typeface="Cambria"/>
               </a:rPr>
-              <a:t>8</a:t>
+              <a:t>9</a:t>
             </a:r>
           </a:p>
         </p:txBody>

</xml_diff>